<commit_message>
Replace 3-year financial figures with x placeholders
Keep the model structure and year columns, but withhold company
projections so the outlook reads as a professional discussion
framework rather than a completed forecast.

Co-authored-by: anthonyleedu <anthonyleedu@users.noreply.github.com>
</commit_message>
<xml_diff>
--- a/51Careers_Addition.pptx
+++ b/51Careers_Addition.pptx
@@ -24094,7 +24094,7 @@
                 </a:solidFill>
                 <a:latin typeface="Segoe UI"/>
               </a:rPr>
-              <a:t>THREE-YEAR FINANCIAL MODEL</a:t>
+              <a:t>FINANCIAL OUTLOOK</a:t>
             </a:r>
           </a:p>
         </p:txBody>
@@ -24127,1188 +24127,84 @@
                 </a:solidFill>
                 <a:latin typeface="Georgia"/>
               </a:rPr>
-              <a:t>Illustrative path from free AI Resume to a paid multi-stream platform</a:t>
-            </a:r>
-          </a:p>
-        </p:txBody>
-      </p:sp>
-      <p:graphicFrame>
-        <p:nvGraphicFramePr>
-          <p:cNvPr id="4" name="Table 3"/>
-          <p:cNvGraphicFramePr>
-            <a:graphicFrameLocks noGrp="1"/>
-          </p:cNvGraphicFramePr>
-          <p:nvPr/>
-        </p:nvGraphicFramePr>
-        <p:xfrm>
-          <a:off x="502920" y="1078992"/>
-          <a:ext cx="11173968" cy="4892040"/>
-        </p:xfrm>
-        <a:graphic>
-          <a:graphicData uri="http://schemas.openxmlformats.org/drawingml/2006/table">
-            <a:tbl>
-              <a:tblPr firstRow="1" bandRow="1">
-                <a:tableStyleId>{5C22544A-7EE6-4342-B048-85BDC9FD1C3A}</a:tableStyleId>
-              </a:tblPr>
-              <a:tblGrid>
-                <a:gridCol w="3246120"/>
-                <a:gridCol w="2642616"/>
-                <a:gridCol w="2642616"/>
-                <a:gridCol w="2642616"/>
-              </a:tblGrid>
-              <a:tr h="407670">
-                <a:tc>
-                  <a:txBody>
-                    <a:bodyPr wrap="square"/>
-                    <a:lstStyle/>
-                    <a:p>
-                      <a:pPr algn="l"/>
-                    </a:p>
-                  </a:txBody>
-                  <a:tcPr anchor="ctr">
-                    <a:solidFill>
-                      <a:srgbClr val="0A6B63"/>
-                    </a:solidFill>
-                  </a:tcPr>
-                </a:tc>
-                <a:tc>
-                  <a:txBody>
-                    <a:bodyPr wrap="square"/>
-                    <a:lstStyle/>
-                    <a:p>
-                      <a:pPr algn="ctr"/>
-                      <a:r>
-                        <a:rPr sz="1200" b="1" i="0">
-                          <a:solidFill>
-                            <a:srgbClr val="FFFFFF"/>
-                          </a:solidFill>
-                          <a:latin typeface="Segoe UI"/>
-                        </a:rPr>
-                        <a:t>Year 1</a:t>
-                      </a:r>
-                    </a:p>
-                  </a:txBody>
-                  <a:tcPr anchor="ctr">
-                    <a:solidFill>
-                      <a:srgbClr val="0A6B63"/>
-                    </a:solidFill>
-                  </a:tcPr>
-                </a:tc>
-                <a:tc>
-                  <a:txBody>
-                    <a:bodyPr wrap="square"/>
-                    <a:lstStyle/>
-                    <a:p>
-                      <a:pPr algn="ctr"/>
-                      <a:r>
-                        <a:rPr sz="1200" b="1" i="0">
-                          <a:solidFill>
-                            <a:srgbClr val="FFFFFF"/>
-                          </a:solidFill>
-                          <a:latin typeface="Segoe UI"/>
-                        </a:rPr>
-                        <a:t>Year 2</a:t>
-                      </a:r>
-                    </a:p>
-                  </a:txBody>
-                  <a:tcPr anchor="ctr">
-                    <a:solidFill>
-                      <a:srgbClr val="0A6B63"/>
-                    </a:solidFill>
-                  </a:tcPr>
-                </a:tc>
-                <a:tc>
-                  <a:txBody>
-                    <a:bodyPr wrap="square"/>
-                    <a:lstStyle/>
-                    <a:p>
-                      <a:pPr algn="ctr"/>
-                      <a:r>
-                        <a:rPr sz="1200" b="1" i="0">
-                          <a:solidFill>
-                            <a:srgbClr val="FFFFFF"/>
-                          </a:solidFill>
-                          <a:latin typeface="Segoe UI"/>
-                        </a:rPr>
-                        <a:t>Year 3</a:t>
-                      </a:r>
-                    </a:p>
-                  </a:txBody>
-                  <a:tcPr anchor="ctr">
-                    <a:solidFill>
-                      <a:srgbClr val="0A6B63"/>
-                    </a:solidFill>
-                  </a:tcPr>
-                </a:tc>
-              </a:tr>
-              <a:tr h="407670">
-                <a:tc>
-                  <a:txBody>
-                    <a:bodyPr wrap="square"/>
-                    <a:lstStyle/>
-                    <a:p>
-                      <a:pPr algn="l"/>
-                      <a:r>
-                        <a:rPr sz="1100" b="1" i="0">
-                          <a:solidFill>
-                            <a:srgbClr val="0B1F33"/>
-                          </a:solidFill>
-                          <a:latin typeface="Segoe UI"/>
-                        </a:rPr>
-                        <a:t>Registered users</a:t>
-                      </a:r>
-                    </a:p>
-                  </a:txBody>
-                  <a:tcPr anchor="ctr">
-                    <a:solidFill>
-                      <a:srgbClr val="FFFFFF"/>
-                    </a:solidFill>
-                  </a:tcPr>
-                </a:tc>
-                <a:tc>
-                  <a:txBody>
-                    <a:bodyPr wrap="square"/>
-                    <a:lstStyle/>
-                    <a:p>
-                      <a:pPr algn="ctr"/>
-                      <a:r>
-                        <a:rPr sz="1100" b="0" i="0">
-                          <a:solidFill>
-                            <a:srgbClr val="0B1F33"/>
-                          </a:solidFill>
-                          <a:latin typeface="Segoe UI"/>
-                        </a:rPr>
-                        <a:t>80,000</a:t>
-                      </a:r>
-                    </a:p>
-                  </a:txBody>
-                  <a:tcPr anchor="ctr">
-                    <a:solidFill>
-                      <a:srgbClr val="FFFFFF"/>
-                    </a:solidFill>
-                  </a:tcPr>
-                </a:tc>
-                <a:tc>
-                  <a:txBody>
-                    <a:bodyPr wrap="square"/>
-                    <a:lstStyle/>
-                    <a:p>
-                      <a:pPr algn="ctr"/>
-                      <a:r>
-                        <a:rPr sz="1100" b="0" i="0">
-                          <a:solidFill>
-                            <a:srgbClr val="0B1F33"/>
-                          </a:solidFill>
-                          <a:latin typeface="Segoe UI"/>
-                        </a:rPr>
-                        <a:t>400,000</a:t>
-                      </a:r>
-                    </a:p>
-                  </a:txBody>
-                  <a:tcPr anchor="ctr">
-                    <a:solidFill>
-                      <a:srgbClr val="FFFFFF"/>
-                    </a:solidFill>
-                  </a:tcPr>
-                </a:tc>
-                <a:tc>
-                  <a:txBody>
-                    <a:bodyPr wrap="square"/>
-                    <a:lstStyle/>
-                    <a:p>
-                      <a:pPr algn="ctr"/>
-                      <a:r>
-                        <a:rPr sz="1100" b="0" i="0">
-                          <a:solidFill>
-                            <a:srgbClr val="0B1F33"/>
-                          </a:solidFill>
-                          <a:latin typeface="Segoe UI"/>
-                        </a:rPr>
-                        <a:t>1,200,000</a:t>
-                      </a:r>
-                    </a:p>
-                  </a:txBody>
-                  <a:tcPr anchor="ctr">
-                    <a:solidFill>
-                      <a:srgbClr val="FFFFFF"/>
-                    </a:solidFill>
-                  </a:tcPr>
-                </a:tc>
-              </a:tr>
-              <a:tr h="407670">
-                <a:tc>
-                  <a:txBody>
-                    <a:bodyPr wrap="square"/>
-                    <a:lstStyle/>
-                    <a:p>
-                      <a:pPr algn="l"/>
-                      <a:r>
-                        <a:rPr sz="1100" b="1" i="0">
-                          <a:solidFill>
-                            <a:srgbClr val="0B1F33"/>
-                          </a:solidFill>
-                          <a:latin typeface="Segoe UI"/>
-                        </a:rPr>
-                        <a:t>MAU</a:t>
-                      </a:r>
-                    </a:p>
-                  </a:txBody>
-                  <a:tcPr anchor="ctr">
-                    <a:solidFill>
-                      <a:srgbClr val="EEF3F8"/>
-                    </a:solidFill>
-                  </a:tcPr>
-                </a:tc>
-                <a:tc>
-                  <a:txBody>
-                    <a:bodyPr wrap="square"/>
-                    <a:lstStyle/>
-                    <a:p>
-                      <a:pPr algn="ctr"/>
-                      <a:r>
-                        <a:rPr sz="1100" b="0" i="0">
-                          <a:solidFill>
-                            <a:srgbClr val="0B1F33"/>
-                          </a:solidFill>
-                          <a:latin typeface="Segoe UI"/>
-                        </a:rPr>
-                        <a:t>20,000</a:t>
-                      </a:r>
-                    </a:p>
-                  </a:txBody>
-                  <a:tcPr anchor="ctr">
-                    <a:solidFill>
-                      <a:srgbClr val="EEF3F8"/>
-                    </a:solidFill>
-                  </a:tcPr>
-                </a:tc>
-                <a:tc>
-                  <a:txBody>
-                    <a:bodyPr wrap="square"/>
-                    <a:lstStyle/>
-                    <a:p>
-                      <a:pPr algn="ctr"/>
-                      <a:r>
-                        <a:rPr sz="1100" b="0" i="0">
-                          <a:solidFill>
-                            <a:srgbClr val="0B1F33"/>
-                          </a:solidFill>
-                          <a:latin typeface="Segoe UI"/>
-                        </a:rPr>
-                        <a:t>80,000</a:t>
-                      </a:r>
-                    </a:p>
-                  </a:txBody>
-                  <a:tcPr anchor="ctr">
-                    <a:solidFill>
-                      <a:srgbClr val="EEF3F8"/>
-                    </a:solidFill>
-                  </a:tcPr>
-                </a:tc>
-                <a:tc>
-                  <a:txBody>
-                    <a:bodyPr wrap="square"/>
-                    <a:lstStyle/>
-                    <a:p>
-                      <a:pPr algn="ctr"/>
-                      <a:r>
-                        <a:rPr sz="1100" b="0" i="0">
-                          <a:solidFill>
-                            <a:srgbClr val="0B1F33"/>
-                          </a:solidFill>
-                          <a:latin typeface="Segoe UI"/>
-                        </a:rPr>
-                        <a:t>220,000</a:t>
-                      </a:r>
-                    </a:p>
-                  </a:txBody>
-                  <a:tcPr anchor="ctr">
-                    <a:solidFill>
-                      <a:srgbClr val="EEF3F8"/>
-                    </a:solidFill>
-                  </a:tcPr>
-                </a:tc>
-              </a:tr>
-              <a:tr h="407670">
-                <a:tc>
-                  <a:txBody>
-                    <a:bodyPr wrap="square"/>
-                    <a:lstStyle/>
-                    <a:p>
-                      <a:pPr algn="l"/>
-                      <a:r>
-                        <a:rPr sz="1100" b="1" i="0">
-                          <a:solidFill>
-                            <a:srgbClr val="0B1F33"/>
-                          </a:solidFill>
-                          <a:latin typeface="Segoe UI"/>
-                        </a:rPr>
-                        <a:t>Paid users</a:t>
-                      </a:r>
-                    </a:p>
-                  </a:txBody>
-                  <a:tcPr anchor="ctr">
-                    <a:solidFill>
-                      <a:srgbClr val="FFFFFF"/>
-                    </a:solidFill>
-                  </a:tcPr>
-                </a:tc>
-                <a:tc>
-                  <a:txBody>
-                    <a:bodyPr wrap="square"/>
-                    <a:lstStyle/>
-                    <a:p>
-                      <a:pPr algn="ctr"/>
-                      <a:r>
-                        <a:rPr sz="1100" b="0" i="0">
-                          <a:solidFill>
-                            <a:srgbClr val="0B1F33"/>
-                          </a:solidFill>
-                          <a:latin typeface="Segoe UI"/>
-                        </a:rPr>
-                        <a:t>1,600</a:t>
-                      </a:r>
-                    </a:p>
-                  </a:txBody>
-                  <a:tcPr anchor="ctr">
-                    <a:solidFill>
-                      <a:srgbClr val="FFFFFF"/>
-                    </a:solidFill>
-                  </a:tcPr>
-                </a:tc>
-                <a:tc>
-                  <a:txBody>
-                    <a:bodyPr wrap="square"/>
-                    <a:lstStyle/>
-                    <a:p>
-                      <a:pPr algn="ctr"/>
-                      <a:r>
-                        <a:rPr sz="1100" b="0" i="0">
-                          <a:solidFill>
-                            <a:srgbClr val="0B1F33"/>
-                          </a:solidFill>
-                          <a:latin typeface="Segoe UI"/>
-                        </a:rPr>
-                        <a:t>16,000</a:t>
-                      </a:r>
-                    </a:p>
-                  </a:txBody>
-                  <a:tcPr anchor="ctr">
-                    <a:solidFill>
-                      <a:srgbClr val="FFFFFF"/>
-                    </a:solidFill>
-                  </a:tcPr>
-                </a:tc>
-                <a:tc>
-                  <a:txBody>
-                    <a:bodyPr wrap="square"/>
-                    <a:lstStyle/>
-                    <a:p>
-                      <a:pPr algn="ctr"/>
-                      <a:r>
-                        <a:rPr sz="1100" b="0" i="0">
-                          <a:solidFill>
-                            <a:srgbClr val="0B1F33"/>
-                          </a:solidFill>
-                          <a:latin typeface="Segoe UI"/>
-                        </a:rPr>
-                        <a:t>60,000</a:t>
-                      </a:r>
-                    </a:p>
-                  </a:txBody>
-                  <a:tcPr anchor="ctr">
-                    <a:solidFill>
-                      <a:srgbClr val="FFFFFF"/>
-                    </a:solidFill>
-                  </a:tcPr>
-                </a:tc>
-              </a:tr>
-              <a:tr h="407670">
-                <a:tc>
-                  <a:txBody>
-                    <a:bodyPr wrap="square"/>
-                    <a:lstStyle/>
-                    <a:p>
-                      <a:pPr algn="l"/>
-                      <a:r>
-                        <a:rPr sz="1100" b="1" i="0">
-                          <a:solidFill>
-                            <a:srgbClr val="0B1F33"/>
-                          </a:solidFill>
-                          <a:latin typeface="Segoe UI"/>
-                        </a:rPr>
-                        <a:t>AI revenue</a:t>
-                      </a:r>
-                    </a:p>
-                  </a:txBody>
-                  <a:tcPr anchor="ctr">
-                    <a:solidFill>
-                      <a:srgbClr val="EEF3F8"/>
-                    </a:solidFill>
-                  </a:tcPr>
-                </a:tc>
-                <a:tc>
-                  <a:txBody>
-                    <a:bodyPr wrap="square"/>
-                    <a:lstStyle/>
-                    <a:p>
-                      <a:pPr algn="ctr"/>
-                      <a:r>
-                        <a:rPr sz="1100" b="0" i="0">
-                          <a:solidFill>
-                            <a:srgbClr val="0B1F33"/>
-                          </a:solidFill>
-                          <a:latin typeface="Segoe UI"/>
-                        </a:rPr>
-                        <a:t>RMB 1.6M</a:t>
-                      </a:r>
-                    </a:p>
-                  </a:txBody>
-                  <a:tcPr anchor="ctr">
-                    <a:solidFill>
-                      <a:srgbClr val="EEF3F8"/>
-                    </a:solidFill>
-                  </a:tcPr>
-                </a:tc>
-                <a:tc>
-                  <a:txBody>
-                    <a:bodyPr wrap="square"/>
-                    <a:lstStyle/>
-                    <a:p>
-                      <a:pPr algn="ctr"/>
-                      <a:r>
-                        <a:rPr sz="1100" b="0" i="0">
-                          <a:solidFill>
-                            <a:srgbClr val="0B1F33"/>
-                          </a:solidFill>
-                          <a:latin typeface="Segoe UI"/>
-                        </a:rPr>
-                        <a:t>RMB 12.8M</a:t>
-                      </a:r>
-                    </a:p>
-                  </a:txBody>
-                  <a:tcPr anchor="ctr">
-                    <a:solidFill>
-                      <a:srgbClr val="EEF3F8"/>
-                    </a:solidFill>
-                  </a:tcPr>
-                </a:tc>
-                <a:tc>
-                  <a:txBody>
-                    <a:bodyPr wrap="square"/>
-                    <a:lstStyle/>
-                    <a:p>
-                      <a:pPr algn="ctr"/>
-                      <a:r>
-                        <a:rPr sz="1100" b="0" i="0">
-                          <a:solidFill>
-                            <a:srgbClr val="0B1F33"/>
-                          </a:solidFill>
-                          <a:latin typeface="Segoe UI"/>
-                        </a:rPr>
-                        <a:t>RMB 42.0M</a:t>
-                      </a:r>
-                    </a:p>
-                  </a:txBody>
-                  <a:tcPr anchor="ctr">
-                    <a:solidFill>
-                      <a:srgbClr val="EEF3F8"/>
-                    </a:solidFill>
-                  </a:tcPr>
-                </a:tc>
-              </a:tr>
-              <a:tr h="407670">
-                <a:tc>
-                  <a:txBody>
-                    <a:bodyPr wrap="square"/>
-                    <a:lstStyle/>
-                    <a:p>
-                      <a:pPr algn="l"/>
-                      <a:r>
-                        <a:rPr sz="1100" b="1" i="0">
-                          <a:solidFill>
-                            <a:srgbClr val="0B1F33"/>
-                          </a:solidFill>
-                          <a:latin typeface="Segoe UI"/>
-                        </a:rPr>
-                        <a:t>Career services</a:t>
-                      </a:r>
-                    </a:p>
-                  </a:txBody>
-                  <a:tcPr anchor="ctr">
-                    <a:solidFill>
-                      <a:srgbClr val="FFFFFF"/>
-                    </a:solidFill>
-                  </a:tcPr>
-                </a:tc>
-                <a:tc>
-                  <a:txBody>
-                    <a:bodyPr wrap="square"/>
-                    <a:lstStyle/>
-                    <a:p>
-                      <a:pPr algn="ctr"/>
-                      <a:r>
-                        <a:rPr sz="1100" b="0" i="0">
-                          <a:solidFill>
-                            <a:srgbClr val="0B1F33"/>
-                          </a:solidFill>
-                          <a:latin typeface="Segoe UI"/>
-                        </a:rPr>
-                        <a:t>RMB 4.0M</a:t>
-                      </a:r>
-                    </a:p>
-                  </a:txBody>
-                  <a:tcPr anchor="ctr">
-                    <a:solidFill>
-                      <a:srgbClr val="FFFFFF"/>
-                    </a:solidFill>
-                  </a:tcPr>
-                </a:tc>
-                <a:tc>
-                  <a:txBody>
-                    <a:bodyPr wrap="square"/>
-                    <a:lstStyle/>
-                    <a:p>
-                      <a:pPr algn="ctr"/>
-                      <a:r>
-                        <a:rPr sz="1100" b="0" i="0">
-                          <a:solidFill>
-                            <a:srgbClr val="0B1F33"/>
-                          </a:solidFill>
-                          <a:latin typeface="Segoe UI"/>
-                        </a:rPr>
-                        <a:t>RMB 6.5M</a:t>
-                      </a:r>
-                    </a:p>
-                  </a:txBody>
-                  <a:tcPr anchor="ctr">
-                    <a:solidFill>
-                      <a:srgbClr val="FFFFFF"/>
-                    </a:solidFill>
-                  </a:tcPr>
-                </a:tc>
-                <a:tc>
-                  <a:txBody>
-                    <a:bodyPr wrap="square"/>
-                    <a:lstStyle/>
-                    <a:p>
-                      <a:pPr algn="ctr"/>
-                      <a:r>
-                        <a:rPr sz="1100" b="0" i="0">
-                          <a:solidFill>
-                            <a:srgbClr val="0B1F33"/>
-                          </a:solidFill>
-                          <a:latin typeface="Segoe UI"/>
-                        </a:rPr>
-                        <a:t>RMB 9.0M</a:t>
-                      </a:r>
-                    </a:p>
-                  </a:txBody>
-                  <a:tcPr anchor="ctr">
-                    <a:solidFill>
-                      <a:srgbClr val="FFFFFF"/>
-                    </a:solidFill>
-                  </a:tcPr>
-                </a:tc>
-              </a:tr>
-              <a:tr h="407670">
-                <a:tc>
-                  <a:txBody>
-                    <a:bodyPr wrap="square"/>
-                    <a:lstStyle/>
-                    <a:p>
-                      <a:pPr algn="l"/>
-                      <a:r>
-                        <a:rPr sz="1100" b="1" i="0">
-                          <a:solidFill>
-                            <a:srgbClr val="0B1F33"/>
-                          </a:solidFill>
-                          <a:latin typeface="Segoe UI"/>
-                        </a:rPr>
-                        <a:t>Commission revenue</a:t>
-                      </a:r>
-                    </a:p>
-                  </a:txBody>
-                  <a:tcPr anchor="ctr">
-                    <a:solidFill>
-                      <a:srgbClr val="EEF3F8"/>
-                    </a:solidFill>
-                  </a:tcPr>
-                </a:tc>
-                <a:tc>
-                  <a:txBody>
-                    <a:bodyPr wrap="square"/>
-                    <a:lstStyle/>
-                    <a:p>
-                      <a:pPr algn="ctr"/>
-                      <a:r>
-                        <a:rPr sz="1100" b="0" i="0">
-                          <a:solidFill>
-                            <a:srgbClr val="0B1F33"/>
-                          </a:solidFill>
-                          <a:latin typeface="Segoe UI"/>
-                        </a:rPr>
-                        <a:t>RMB 0.2M</a:t>
-                      </a:r>
-                    </a:p>
-                  </a:txBody>
-                  <a:tcPr anchor="ctr">
-                    <a:solidFill>
-                      <a:srgbClr val="EEF3F8"/>
-                    </a:solidFill>
-                  </a:tcPr>
-                </a:tc>
-                <a:tc>
-                  <a:txBody>
-                    <a:bodyPr wrap="square"/>
-                    <a:lstStyle/>
-                    <a:p>
-                      <a:pPr algn="ctr"/>
-                      <a:r>
-                        <a:rPr sz="1100" b="0" i="0">
-                          <a:solidFill>
-                            <a:srgbClr val="0B1F33"/>
-                          </a:solidFill>
-                          <a:latin typeface="Segoe UI"/>
-                        </a:rPr>
-                        <a:t>RMB 2.4M</a:t>
-                      </a:r>
-                    </a:p>
-                  </a:txBody>
-                  <a:tcPr anchor="ctr">
-                    <a:solidFill>
-                      <a:srgbClr val="EEF3F8"/>
-                    </a:solidFill>
-                  </a:tcPr>
-                </a:tc>
-                <a:tc>
-                  <a:txBody>
-                    <a:bodyPr wrap="square"/>
-                    <a:lstStyle/>
-                    <a:p>
-                      <a:pPr algn="ctr"/>
-                      <a:r>
-                        <a:rPr sz="1100" b="0" i="0">
-                          <a:solidFill>
-                            <a:srgbClr val="0B1F33"/>
-                          </a:solidFill>
-                          <a:latin typeface="Segoe UI"/>
-                        </a:rPr>
-                        <a:t>RMB 8.5M</a:t>
-                      </a:r>
-                    </a:p>
-                  </a:txBody>
-                  <a:tcPr anchor="ctr">
-                    <a:solidFill>
-                      <a:srgbClr val="EEF3F8"/>
-                    </a:solidFill>
-                  </a:tcPr>
-                </a:tc>
-              </a:tr>
-              <a:tr h="407670">
-                <a:tc>
-                  <a:txBody>
-                    <a:bodyPr wrap="square"/>
-                    <a:lstStyle/>
-                    <a:p>
-                      <a:pPr algn="l"/>
-                      <a:r>
-                        <a:rPr sz="1100" b="1" i="0">
-                          <a:solidFill>
-                            <a:srgbClr val="0B1F33"/>
-                          </a:solidFill>
-                          <a:latin typeface="Segoe UI"/>
-                        </a:rPr>
-                        <a:t>Advertising</a:t>
-                      </a:r>
-                    </a:p>
-                  </a:txBody>
-                  <a:tcPr anchor="ctr">
-                    <a:solidFill>
-                      <a:srgbClr val="FFFFFF"/>
-                    </a:solidFill>
-                  </a:tcPr>
-                </a:tc>
-                <a:tc>
-                  <a:txBody>
-                    <a:bodyPr wrap="square"/>
-                    <a:lstStyle/>
-                    <a:p>
-                      <a:pPr algn="ctr"/>
-                      <a:r>
-                        <a:rPr sz="1100" b="0" i="0">
-                          <a:solidFill>
-                            <a:srgbClr val="0B1F33"/>
-                          </a:solidFill>
-                          <a:latin typeface="Segoe UI"/>
-                        </a:rPr>
-                        <a:t>—</a:t>
-                      </a:r>
-                    </a:p>
-                  </a:txBody>
-                  <a:tcPr anchor="ctr">
-                    <a:solidFill>
-                      <a:srgbClr val="FFFFFF"/>
-                    </a:solidFill>
-                  </a:tcPr>
-                </a:tc>
-                <a:tc>
-                  <a:txBody>
-                    <a:bodyPr wrap="square"/>
-                    <a:lstStyle/>
-                    <a:p>
-                      <a:pPr algn="ctr"/>
-                      <a:r>
-                        <a:rPr sz="1100" b="0" i="0">
-                          <a:solidFill>
-                            <a:srgbClr val="0B1F33"/>
-                          </a:solidFill>
-                          <a:latin typeface="Segoe UI"/>
-                        </a:rPr>
-                        <a:t>RMB 1.2M</a:t>
-                      </a:r>
-                    </a:p>
-                  </a:txBody>
-                  <a:tcPr anchor="ctr">
-                    <a:solidFill>
-                      <a:srgbClr val="FFFFFF"/>
-                    </a:solidFill>
-                  </a:tcPr>
-                </a:tc>
-                <a:tc>
-                  <a:txBody>
-                    <a:bodyPr wrap="square"/>
-                    <a:lstStyle/>
-                    <a:p>
-                      <a:pPr algn="ctr"/>
-                      <a:r>
-                        <a:rPr sz="1100" b="0" i="0">
-                          <a:solidFill>
-                            <a:srgbClr val="0B1F33"/>
-                          </a:solidFill>
-                          <a:latin typeface="Segoe UI"/>
-                        </a:rPr>
-                        <a:t>RMB 5.0M</a:t>
-                      </a:r>
-                    </a:p>
-                  </a:txBody>
-                  <a:tcPr anchor="ctr">
-                    <a:solidFill>
-                      <a:srgbClr val="FFFFFF"/>
-                    </a:solidFill>
-                  </a:tcPr>
-                </a:tc>
-              </a:tr>
-              <a:tr h="407670">
-                <a:tc>
-                  <a:txBody>
-                    <a:bodyPr wrap="square"/>
-                    <a:lstStyle/>
-                    <a:p>
-                      <a:pPr algn="l"/>
-                      <a:r>
-                        <a:rPr sz="1100" b="1" i="0">
-                          <a:solidFill>
-                            <a:srgbClr val="0B1F33"/>
-                          </a:solidFill>
-                          <a:latin typeface="Segoe UI"/>
-                        </a:rPr>
-                        <a:t>B2B revenue</a:t>
-                      </a:r>
-                    </a:p>
-                  </a:txBody>
-                  <a:tcPr anchor="ctr">
-                    <a:solidFill>
-                      <a:srgbClr val="EEF3F8"/>
-                    </a:solidFill>
-                  </a:tcPr>
-                </a:tc>
-                <a:tc>
-                  <a:txBody>
-                    <a:bodyPr wrap="square"/>
-                    <a:lstStyle/>
-                    <a:p>
-                      <a:pPr algn="ctr"/>
-                      <a:r>
-                        <a:rPr sz="1100" b="0" i="0">
-                          <a:solidFill>
-                            <a:srgbClr val="0B1F33"/>
-                          </a:solidFill>
-                          <a:latin typeface="Segoe UI"/>
-                        </a:rPr>
-                        <a:t>RMB 0.4M</a:t>
-                      </a:r>
-                    </a:p>
-                  </a:txBody>
-                  <a:tcPr anchor="ctr">
-                    <a:solidFill>
-                      <a:srgbClr val="EEF3F8"/>
-                    </a:solidFill>
-                  </a:tcPr>
-                </a:tc>
-                <a:tc>
-                  <a:txBody>
-                    <a:bodyPr wrap="square"/>
-                    <a:lstStyle/>
-                    <a:p>
-                      <a:pPr algn="ctr"/>
-                      <a:r>
-                        <a:rPr sz="1100" b="0" i="0">
-                          <a:solidFill>
-                            <a:srgbClr val="0B1F33"/>
-                          </a:solidFill>
-                          <a:latin typeface="Segoe UI"/>
-                        </a:rPr>
-                        <a:t>RMB 3.0M</a:t>
-                      </a:r>
-                    </a:p>
-                  </a:txBody>
-                  <a:tcPr anchor="ctr">
-                    <a:solidFill>
-                      <a:srgbClr val="EEF3F8"/>
-                    </a:solidFill>
-                  </a:tcPr>
-                </a:tc>
-                <a:tc>
-                  <a:txBody>
-                    <a:bodyPr wrap="square"/>
-                    <a:lstStyle/>
-                    <a:p>
-                      <a:pPr algn="ctr"/>
-                      <a:r>
-                        <a:rPr sz="1100" b="0" i="0">
-                          <a:solidFill>
-                            <a:srgbClr val="0B1F33"/>
-                          </a:solidFill>
-                          <a:latin typeface="Segoe UI"/>
-                        </a:rPr>
-                        <a:t>RMB 10.0M</a:t>
-                      </a:r>
-                    </a:p>
-                  </a:txBody>
-                  <a:tcPr anchor="ctr">
-                    <a:solidFill>
-                      <a:srgbClr val="EEF3F8"/>
-                    </a:solidFill>
-                  </a:tcPr>
-                </a:tc>
-              </a:tr>
-              <a:tr h="407670">
-                <a:tc>
-                  <a:txBody>
-                    <a:bodyPr wrap="square"/>
-                    <a:lstStyle/>
-                    <a:p>
-                      <a:pPr algn="l"/>
-                      <a:r>
-                        <a:rPr sz="1100" b="1" i="0">
-                          <a:solidFill>
-                            <a:srgbClr val="FFFFFF"/>
-                          </a:solidFill>
-                          <a:latin typeface="Segoe UI"/>
-                        </a:rPr>
-                        <a:t>Total revenue</a:t>
-                      </a:r>
-                    </a:p>
-                  </a:txBody>
-                  <a:tcPr anchor="ctr">
-                    <a:solidFill>
-                      <a:srgbClr val="0B1F33"/>
-                    </a:solidFill>
-                  </a:tcPr>
-                </a:tc>
-                <a:tc>
-                  <a:txBody>
-                    <a:bodyPr wrap="square"/>
-                    <a:lstStyle/>
-                    <a:p>
-                      <a:pPr algn="ctr"/>
-                      <a:r>
-                        <a:rPr sz="1100" b="1" i="0">
-                          <a:solidFill>
-                            <a:srgbClr val="FFFFFF"/>
-                          </a:solidFill>
-                          <a:latin typeface="Segoe UI"/>
-                        </a:rPr>
-                        <a:t>RMB 6.2M</a:t>
-                      </a:r>
-                    </a:p>
-                  </a:txBody>
-                  <a:tcPr anchor="ctr">
-                    <a:solidFill>
-                      <a:srgbClr val="0B1F33"/>
-                    </a:solidFill>
-                  </a:tcPr>
-                </a:tc>
-                <a:tc>
-                  <a:txBody>
-                    <a:bodyPr wrap="square"/>
-                    <a:lstStyle/>
-                    <a:p>
-                      <a:pPr algn="ctr"/>
-                      <a:r>
-                        <a:rPr sz="1100" b="1" i="0">
-                          <a:solidFill>
-                            <a:srgbClr val="FFFFFF"/>
-                          </a:solidFill>
-                          <a:latin typeface="Segoe UI"/>
-                        </a:rPr>
-                        <a:t>RMB 25.9M</a:t>
-                      </a:r>
-                    </a:p>
-                  </a:txBody>
-                  <a:tcPr anchor="ctr">
-                    <a:solidFill>
-                      <a:srgbClr val="0B1F33"/>
-                    </a:solidFill>
-                  </a:tcPr>
-                </a:tc>
-                <a:tc>
-                  <a:txBody>
-                    <a:bodyPr wrap="square"/>
-                    <a:lstStyle/>
-                    <a:p>
-                      <a:pPr algn="ctr"/>
-                      <a:r>
-                        <a:rPr sz="1100" b="1" i="0">
-                          <a:solidFill>
-                            <a:srgbClr val="FFFFFF"/>
-                          </a:solidFill>
-                          <a:latin typeface="Segoe UI"/>
-                        </a:rPr>
-                        <a:t>RMB 74.5M</a:t>
-                      </a:r>
-                    </a:p>
-                  </a:txBody>
-                  <a:tcPr anchor="ctr">
-                    <a:solidFill>
-                      <a:srgbClr val="0B1F33"/>
-                    </a:solidFill>
-                  </a:tcPr>
-                </a:tc>
-              </a:tr>
-              <a:tr h="407670">
-                <a:tc>
-                  <a:txBody>
-                    <a:bodyPr wrap="square"/>
-                    <a:lstStyle/>
-                    <a:p>
-                      <a:pPr algn="l"/>
-                      <a:r>
-                        <a:rPr sz="1100" b="1" i="0">
-                          <a:solidFill>
-                            <a:srgbClr val="FFFFFF"/>
-                          </a:solidFill>
-                          <a:latin typeface="Segoe UI"/>
-                        </a:rPr>
-                        <a:t>Gross profit</a:t>
-                      </a:r>
-                    </a:p>
-                  </a:txBody>
-                  <a:tcPr anchor="ctr">
-                    <a:solidFill>
-                      <a:srgbClr val="0B1F33"/>
-                    </a:solidFill>
-                  </a:tcPr>
-                </a:tc>
-                <a:tc>
-                  <a:txBody>
-                    <a:bodyPr wrap="square"/>
-                    <a:lstStyle/>
-                    <a:p>
-                      <a:pPr algn="ctr"/>
-                      <a:r>
-                        <a:rPr sz="1100" b="1" i="0">
-                          <a:solidFill>
-                            <a:srgbClr val="FFFFFF"/>
-                          </a:solidFill>
-                          <a:latin typeface="Segoe UI"/>
-                        </a:rPr>
-                        <a:t>RMB 3.5M</a:t>
-                      </a:r>
-                    </a:p>
-                  </a:txBody>
-                  <a:tcPr anchor="ctr">
-                    <a:solidFill>
-                      <a:srgbClr val="0B1F33"/>
-                    </a:solidFill>
-                  </a:tcPr>
-                </a:tc>
-                <a:tc>
-                  <a:txBody>
-                    <a:bodyPr wrap="square"/>
-                    <a:lstStyle/>
-                    <a:p>
-                      <a:pPr algn="ctr"/>
-                      <a:r>
-                        <a:rPr sz="1100" b="1" i="0">
-                          <a:solidFill>
-                            <a:srgbClr val="FFFFFF"/>
-                          </a:solidFill>
-                          <a:latin typeface="Segoe UI"/>
-                        </a:rPr>
-                        <a:t>RMB 16.8M</a:t>
-                      </a:r>
-                    </a:p>
-                  </a:txBody>
-                  <a:tcPr anchor="ctr">
-                    <a:solidFill>
-                      <a:srgbClr val="0B1F33"/>
-                    </a:solidFill>
-                  </a:tcPr>
-                </a:tc>
-                <a:tc>
-                  <a:txBody>
-                    <a:bodyPr wrap="square"/>
-                    <a:lstStyle/>
-                    <a:p>
-                      <a:pPr algn="ctr"/>
-                      <a:r>
-                        <a:rPr sz="1100" b="1" i="0">
-                          <a:solidFill>
-                            <a:srgbClr val="FFFFFF"/>
-                          </a:solidFill>
-                          <a:latin typeface="Segoe UI"/>
-                        </a:rPr>
-                        <a:t>RMB 50.0M</a:t>
-                      </a:r>
-                    </a:p>
-                  </a:txBody>
-                  <a:tcPr anchor="ctr">
-                    <a:solidFill>
-                      <a:srgbClr val="0B1F33"/>
-                    </a:solidFill>
-                  </a:tcPr>
-                </a:tc>
-              </a:tr>
-              <a:tr h="407670">
-                <a:tc>
-                  <a:txBody>
-                    <a:bodyPr wrap="square"/>
-                    <a:lstStyle/>
-                    <a:p>
-                      <a:pPr algn="l"/>
-                      <a:r>
-                        <a:rPr sz="1100" b="1" i="0">
-                          <a:solidFill>
-                            <a:srgbClr val="FFFFFF"/>
-                          </a:solidFill>
-                          <a:latin typeface="Segoe UI"/>
-                        </a:rPr>
-                        <a:t>EBITDA</a:t>
-                      </a:r>
-                    </a:p>
-                  </a:txBody>
-                  <a:tcPr anchor="ctr">
-                    <a:solidFill>
-                      <a:srgbClr val="0B1F33"/>
-                    </a:solidFill>
-                  </a:tcPr>
-                </a:tc>
-                <a:tc>
-                  <a:txBody>
-                    <a:bodyPr wrap="square"/>
-                    <a:lstStyle/>
-                    <a:p>
-                      <a:pPr algn="ctr"/>
-                      <a:r>
-                        <a:rPr sz="1100" b="1" i="0">
-                          <a:solidFill>
-                            <a:srgbClr val="FFFFFF"/>
-                          </a:solidFill>
-                          <a:latin typeface="Segoe UI"/>
-                        </a:rPr>
-                        <a:t>(RMB 9.0M)</a:t>
-                      </a:r>
-                    </a:p>
-                  </a:txBody>
-                  <a:tcPr anchor="ctr">
-                    <a:solidFill>
-                      <a:srgbClr val="0B1F33"/>
-                    </a:solidFill>
-                  </a:tcPr>
-                </a:tc>
-                <a:tc>
-                  <a:txBody>
-                    <a:bodyPr wrap="square"/>
-                    <a:lstStyle/>
-                    <a:p>
-                      <a:pPr algn="ctr"/>
-                      <a:r>
-                        <a:rPr sz="1100" b="1" i="0">
-                          <a:solidFill>
-                            <a:srgbClr val="FFFFFF"/>
-                          </a:solidFill>
-                          <a:latin typeface="Segoe UI"/>
-                        </a:rPr>
-                        <a:t>RMB 0.8M</a:t>
-                      </a:r>
-                    </a:p>
-                  </a:txBody>
-                  <a:tcPr anchor="ctr">
-                    <a:solidFill>
-                      <a:srgbClr val="0B1F33"/>
-                    </a:solidFill>
-                  </a:tcPr>
-                </a:tc>
-                <a:tc>
-                  <a:txBody>
-                    <a:bodyPr wrap="square"/>
-                    <a:lstStyle/>
-                    <a:p>
-                      <a:pPr algn="ctr"/>
-                      <a:r>
-                        <a:rPr sz="1100" b="1" i="0">
-                          <a:solidFill>
-                            <a:srgbClr val="FFFFFF"/>
-                          </a:solidFill>
-                          <a:latin typeface="Segoe UI"/>
-                        </a:rPr>
-                        <a:t>RMB 16.5M</a:t>
-                      </a:r>
-                    </a:p>
-                  </a:txBody>
-                  <a:tcPr anchor="ctr">
-                    <a:solidFill>
-                      <a:srgbClr val="0B1F33"/>
-                    </a:solidFill>
-                  </a:tcPr>
-                </a:tc>
-              </a:tr>
-            </a:tbl>
-          </a:graphicData>
-        </a:graphic>
-      </p:graphicFrame>
-      <p:sp>
-        <p:nvSpPr>
-          <p:cNvPr id="5" name="TextBox 4"/>
-          <p:cNvSpPr txBox="1"/>
-          <p:nvPr/>
-        </p:nvSpPr>
-        <p:spPr>
-          <a:xfrm>
-            <a:off x="502920" y="6016752"/>
-            <a:ext cx="11183112" cy="365760"/>
-          </a:xfrm>
-          <a:prstGeom prst="rect">
-            <a:avLst/>
-          </a:prstGeom>
-          <a:noFill/>
-        </p:spPr>
-        <p:txBody>
-          <a:bodyPr wrap="square" anchor="t"/>
-          <a:lstStyle/>
-          <a:p>
-            <a:pPr algn="l"/>
-            <a:r>
-              <a:rPr sz="1000" b="0" i="0">
+              <a:t>Three-Year Financial Model</a:t>
+            </a:r>
+          </a:p>
+        </p:txBody>
+      </p:sp>
+      <p:sp>
+        <p:nvSpPr>
+          <p:cNvPr id="4" name="TextBox 3"/>
+          <p:cNvSpPr txBox="1"/>
+          <p:nvPr/>
+        </p:nvSpPr>
+        <p:spPr>
+          <a:xfrm>
+            <a:off x="502920" y="841248"/>
+            <a:ext cx="11183112" cy="256032"/>
+          </a:xfrm>
+          <a:prstGeom prst="rect">
+            <a:avLst/>
+          </a:prstGeom>
+          <a:noFill/>
+        </p:spPr>
+        <p:txBody>
+          <a:bodyPr wrap="square" anchor="t"/>
+          <a:lstStyle/>
+          <a:p>
+            <a:pPr algn="l"/>
+            <a:r>
+              <a:rPr sz="1300" b="0" i="0">
                 <a:solidFill>
                   <a:srgbClr val="5E6E80"/>
                 </a:solidFill>
                 <a:latin typeface="Segoe UI"/>
               </a:rPr>
-              <a:t>Illustrative management projections only — not a forecast. Year 1 is the first 12 months post-financing.  USD at an illustrative RMB 6.73 / US$1. Figures labeled illustrative are management projections, not forecasts.</a:t>
-            </a:r>
+              <a:t>Path from free AI Resume to a paid multi-stream platform</a:t>
+            </a:r>
+          </a:p>
+        </p:txBody>
+      </p:sp>
+      <p:sp>
+        <p:nvSpPr>
+          <p:cNvPr id="5" name="Rectangle 4"/>
+          <p:cNvSpPr/>
+          <p:nvPr/>
+        </p:nvSpPr>
+        <p:spPr>
+          <a:xfrm>
+            <a:off x="502920" y="1115568"/>
+            <a:ext cx="11183112" cy="5102352"/>
+          </a:xfrm>
+          <a:prstGeom prst="rect">
+            <a:avLst/>
+          </a:prstGeom>
+          <a:solidFill>
+            <a:srgbClr val="FFFFFF"/>
+          </a:solidFill>
+          <a:ln>
+            <a:noFill/>
+          </a:ln>
+        </p:spPr>
+        <p:style>
+          <a:lnRef idx="1">
+            <a:schemeClr val="accent1"/>
+          </a:lnRef>
+          <a:fillRef idx="3">
+            <a:schemeClr val="accent1"/>
+          </a:fillRef>
+          <a:effectRef idx="2">
+            <a:schemeClr val="accent1"/>
+          </a:effectRef>
+          <a:fontRef idx="minor">
+            <a:schemeClr val="lt1"/>
+          </a:fontRef>
+        </p:style>
+        <p:txBody>
+          <a:bodyPr rtlCol="0" anchor="ctr"/>
+          <a:lstStyle/>
+          <a:p>
+            <a:pPr algn="ctr"/>
           </a:p>
         </p:txBody>
       </p:sp>
@@ -25320,8 +24216,8 @@
         </p:nvSpPr>
         <p:spPr>
           <a:xfrm>
-            <a:off x="0" y="0"/>
-            <a:ext cx="12191695" cy="73152"/>
+            <a:off x="502920" y="1115568"/>
+            <a:ext cx="11183112" cy="402336"/>
           </a:xfrm>
           <a:prstGeom prst="rect">
             <a:avLst/>
@@ -25363,8 +24259,348 @@
         </p:nvSpPr>
         <p:spPr>
           <a:xfrm>
-            <a:off x="0" y="6473952"/>
-            <a:ext cx="12191695" cy="384048"/>
+            <a:off x="502920" y="1115568"/>
+            <a:ext cx="73152" cy="5102352"/>
+          </a:xfrm>
+          <a:prstGeom prst="rect">
+            <a:avLst/>
+          </a:prstGeom>
+          <a:solidFill>
+            <a:srgbClr val="0A6B63"/>
+          </a:solidFill>
+          <a:ln>
+            <a:noFill/>
+          </a:ln>
+        </p:spPr>
+        <p:style>
+          <a:lnRef idx="1">
+            <a:schemeClr val="accent1"/>
+          </a:lnRef>
+          <a:fillRef idx="3">
+            <a:schemeClr val="accent1"/>
+          </a:fillRef>
+          <a:effectRef idx="2">
+            <a:schemeClr val="accent1"/>
+          </a:effectRef>
+          <a:fontRef idx="minor">
+            <a:schemeClr val="lt1"/>
+          </a:fontRef>
+        </p:style>
+        <p:txBody>
+          <a:bodyPr rtlCol="0" anchor="ctr"/>
+          <a:lstStyle/>
+          <a:p>
+            <a:pPr algn="ctr"/>
+          </a:p>
+        </p:txBody>
+      </p:sp>
+      <p:sp>
+        <p:nvSpPr>
+          <p:cNvPr id="8" name="TextBox 7"/>
+          <p:cNvSpPr txBox="1"/>
+          <p:nvPr/>
+        </p:nvSpPr>
+        <p:spPr>
+          <a:xfrm>
+            <a:off x="749808" y="1179576"/>
+            <a:ext cx="3383280" cy="292608"/>
+          </a:xfrm>
+          <a:prstGeom prst="rect">
+            <a:avLst/>
+          </a:prstGeom>
+          <a:noFill/>
+        </p:spPr>
+        <p:txBody>
+          <a:bodyPr wrap="square" anchor="t"/>
+          <a:lstStyle/>
+          <a:p>
+            <a:pPr algn="l"/>
+            <a:r>
+              <a:rPr sz="1200" b="1" i="0">
+                <a:solidFill>
+                  <a:srgbClr val="FFFFFF"/>
+                </a:solidFill>
+                <a:latin typeface="Segoe UI"/>
+              </a:rPr>
+              <a:t>Metric</a:t>
+            </a:r>
+          </a:p>
+        </p:txBody>
+      </p:sp>
+      <p:sp>
+        <p:nvSpPr>
+          <p:cNvPr id="9" name="TextBox 8"/>
+          <p:cNvSpPr txBox="1"/>
+          <p:nvPr/>
+        </p:nvSpPr>
+        <p:spPr>
+          <a:xfrm>
+            <a:off x="4297680" y="1179576"/>
+            <a:ext cx="2377440" cy="292608"/>
+          </a:xfrm>
+          <a:prstGeom prst="rect">
+            <a:avLst/>
+          </a:prstGeom>
+          <a:noFill/>
+        </p:spPr>
+        <p:txBody>
+          <a:bodyPr wrap="square" anchor="t"/>
+          <a:lstStyle/>
+          <a:p>
+            <a:pPr algn="ctr"/>
+            <a:r>
+              <a:rPr sz="1200" b="1" i="0">
+                <a:solidFill>
+                  <a:srgbClr val="FFFFFF"/>
+                </a:solidFill>
+                <a:latin typeface="Segoe UI"/>
+              </a:rPr>
+              <a:t>Year 1</a:t>
+            </a:r>
+          </a:p>
+        </p:txBody>
+      </p:sp>
+      <p:sp>
+        <p:nvSpPr>
+          <p:cNvPr id="10" name="TextBox 9"/>
+          <p:cNvSpPr txBox="1"/>
+          <p:nvPr/>
+        </p:nvSpPr>
+        <p:spPr>
+          <a:xfrm>
+            <a:off x="6903720" y="1179576"/>
+            <a:ext cx="2377440" cy="292608"/>
+          </a:xfrm>
+          <a:prstGeom prst="rect">
+            <a:avLst/>
+          </a:prstGeom>
+          <a:noFill/>
+        </p:spPr>
+        <p:txBody>
+          <a:bodyPr wrap="square" anchor="t"/>
+          <a:lstStyle/>
+          <a:p>
+            <a:pPr algn="ctr"/>
+            <a:r>
+              <a:rPr sz="1200" b="1" i="0">
+                <a:solidFill>
+                  <a:srgbClr val="FFFFFF"/>
+                </a:solidFill>
+                <a:latin typeface="Segoe UI"/>
+              </a:rPr>
+              <a:t>Year 2</a:t>
+            </a:r>
+          </a:p>
+        </p:txBody>
+      </p:sp>
+      <p:sp>
+        <p:nvSpPr>
+          <p:cNvPr id="11" name="TextBox 10"/>
+          <p:cNvSpPr txBox="1"/>
+          <p:nvPr/>
+        </p:nvSpPr>
+        <p:spPr>
+          <a:xfrm>
+            <a:off x="9509760" y="1179576"/>
+            <a:ext cx="2377440" cy="292608"/>
+          </a:xfrm>
+          <a:prstGeom prst="rect">
+            <a:avLst/>
+          </a:prstGeom>
+          <a:noFill/>
+        </p:spPr>
+        <p:txBody>
+          <a:bodyPr wrap="square" anchor="t"/>
+          <a:lstStyle/>
+          <a:p>
+            <a:pPr algn="ctr"/>
+            <a:r>
+              <a:rPr sz="1200" b="1" i="0">
+                <a:solidFill>
+                  <a:srgbClr val="FFFFFF"/>
+                </a:solidFill>
+                <a:latin typeface="Segoe UI"/>
+              </a:rPr>
+              <a:t>Year 3</a:t>
+            </a:r>
+          </a:p>
+        </p:txBody>
+      </p:sp>
+      <p:sp>
+        <p:nvSpPr>
+          <p:cNvPr id="12" name="TextBox 11"/>
+          <p:cNvSpPr txBox="1"/>
+          <p:nvPr/>
+        </p:nvSpPr>
+        <p:spPr>
+          <a:xfrm>
+            <a:off x="749808" y="1609344"/>
+            <a:ext cx="10515600" cy="201168"/>
+          </a:xfrm>
+          <a:prstGeom prst="rect">
+            <a:avLst/>
+          </a:prstGeom>
+          <a:noFill/>
+        </p:spPr>
+        <p:txBody>
+          <a:bodyPr wrap="square" anchor="t"/>
+          <a:lstStyle/>
+          <a:p>
+            <a:pPr algn="l"/>
+            <a:r>
+              <a:rPr sz="1000" b="1" i="0">
+                <a:solidFill>
+                  <a:srgbClr val="0A6B63"/>
+                </a:solidFill>
+                <a:latin typeface="Segoe UI"/>
+              </a:rPr>
+              <a:t>USERS</a:t>
+            </a:r>
+          </a:p>
+        </p:txBody>
+      </p:sp>
+      <p:sp>
+        <p:nvSpPr>
+          <p:cNvPr id="13" name="TextBox 12"/>
+          <p:cNvSpPr txBox="1"/>
+          <p:nvPr/>
+        </p:nvSpPr>
+        <p:spPr>
+          <a:xfrm>
+            <a:off x="749808" y="1837943"/>
+            <a:ext cx="3383280" cy="274320"/>
+          </a:xfrm>
+          <a:prstGeom prst="rect">
+            <a:avLst/>
+          </a:prstGeom>
+          <a:noFill/>
+        </p:spPr>
+        <p:txBody>
+          <a:bodyPr wrap="square" anchor="t"/>
+          <a:lstStyle/>
+          <a:p>
+            <a:pPr algn="l"/>
+            <a:r>
+              <a:rPr sz="1300" b="0" i="0">
+                <a:solidFill>
+                  <a:srgbClr val="0B1F33"/>
+                </a:solidFill>
+                <a:latin typeface="Segoe UI"/>
+              </a:rPr>
+              <a:t>Registered users</a:t>
+            </a:r>
+          </a:p>
+        </p:txBody>
+      </p:sp>
+      <p:sp>
+        <p:nvSpPr>
+          <p:cNvPr id="14" name="TextBox 13"/>
+          <p:cNvSpPr txBox="1"/>
+          <p:nvPr/>
+        </p:nvSpPr>
+        <p:spPr>
+          <a:xfrm>
+            <a:off x="4297680" y="1828800"/>
+            <a:ext cx="2377440" cy="292608"/>
+          </a:xfrm>
+          <a:prstGeom prst="rect">
+            <a:avLst/>
+          </a:prstGeom>
+          <a:noFill/>
+        </p:spPr>
+        <p:txBody>
+          <a:bodyPr wrap="square" anchor="t"/>
+          <a:lstStyle/>
+          <a:p>
+            <a:pPr algn="ctr"/>
+            <a:r>
+              <a:rPr sz="1600" b="1" i="0">
+                <a:solidFill>
+                  <a:srgbClr val="0A6B63"/>
+                </a:solidFill>
+                <a:latin typeface="Georgia"/>
+              </a:rPr>
+              <a:t>x</a:t>
+            </a:r>
+          </a:p>
+        </p:txBody>
+      </p:sp>
+      <p:sp>
+        <p:nvSpPr>
+          <p:cNvPr id="15" name="TextBox 14"/>
+          <p:cNvSpPr txBox="1"/>
+          <p:nvPr/>
+        </p:nvSpPr>
+        <p:spPr>
+          <a:xfrm>
+            <a:off x="6903720" y="1828800"/>
+            <a:ext cx="2377440" cy="292608"/>
+          </a:xfrm>
+          <a:prstGeom prst="rect">
+            <a:avLst/>
+          </a:prstGeom>
+          <a:noFill/>
+        </p:spPr>
+        <p:txBody>
+          <a:bodyPr wrap="square" anchor="t"/>
+          <a:lstStyle/>
+          <a:p>
+            <a:pPr algn="ctr"/>
+            <a:r>
+              <a:rPr sz="1600" b="1" i="0">
+                <a:solidFill>
+                  <a:srgbClr val="0A6B63"/>
+                </a:solidFill>
+                <a:latin typeface="Georgia"/>
+              </a:rPr>
+              <a:t>x</a:t>
+            </a:r>
+          </a:p>
+        </p:txBody>
+      </p:sp>
+      <p:sp>
+        <p:nvSpPr>
+          <p:cNvPr id="16" name="TextBox 15"/>
+          <p:cNvSpPr txBox="1"/>
+          <p:nvPr/>
+        </p:nvSpPr>
+        <p:spPr>
+          <a:xfrm>
+            <a:off x="9509760" y="1828800"/>
+            <a:ext cx="2377440" cy="292608"/>
+          </a:xfrm>
+          <a:prstGeom prst="rect">
+            <a:avLst/>
+          </a:prstGeom>
+          <a:noFill/>
+        </p:spPr>
+        <p:txBody>
+          <a:bodyPr wrap="square" anchor="t"/>
+          <a:lstStyle/>
+          <a:p>
+            <a:pPr algn="ctr"/>
+            <a:r>
+              <a:rPr sz="1600" b="1" i="0">
+                <a:solidFill>
+                  <a:srgbClr val="0A6B63"/>
+                </a:solidFill>
+                <a:latin typeface="Georgia"/>
+              </a:rPr>
+              <a:t>x</a:t>
+            </a:r>
+          </a:p>
+        </p:txBody>
+      </p:sp>
+      <p:sp>
+        <p:nvSpPr>
+          <p:cNvPr id="17" name="Rectangle 16"/>
+          <p:cNvSpPr/>
+          <p:nvPr/>
+        </p:nvSpPr>
+        <p:spPr>
+          <a:xfrm>
+            <a:off x="576072" y="2121408"/>
+            <a:ext cx="11036808" cy="292608"/>
           </a:xfrm>
           <a:prstGeom prst="rect">
             <a:avLst/>
@@ -25400,14 +24636,278 @@
       </p:sp>
       <p:sp>
         <p:nvSpPr>
-          <p:cNvPr id="8" name="Rectangle 7"/>
+          <p:cNvPr id="18" name="TextBox 17"/>
+          <p:cNvSpPr txBox="1"/>
+          <p:nvPr/>
+        </p:nvSpPr>
+        <p:spPr>
+          <a:xfrm>
+            <a:off x="749808" y="2130551"/>
+            <a:ext cx="3383280" cy="274320"/>
+          </a:xfrm>
+          <a:prstGeom prst="rect">
+            <a:avLst/>
+          </a:prstGeom>
+          <a:noFill/>
+        </p:spPr>
+        <p:txBody>
+          <a:bodyPr wrap="square" anchor="t"/>
+          <a:lstStyle/>
+          <a:p>
+            <a:pPr algn="l"/>
+            <a:r>
+              <a:rPr sz="1300" b="0" i="0">
+                <a:solidFill>
+                  <a:srgbClr val="0B1F33"/>
+                </a:solidFill>
+                <a:latin typeface="Segoe UI"/>
+              </a:rPr>
+              <a:t>Monthly active users</a:t>
+            </a:r>
+          </a:p>
+        </p:txBody>
+      </p:sp>
+      <p:sp>
+        <p:nvSpPr>
+          <p:cNvPr id="19" name="TextBox 18"/>
+          <p:cNvSpPr txBox="1"/>
+          <p:nvPr/>
+        </p:nvSpPr>
+        <p:spPr>
+          <a:xfrm>
+            <a:off x="4297680" y="2121408"/>
+            <a:ext cx="2377440" cy="292608"/>
+          </a:xfrm>
+          <a:prstGeom prst="rect">
+            <a:avLst/>
+          </a:prstGeom>
+          <a:noFill/>
+        </p:spPr>
+        <p:txBody>
+          <a:bodyPr wrap="square" anchor="t"/>
+          <a:lstStyle/>
+          <a:p>
+            <a:pPr algn="ctr"/>
+            <a:r>
+              <a:rPr sz="1600" b="1" i="0">
+                <a:solidFill>
+                  <a:srgbClr val="0A6B63"/>
+                </a:solidFill>
+                <a:latin typeface="Georgia"/>
+              </a:rPr>
+              <a:t>x</a:t>
+            </a:r>
+          </a:p>
+        </p:txBody>
+      </p:sp>
+      <p:sp>
+        <p:nvSpPr>
+          <p:cNvPr id="20" name="TextBox 19"/>
+          <p:cNvSpPr txBox="1"/>
+          <p:nvPr/>
+        </p:nvSpPr>
+        <p:spPr>
+          <a:xfrm>
+            <a:off x="6903720" y="2121408"/>
+            <a:ext cx="2377440" cy="292608"/>
+          </a:xfrm>
+          <a:prstGeom prst="rect">
+            <a:avLst/>
+          </a:prstGeom>
+          <a:noFill/>
+        </p:spPr>
+        <p:txBody>
+          <a:bodyPr wrap="square" anchor="t"/>
+          <a:lstStyle/>
+          <a:p>
+            <a:pPr algn="ctr"/>
+            <a:r>
+              <a:rPr sz="1600" b="1" i="0">
+                <a:solidFill>
+                  <a:srgbClr val="0A6B63"/>
+                </a:solidFill>
+                <a:latin typeface="Georgia"/>
+              </a:rPr>
+              <a:t>x</a:t>
+            </a:r>
+          </a:p>
+        </p:txBody>
+      </p:sp>
+      <p:sp>
+        <p:nvSpPr>
+          <p:cNvPr id="21" name="TextBox 20"/>
+          <p:cNvSpPr txBox="1"/>
+          <p:nvPr/>
+        </p:nvSpPr>
+        <p:spPr>
+          <a:xfrm>
+            <a:off x="9509760" y="2121408"/>
+            <a:ext cx="2377440" cy="292608"/>
+          </a:xfrm>
+          <a:prstGeom prst="rect">
+            <a:avLst/>
+          </a:prstGeom>
+          <a:noFill/>
+        </p:spPr>
+        <p:txBody>
+          <a:bodyPr wrap="square" anchor="t"/>
+          <a:lstStyle/>
+          <a:p>
+            <a:pPr algn="ctr"/>
+            <a:r>
+              <a:rPr sz="1600" b="1" i="0">
+                <a:solidFill>
+                  <a:srgbClr val="0A6B63"/>
+                </a:solidFill>
+                <a:latin typeface="Georgia"/>
+              </a:rPr>
+              <a:t>x</a:t>
+            </a:r>
+          </a:p>
+        </p:txBody>
+      </p:sp>
+      <p:sp>
+        <p:nvSpPr>
+          <p:cNvPr id="22" name="TextBox 21"/>
+          <p:cNvSpPr txBox="1"/>
+          <p:nvPr/>
+        </p:nvSpPr>
+        <p:spPr>
+          <a:xfrm>
+            <a:off x="749808" y="2423159"/>
+            <a:ext cx="3383280" cy="274320"/>
+          </a:xfrm>
+          <a:prstGeom prst="rect">
+            <a:avLst/>
+          </a:prstGeom>
+          <a:noFill/>
+        </p:spPr>
+        <p:txBody>
+          <a:bodyPr wrap="square" anchor="t"/>
+          <a:lstStyle/>
+          <a:p>
+            <a:pPr algn="l"/>
+            <a:r>
+              <a:rPr sz="1300" b="0" i="0">
+                <a:solidFill>
+                  <a:srgbClr val="0B1F33"/>
+                </a:solidFill>
+                <a:latin typeface="Segoe UI"/>
+              </a:rPr>
+              <a:t>Paid users</a:t>
+            </a:r>
+          </a:p>
+        </p:txBody>
+      </p:sp>
+      <p:sp>
+        <p:nvSpPr>
+          <p:cNvPr id="23" name="TextBox 22"/>
+          <p:cNvSpPr txBox="1"/>
+          <p:nvPr/>
+        </p:nvSpPr>
+        <p:spPr>
+          <a:xfrm>
+            <a:off x="4297680" y="2414015"/>
+            <a:ext cx="2377440" cy="292608"/>
+          </a:xfrm>
+          <a:prstGeom prst="rect">
+            <a:avLst/>
+          </a:prstGeom>
+          <a:noFill/>
+        </p:spPr>
+        <p:txBody>
+          <a:bodyPr wrap="square" anchor="t"/>
+          <a:lstStyle/>
+          <a:p>
+            <a:pPr algn="ctr"/>
+            <a:r>
+              <a:rPr sz="1600" b="1" i="0">
+                <a:solidFill>
+                  <a:srgbClr val="0A6B63"/>
+                </a:solidFill>
+                <a:latin typeface="Georgia"/>
+              </a:rPr>
+              <a:t>x</a:t>
+            </a:r>
+          </a:p>
+        </p:txBody>
+      </p:sp>
+      <p:sp>
+        <p:nvSpPr>
+          <p:cNvPr id="24" name="TextBox 23"/>
+          <p:cNvSpPr txBox="1"/>
+          <p:nvPr/>
+        </p:nvSpPr>
+        <p:spPr>
+          <a:xfrm>
+            <a:off x="6903720" y="2414015"/>
+            <a:ext cx="2377440" cy="292608"/>
+          </a:xfrm>
+          <a:prstGeom prst="rect">
+            <a:avLst/>
+          </a:prstGeom>
+          <a:noFill/>
+        </p:spPr>
+        <p:txBody>
+          <a:bodyPr wrap="square" anchor="t"/>
+          <a:lstStyle/>
+          <a:p>
+            <a:pPr algn="ctr"/>
+            <a:r>
+              <a:rPr sz="1600" b="1" i="0">
+                <a:solidFill>
+                  <a:srgbClr val="0A6B63"/>
+                </a:solidFill>
+                <a:latin typeface="Georgia"/>
+              </a:rPr>
+              <a:t>x</a:t>
+            </a:r>
+          </a:p>
+        </p:txBody>
+      </p:sp>
+      <p:sp>
+        <p:nvSpPr>
+          <p:cNvPr id="25" name="TextBox 24"/>
+          <p:cNvSpPr txBox="1"/>
+          <p:nvPr/>
+        </p:nvSpPr>
+        <p:spPr>
+          <a:xfrm>
+            <a:off x="9509760" y="2414015"/>
+            <a:ext cx="2377440" cy="292608"/>
+          </a:xfrm>
+          <a:prstGeom prst="rect">
+            <a:avLst/>
+          </a:prstGeom>
+          <a:noFill/>
+        </p:spPr>
+        <p:txBody>
+          <a:bodyPr wrap="square" anchor="t"/>
+          <a:lstStyle/>
+          <a:p>
+            <a:pPr algn="ctr"/>
+            <a:r>
+              <a:rPr sz="1600" b="1" i="0">
+                <a:solidFill>
+                  <a:srgbClr val="0A6B63"/>
+                </a:solidFill>
+                <a:latin typeface="Georgia"/>
+              </a:rPr>
+              <a:t>x</a:t>
+            </a:r>
+          </a:p>
+        </p:txBody>
+      </p:sp>
+      <p:sp>
+        <p:nvSpPr>
+          <p:cNvPr id="26" name="Rectangle 25"/>
           <p:cNvSpPr/>
           <p:nvPr/>
         </p:nvSpPr>
         <p:spPr>
           <a:xfrm>
-            <a:off x="0" y="6473952"/>
-            <a:ext cx="12191695" cy="9144"/>
+            <a:off x="749808" y="2724911"/>
+            <a:ext cx="10515600" cy="9144"/>
           </a:xfrm>
           <a:prstGeom prst="rect">
             <a:avLst/>
@@ -25443,7 +24943,1549 @@
       </p:sp>
       <p:sp>
         <p:nvSpPr>
-          <p:cNvPr id="9" name="TextBox 8"/>
+          <p:cNvPr id="27" name="TextBox 26"/>
+          <p:cNvSpPr txBox="1"/>
+          <p:nvPr/>
+        </p:nvSpPr>
+        <p:spPr>
+          <a:xfrm>
+            <a:off x="749808" y="2779775"/>
+            <a:ext cx="10515600" cy="201168"/>
+          </a:xfrm>
+          <a:prstGeom prst="rect">
+            <a:avLst/>
+          </a:prstGeom>
+          <a:noFill/>
+        </p:spPr>
+        <p:txBody>
+          <a:bodyPr wrap="square" anchor="t"/>
+          <a:lstStyle/>
+          <a:p>
+            <a:pPr algn="l"/>
+            <a:r>
+              <a:rPr sz="1000" b="1" i="0">
+                <a:solidFill>
+                  <a:srgbClr val="0A6B63"/>
+                </a:solidFill>
+                <a:latin typeface="Segoe UI"/>
+              </a:rPr>
+              <a:t>REVENUE</a:t>
+            </a:r>
+          </a:p>
+        </p:txBody>
+      </p:sp>
+      <p:sp>
+        <p:nvSpPr>
+          <p:cNvPr id="28" name="TextBox 27"/>
+          <p:cNvSpPr txBox="1"/>
+          <p:nvPr/>
+        </p:nvSpPr>
+        <p:spPr>
+          <a:xfrm>
+            <a:off x="749808" y="3008375"/>
+            <a:ext cx="3383280" cy="274320"/>
+          </a:xfrm>
+          <a:prstGeom prst="rect">
+            <a:avLst/>
+          </a:prstGeom>
+          <a:noFill/>
+        </p:spPr>
+        <p:txBody>
+          <a:bodyPr wrap="square" anchor="t"/>
+          <a:lstStyle/>
+          <a:p>
+            <a:pPr algn="l"/>
+            <a:r>
+              <a:rPr sz="1300" b="0" i="0">
+                <a:solidFill>
+                  <a:srgbClr val="0B1F33"/>
+                </a:solidFill>
+                <a:latin typeface="Segoe UI"/>
+              </a:rPr>
+              <a:t>AI revenue</a:t>
+            </a:r>
+          </a:p>
+        </p:txBody>
+      </p:sp>
+      <p:sp>
+        <p:nvSpPr>
+          <p:cNvPr id="29" name="TextBox 28"/>
+          <p:cNvSpPr txBox="1"/>
+          <p:nvPr/>
+        </p:nvSpPr>
+        <p:spPr>
+          <a:xfrm>
+            <a:off x="4297680" y="2999231"/>
+            <a:ext cx="2377440" cy="292608"/>
+          </a:xfrm>
+          <a:prstGeom prst="rect">
+            <a:avLst/>
+          </a:prstGeom>
+          <a:noFill/>
+        </p:spPr>
+        <p:txBody>
+          <a:bodyPr wrap="square" anchor="t"/>
+          <a:lstStyle/>
+          <a:p>
+            <a:pPr algn="ctr"/>
+            <a:r>
+              <a:rPr sz="1600" b="1" i="0">
+                <a:solidFill>
+                  <a:srgbClr val="0A6B63"/>
+                </a:solidFill>
+                <a:latin typeface="Georgia"/>
+              </a:rPr>
+              <a:t>x</a:t>
+            </a:r>
+          </a:p>
+        </p:txBody>
+      </p:sp>
+      <p:sp>
+        <p:nvSpPr>
+          <p:cNvPr id="30" name="TextBox 29"/>
+          <p:cNvSpPr txBox="1"/>
+          <p:nvPr/>
+        </p:nvSpPr>
+        <p:spPr>
+          <a:xfrm>
+            <a:off x="6903720" y="2999231"/>
+            <a:ext cx="2377440" cy="292608"/>
+          </a:xfrm>
+          <a:prstGeom prst="rect">
+            <a:avLst/>
+          </a:prstGeom>
+          <a:noFill/>
+        </p:spPr>
+        <p:txBody>
+          <a:bodyPr wrap="square" anchor="t"/>
+          <a:lstStyle/>
+          <a:p>
+            <a:pPr algn="ctr"/>
+            <a:r>
+              <a:rPr sz="1600" b="1" i="0">
+                <a:solidFill>
+                  <a:srgbClr val="0A6B63"/>
+                </a:solidFill>
+                <a:latin typeface="Georgia"/>
+              </a:rPr>
+              <a:t>x</a:t>
+            </a:r>
+          </a:p>
+        </p:txBody>
+      </p:sp>
+      <p:sp>
+        <p:nvSpPr>
+          <p:cNvPr id="31" name="TextBox 30"/>
+          <p:cNvSpPr txBox="1"/>
+          <p:nvPr/>
+        </p:nvSpPr>
+        <p:spPr>
+          <a:xfrm>
+            <a:off x="9509760" y="2999231"/>
+            <a:ext cx="2377440" cy="292608"/>
+          </a:xfrm>
+          <a:prstGeom prst="rect">
+            <a:avLst/>
+          </a:prstGeom>
+          <a:noFill/>
+        </p:spPr>
+        <p:txBody>
+          <a:bodyPr wrap="square" anchor="t"/>
+          <a:lstStyle/>
+          <a:p>
+            <a:pPr algn="ctr"/>
+            <a:r>
+              <a:rPr sz="1600" b="1" i="0">
+                <a:solidFill>
+                  <a:srgbClr val="0A6B63"/>
+                </a:solidFill>
+                <a:latin typeface="Georgia"/>
+              </a:rPr>
+              <a:t>x</a:t>
+            </a:r>
+          </a:p>
+        </p:txBody>
+      </p:sp>
+      <p:sp>
+        <p:nvSpPr>
+          <p:cNvPr id="32" name="Rectangle 31"/>
+          <p:cNvSpPr/>
+          <p:nvPr/>
+        </p:nvSpPr>
+        <p:spPr>
+          <a:xfrm>
+            <a:off x="576072" y="3291839"/>
+            <a:ext cx="11036808" cy="292608"/>
+          </a:xfrm>
+          <a:prstGeom prst="rect">
+            <a:avLst/>
+          </a:prstGeom>
+          <a:solidFill>
+            <a:srgbClr val="F5F8FB"/>
+          </a:solidFill>
+          <a:ln>
+            <a:noFill/>
+          </a:ln>
+        </p:spPr>
+        <p:style>
+          <a:lnRef idx="1">
+            <a:schemeClr val="accent1"/>
+          </a:lnRef>
+          <a:fillRef idx="3">
+            <a:schemeClr val="accent1"/>
+          </a:fillRef>
+          <a:effectRef idx="2">
+            <a:schemeClr val="accent1"/>
+          </a:effectRef>
+          <a:fontRef idx="minor">
+            <a:schemeClr val="lt1"/>
+          </a:fontRef>
+        </p:style>
+        <p:txBody>
+          <a:bodyPr rtlCol="0" anchor="ctr"/>
+          <a:lstStyle/>
+          <a:p>
+            <a:pPr algn="ctr"/>
+          </a:p>
+        </p:txBody>
+      </p:sp>
+      <p:sp>
+        <p:nvSpPr>
+          <p:cNvPr id="33" name="TextBox 32"/>
+          <p:cNvSpPr txBox="1"/>
+          <p:nvPr/>
+        </p:nvSpPr>
+        <p:spPr>
+          <a:xfrm>
+            <a:off x="749808" y="3300983"/>
+            <a:ext cx="3383280" cy="274320"/>
+          </a:xfrm>
+          <a:prstGeom prst="rect">
+            <a:avLst/>
+          </a:prstGeom>
+          <a:noFill/>
+        </p:spPr>
+        <p:txBody>
+          <a:bodyPr wrap="square" anchor="t"/>
+          <a:lstStyle/>
+          <a:p>
+            <a:pPr algn="l"/>
+            <a:r>
+              <a:rPr sz="1300" b="0" i="0">
+                <a:solidFill>
+                  <a:srgbClr val="0B1F33"/>
+                </a:solidFill>
+                <a:latin typeface="Segoe UI"/>
+              </a:rPr>
+              <a:t>Career services</a:t>
+            </a:r>
+          </a:p>
+        </p:txBody>
+      </p:sp>
+      <p:sp>
+        <p:nvSpPr>
+          <p:cNvPr id="34" name="TextBox 33"/>
+          <p:cNvSpPr txBox="1"/>
+          <p:nvPr/>
+        </p:nvSpPr>
+        <p:spPr>
+          <a:xfrm>
+            <a:off x="4297680" y="3291839"/>
+            <a:ext cx="2377440" cy="292608"/>
+          </a:xfrm>
+          <a:prstGeom prst="rect">
+            <a:avLst/>
+          </a:prstGeom>
+          <a:noFill/>
+        </p:spPr>
+        <p:txBody>
+          <a:bodyPr wrap="square" anchor="t"/>
+          <a:lstStyle/>
+          <a:p>
+            <a:pPr algn="ctr"/>
+            <a:r>
+              <a:rPr sz="1600" b="1" i="0">
+                <a:solidFill>
+                  <a:srgbClr val="0A6B63"/>
+                </a:solidFill>
+                <a:latin typeface="Georgia"/>
+              </a:rPr>
+              <a:t>x</a:t>
+            </a:r>
+          </a:p>
+        </p:txBody>
+      </p:sp>
+      <p:sp>
+        <p:nvSpPr>
+          <p:cNvPr id="35" name="TextBox 34"/>
+          <p:cNvSpPr txBox="1"/>
+          <p:nvPr/>
+        </p:nvSpPr>
+        <p:spPr>
+          <a:xfrm>
+            <a:off x="6903720" y="3291839"/>
+            <a:ext cx="2377440" cy="292608"/>
+          </a:xfrm>
+          <a:prstGeom prst="rect">
+            <a:avLst/>
+          </a:prstGeom>
+          <a:noFill/>
+        </p:spPr>
+        <p:txBody>
+          <a:bodyPr wrap="square" anchor="t"/>
+          <a:lstStyle/>
+          <a:p>
+            <a:pPr algn="ctr"/>
+            <a:r>
+              <a:rPr sz="1600" b="1" i="0">
+                <a:solidFill>
+                  <a:srgbClr val="0A6B63"/>
+                </a:solidFill>
+                <a:latin typeface="Georgia"/>
+              </a:rPr>
+              <a:t>x</a:t>
+            </a:r>
+          </a:p>
+        </p:txBody>
+      </p:sp>
+      <p:sp>
+        <p:nvSpPr>
+          <p:cNvPr id="36" name="TextBox 35"/>
+          <p:cNvSpPr txBox="1"/>
+          <p:nvPr/>
+        </p:nvSpPr>
+        <p:spPr>
+          <a:xfrm>
+            <a:off x="9509760" y="3291839"/>
+            <a:ext cx="2377440" cy="292608"/>
+          </a:xfrm>
+          <a:prstGeom prst="rect">
+            <a:avLst/>
+          </a:prstGeom>
+          <a:noFill/>
+        </p:spPr>
+        <p:txBody>
+          <a:bodyPr wrap="square" anchor="t"/>
+          <a:lstStyle/>
+          <a:p>
+            <a:pPr algn="ctr"/>
+            <a:r>
+              <a:rPr sz="1600" b="1" i="0">
+                <a:solidFill>
+                  <a:srgbClr val="0A6B63"/>
+                </a:solidFill>
+                <a:latin typeface="Georgia"/>
+              </a:rPr>
+              <a:t>x</a:t>
+            </a:r>
+          </a:p>
+        </p:txBody>
+      </p:sp>
+      <p:sp>
+        <p:nvSpPr>
+          <p:cNvPr id="37" name="TextBox 36"/>
+          <p:cNvSpPr txBox="1"/>
+          <p:nvPr/>
+        </p:nvSpPr>
+        <p:spPr>
+          <a:xfrm>
+            <a:off x="749808" y="3593591"/>
+            <a:ext cx="3383280" cy="274320"/>
+          </a:xfrm>
+          <a:prstGeom prst="rect">
+            <a:avLst/>
+          </a:prstGeom>
+          <a:noFill/>
+        </p:spPr>
+        <p:txBody>
+          <a:bodyPr wrap="square" anchor="t"/>
+          <a:lstStyle/>
+          <a:p>
+            <a:pPr algn="l"/>
+            <a:r>
+              <a:rPr sz="1300" b="0" i="0">
+                <a:solidFill>
+                  <a:srgbClr val="0B1F33"/>
+                </a:solidFill>
+                <a:latin typeface="Segoe UI"/>
+              </a:rPr>
+              <a:t>Commission revenue</a:t>
+            </a:r>
+          </a:p>
+        </p:txBody>
+      </p:sp>
+      <p:sp>
+        <p:nvSpPr>
+          <p:cNvPr id="38" name="TextBox 37"/>
+          <p:cNvSpPr txBox="1"/>
+          <p:nvPr/>
+        </p:nvSpPr>
+        <p:spPr>
+          <a:xfrm>
+            <a:off x="4297680" y="3584447"/>
+            <a:ext cx="2377440" cy="292608"/>
+          </a:xfrm>
+          <a:prstGeom prst="rect">
+            <a:avLst/>
+          </a:prstGeom>
+          <a:noFill/>
+        </p:spPr>
+        <p:txBody>
+          <a:bodyPr wrap="square" anchor="t"/>
+          <a:lstStyle/>
+          <a:p>
+            <a:pPr algn="ctr"/>
+            <a:r>
+              <a:rPr sz="1600" b="1" i="0">
+                <a:solidFill>
+                  <a:srgbClr val="0A6B63"/>
+                </a:solidFill>
+                <a:latin typeface="Georgia"/>
+              </a:rPr>
+              <a:t>x</a:t>
+            </a:r>
+          </a:p>
+        </p:txBody>
+      </p:sp>
+      <p:sp>
+        <p:nvSpPr>
+          <p:cNvPr id="39" name="TextBox 38"/>
+          <p:cNvSpPr txBox="1"/>
+          <p:nvPr/>
+        </p:nvSpPr>
+        <p:spPr>
+          <a:xfrm>
+            <a:off x="6903720" y="3584447"/>
+            <a:ext cx="2377440" cy="292608"/>
+          </a:xfrm>
+          <a:prstGeom prst="rect">
+            <a:avLst/>
+          </a:prstGeom>
+          <a:noFill/>
+        </p:spPr>
+        <p:txBody>
+          <a:bodyPr wrap="square" anchor="t"/>
+          <a:lstStyle/>
+          <a:p>
+            <a:pPr algn="ctr"/>
+            <a:r>
+              <a:rPr sz="1600" b="1" i="0">
+                <a:solidFill>
+                  <a:srgbClr val="0A6B63"/>
+                </a:solidFill>
+                <a:latin typeface="Georgia"/>
+              </a:rPr>
+              <a:t>x</a:t>
+            </a:r>
+          </a:p>
+        </p:txBody>
+      </p:sp>
+      <p:sp>
+        <p:nvSpPr>
+          <p:cNvPr id="40" name="TextBox 39"/>
+          <p:cNvSpPr txBox="1"/>
+          <p:nvPr/>
+        </p:nvSpPr>
+        <p:spPr>
+          <a:xfrm>
+            <a:off x="9509760" y="3584447"/>
+            <a:ext cx="2377440" cy="292608"/>
+          </a:xfrm>
+          <a:prstGeom prst="rect">
+            <a:avLst/>
+          </a:prstGeom>
+          <a:noFill/>
+        </p:spPr>
+        <p:txBody>
+          <a:bodyPr wrap="square" anchor="t"/>
+          <a:lstStyle/>
+          <a:p>
+            <a:pPr algn="ctr"/>
+            <a:r>
+              <a:rPr sz="1600" b="1" i="0">
+                <a:solidFill>
+                  <a:srgbClr val="0A6B63"/>
+                </a:solidFill>
+                <a:latin typeface="Georgia"/>
+              </a:rPr>
+              <a:t>x</a:t>
+            </a:r>
+          </a:p>
+        </p:txBody>
+      </p:sp>
+      <p:sp>
+        <p:nvSpPr>
+          <p:cNvPr id="41" name="Rectangle 40"/>
+          <p:cNvSpPr/>
+          <p:nvPr/>
+        </p:nvSpPr>
+        <p:spPr>
+          <a:xfrm>
+            <a:off x="576072" y="3877055"/>
+            <a:ext cx="11036808" cy="292608"/>
+          </a:xfrm>
+          <a:prstGeom prst="rect">
+            <a:avLst/>
+          </a:prstGeom>
+          <a:solidFill>
+            <a:srgbClr val="F5F8FB"/>
+          </a:solidFill>
+          <a:ln>
+            <a:noFill/>
+          </a:ln>
+        </p:spPr>
+        <p:style>
+          <a:lnRef idx="1">
+            <a:schemeClr val="accent1"/>
+          </a:lnRef>
+          <a:fillRef idx="3">
+            <a:schemeClr val="accent1"/>
+          </a:fillRef>
+          <a:effectRef idx="2">
+            <a:schemeClr val="accent1"/>
+          </a:effectRef>
+          <a:fontRef idx="minor">
+            <a:schemeClr val="lt1"/>
+          </a:fontRef>
+        </p:style>
+        <p:txBody>
+          <a:bodyPr rtlCol="0" anchor="ctr"/>
+          <a:lstStyle/>
+          <a:p>
+            <a:pPr algn="ctr"/>
+          </a:p>
+        </p:txBody>
+      </p:sp>
+      <p:sp>
+        <p:nvSpPr>
+          <p:cNvPr id="42" name="TextBox 41"/>
+          <p:cNvSpPr txBox="1"/>
+          <p:nvPr/>
+        </p:nvSpPr>
+        <p:spPr>
+          <a:xfrm>
+            <a:off x="749808" y="3886199"/>
+            <a:ext cx="3383280" cy="274320"/>
+          </a:xfrm>
+          <a:prstGeom prst="rect">
+            <a:avLst/>
+          </a:prstGeom>
+          <a:noFill/>
+        </p:spPr>
+        <p:txBody>
+          <a:bodyPr wrap="square" anchor="t"/>
+          <a:lstStyle/>
+          <a:p>
+            <a:pPr algn="l"/>
+            <a:r>
+              <a:rPr sz="1300" b="0" i="0">
+                <a:solidFill>
+                  <a:srgbClr val="0B1F33"/>
+                </a:solidFill>
+                <a:latin typeface="Segoe UI"/>
+              </a:rPr>
+              <a:t>Advertising</a:t>
+            </a:r>
+          </a:p>
+        </p:txBody>
+      </p:sp>
+      <p:sp>
+        <p:nvSpPr>
+          <p:cNvPr id="43" name="TextBox 42"/>
+          <p:cNvSpPr txBox="1"/>
+          <p:nvPr/>
+        </p:nvSpPr>
+        <p:spPr>
+          <a:xfrm>
+            <a:off x="4297680" y="3877055"/>
+            <a:ext cx="2377440" cy="292608"/>
+          </a:xfrm>
+          <a:prstGeom prst="rect">
+            <a:avLst/>
+          </a:prstGeom>
+          <a:noFill/>
+        </p:spPr>
+        <p:txBody>
+          <a:bodyPr wrap="square" anchor="t"/>
+          <a:lstStyle/>
+          <a:p>
+            <a:pPr algn="ctr"/>
+            <a:r>
+              <a:rPr sz="1600" b="1" i="0">
+                <a:solidFill>
+                  <a:srgbClr val="0A6B63"/>
+                </a:solidFill>
+                <a:latin typeface="Georgia"/>
+              </a:rPr>
+              <a:t>x</a:t>
+            </a:r>
+          </a:p>
+        </p:txBody>
+      </p:sp>
+      <p:sp>
+        <p:nvSpPr>
+          <p:cNvPr id="44" name="TextBox 43"/>
+          <p:cNvSpPr txBox="1"/>
+          <p:nvPr/>
+        </p:nvSpPr>
+        <p:spPr>
+          <a:xfrm>
+            <a:off x="6903720" y="3877055"/>
+            <a:ext cx="2377440" cy="292608"/>
+          </a:xfrm>
+          <a:prstGeom prst="rect">
+            <a:avLst/>
+          </a:prstGeom>
+          <a:noFill/>
+        </p:spPr>
+        <p:txBody>
+          <a:bodyPr wrap="square" anchor="t"/>
+          <a:lstStyle/>
+          <a:p>
+            <a:pPr algn="ctr"/>
+            <a:r>
+              <a:rPr sz="1600" b="1" i="0">
+                <a:solidFill>
+                  <a:srgbClr val="0A6B63"/>
+                </a:solidFill>
+                <a:latin typeface="Georgia"/>
+              </a:rPr>
+              <a:t>x</a:t>
+            </a:r>
+          </a:p>
+        </p:txBody>
+      </p:sp>
+      <p:sp>
+        <p:nvSpPr>
+          <p:cNvPr id="45" name="TextBox 44"/>
+          <p:cNvSpPr txBox="1"/>
+          <p:nvPr/>
+        </p:nvSpPr>
+        <p:spPr>
+          <a:xfrm>
+            <a:off x="9509760" y="3877055"/>
+            <a:ext cx="2377440" cy="292608"/>
+          </a:xfrm>
+          <a:prstGeom prst="rect">
+            <a:avLst/>
+          </a:prstGeom>
+          <a:noFill/>
+        </p:spPr>
+        <p:txBody>
+          <a:bodyPr wrap="square" anchor="t"/>
+          <a:lstStyle/>
+          <a:p>
+            <a:pPr algn="ctr"/>
+            <a:r>
+              <a:rPr sz="1600" b="1" i="0">
+                <a:solidFill>
+                  <a:srgbClr val="0A6B63"/>
+                </a:solidFill>
+                <a:latin typeface="Georgia"/>
+              </a:rPr>
+              <a:t>x</a:t>
+            </a:r>
+          </a:p>
+        </p:txBody>
+      </p:sp>
+      <p:sp>
+        <p:nvSpPr>
+          <p:cNvPr id="46" name="TextBox 45"/>
+          <p:cNvSpPr txBox="1"/>
+          <p:nvPr/>
+        </p:nvSpPr>
+        <p:spPr>
+          <a:xfrm>
+            <a:off x="749808" y="4178807"/>
+            <a:ext cx="3383280" cy="274320"/>
+          </a:xfrm>
+          <a:prstGeom prst="rect">
+            <a:avLst/>
+          </a:prstGeom>
+          <a:noFill/>
+        </p:spPr>
+        <p:txBody>
+          <a:bodyPr wrap="square" anchor="t"/>
+          <a:lstStyle/>
+          <a:p>
+            <a:pPr algn="l"/>
+            <a:r>
+              <a:rPr sz="1300" b="0" i="0">
+                <a:solidFill>
+                  <a:srgbClr val="0B1F33"/>
+                </a:solidFill>
+                <a:latin typeface="Segoe UI"/>
+              </a:rPr>
+              <a:t>B2B revenue</a:t>
+            </a:r>
+          </a:p>
+        </p:txBody>
+      </p:sp>
+      <p:sp>
+        <p:nvSpPr>
+          <p:cNvPr id="47" name="TextBox 46"/>
+          <p:cNvSpPr txBox="1"/>
+          <p:nvPr/>
+        </p:nvSpPr>
+        <p:spPr>
+          <a:xfrm>
+            <a:off x="4297680" y="4169663"/>
+            <a:ext cx="2377440" cy="292608"/>
+          </a:xfrm>
+          <a:prstGeom prst="rect">
+            <a:avLst/>
+          </a:prstGeom>
+          <a:noFill/>
+        </p:spPr>
+        <p:txBody>
+          <a:bodyPr wrap="square" anchor="t"/>
+          <a:lstStyle/>
+          <a:p>
+            <a:pPr algn="ctr"/>
+            <a:r>
+              <a:rPr sz="1600" b="1" i="0">
+                <a:solidFill>
+                  <a:srgbClr val="0A6B63"/>
+                </a:solidFill>
+                <a:latin typeface="Georgia"/>
+              </a:rPr>
+              <a:t>x</a:t>
+            </a:r>
+          </a:p>
+        </p:txBody>
+      </p:sp>
+      <p:sp>
+        <p:nvSpPr>
+          <p:cNvPr id="48" name="TextBox 47"/>
+          <p:cNvSpPr txBox="1"/>
+          <p:nvPr/>
+        </p:nvSpPr>
+        <p:spPr>
+          <a:xfrm>
+            <a:off x="6903720" y="4169663"/>
+            <a:ext cx="2377440" cy="292608"/>
+          </a:xfrm>
+          <a:prstGeom prst="rect">
+            <a:avLst/>
+          </a:prstGeom>
+          <a:noFill/>
+        </p:spPr>
+        <p:txBody>
+          <a:bodyPr wrap="square" anchor="t"/>
+          <a:lstStyle/>
+          <a:p>
+            <a:pPr algn="ctr"/>
+            <a:r>
+              <a:rPr sz="1600" b="1" i="0">
+                <a:solidFill>
+                  <a:srgbClr val="0A6B63"/>
+                </a:solidFill>
+                <a:latin typeface="Georgia"/>
+              </a:rPr>
+              <a:t>x</a:t>
+            </a:r>
+          </a:p>
+        </p:txBody>
+      </p:sp>
+      <p:sp>
+        <p:nvSpPr>
+          <p:cNvPr id="49" name="TextBox 48"/>
+          <p:cNvSpPr txBox="1"/>
+          <p:nvPr/>
+        </p:nvSpPr>
+        <p:spPr>
+          <a:xfrm>
+            <a:off x="9509760" y="4169663"/>
+            <a:ext cx="2377440" cy="292608"/>
+          </a:xfrm>
+          <a:prstGeom prst="rect">
+            <a:avLst/>
+          </a:prstGeom>
+          <a:noFill/>
+        </p:spPr>
+        <p:txBody>
+          <a:bodyPr wrap="square" anchor="t"/>
+          <a:lstStyle/>
+          <a:p>
+            <a:pPr algn="ctr"/>
+            <a:r>
+              <a:rPr sz="1600" b="1" i="0">
+                <a:solidFill>
+                  <a:srgbClr val="0A6B63"/>
+                </a:solidFill>
+                <a:latin typeface="Georgia"/>
+              </a:rPr>
+              <a:t>x</a:t>
+            </a:r>
+          </a:p>
+        </p:txBody>
+      </p:sp>
+      <p:sp>
+        <p:nvSpPr>
+          <p:cNvPr id="50" name="Rectangle 49"/>
+          <p:cNvSpPr/>
+          <p:nvPr/>
+        </p:nvSpPr>
+        <p:spPr>
+          <a:xfrm>
+            <a:off x="749808" y="4480560"/>
+            <a:ext cx="10515600" cy="9144"/>
+          </a:xfrm>
+          <a:prstGeom prst="rect">
+            <a:avLst/>
+          </a:prstGeom>
+          <a:solidFill>
+            <a:srgbClr val="D4DEE8"/>
+          </a:solidFill>
+          <a:ln>
+            <a:noFill/>
+          </a:ln>
+        </p:spPr>
+        <p:style>
+          <a:lnRef idx="1">
+            <a:schemeClr val="accent1"/>
+          </a:lnRef>
+          <a:fillRef idx="3">
+            <a:schemeClr val="accent1"/>
+          </a:fillRef>
+          <a:effectRef idx="2">
+            <a:schemeClr val="accent1"/>
+          </a:effectRef>
+          <a:fontRef idx="minor">
+            <a:schemeClr val="lt1"/>
+          </a:fontRef>
+        </p:style>
+        <p:txBody>
+          <a:bodyPr rtlCol="0" anchor="ctr"/>
+          <a:lstStyle/>
+          <a:p>
+            <a:pPr algn="ctr"/>
+          </a:p>
+        </p:txBody>
+      </p:sp>
+      <p:sp>
+        <p:nvSpPr>
+          <p:cNvPr id="51" name="TextBox 50"/>
+          <p:cNvSpPr txBox="1"/>
+          <p:nvPr/>
+        </p:nvSpPr>
+        <p:spPr>
+          <a:xfrm>
+            <a:off x="749808" y="4535424"/>
+            <a:ext cx="10515600" cy="201168"/>
+          </a:xfrm>
+          <a:prstGeom prst="rect">
+            <a:avLst/>
+          </a:prstGeom>
+          <a:noFill/>
+        </p:spPr>
+        <p:txBody>
+          <a:bodyPr wrap="square" anchor="t"/>
+          <a:lstStyle/>
+          <a:p>
+            <a:pPr algn="l"/>
+            <a:r>
+              <a:rPr sz="1000" b="1" i="0">
+                <a:solidFill>
+                  <a:srgbClr val="0A6B63"/>
+                </a:solidFill>
+                <a:latin typeface="Segoe UI"/>
+              </a:rPr>
+              <a:t>PROFITABILITY</a:t>
+            </a:r>
+          </a:p>
+        </p:txBody>
+      </p:sp>
+      <p:sp>
+        <p:nvSpPr>
+          <p:cNvPr id="52" name="Rectangle 51"/>
+          <p:cNvSpPr/>
+          <p:nvPr/>
+        </p:nvSpPr>
+        <p:spPr>
+          <a:xfrm>
+            <a:off x="576072" y="4754880"/>
+            <a:ext cx="11036808" cy="292608"/>
+          </a:xfrm>
+          <a:prstGeom prst="rect">
+            <a:avLst/>
+          </a:prstGeom>
+          <a:solidFill>
+            <a:srgbClr val="EEF3F8"/>
+          </a:solidFill>
+          <a:ln>
+            <a:noFill/>
+          </a:ln>
+        </p:spPr>
+        <p:style>
+          <a:lnRef idx="1">
+            <a:schemeClr val="accent1"/>
+          </a:lnRef>
+          <a:fillRef idx="3">
+            <a:schemeClr val="accent1"/>
+          </a:fillRef>
+          <a:effectRef idx="2">
+            <a:schemeClr val="accent1"/>
+          </a:effectRef>
+          <a:fontRef idx="minor">
+            <a:schemeClr val="lt1"/>
+          </a:fontRef>
+        </p:style>
+        <p:txBody>
+          <a:bodyPr rtlCol="0" anchor="ctr"/>
+          <a:lstStyle/>
+          <a:p>
+            <a:pPr algn="ctr"/>
+          </a:p>
+        </p:txBody>
+      </p:sp>
+      <p:sp>
+        <p:nvSpPr>
+          <p:cNvPr id="53" name="TextBox 52"/>
+          <p:cNvSpPr txBox="1"/>
+          <p:nvPr/>
+        </p:nvSpPr>
+        <p:spPr>
+          <a:xfrm>
+            <a:off x="749808" y="4764024"/>
+            <a:ext cx="3383280" cy="274320"/>
+          </a:xfrm>
+          <a:prstGeom prst="rect">
+            <a:avLst/>
+          </a:prstGeom>
+          <a:noFill/>
+        </p:spPr>
+        <p:txBody>
+          <a:bodyPr wrap="square" anchor="t"/>
+          <a:lstStyle/>
+          <a:p>
+            <a:pPr algn="l"/>
+            <a:r>
+              <a:rPr sz="1300" b="1" i="0">
+                <a:solidFill>
+                  <a:srgbClr val="0B1F33"/>
+                </a:solidFill>
+                <a:latin typeface="Segoe UI"/>
+              </a:rPr>
+              <a:t>Total revenue</a:t>
+            </a:r>
+          </a:p>
+        </p:txBody>
+      </p:sp>
+      <p:sp>
+        <p:nvSpPr>
+          <p:cNvPr id="54" name="TextBox 53"/>
+          <p:cNvSpPr txBox="1"/>
+          <p:nvPr/>
+        </p:nvSpPr>
+        <p:spPr>
+          <a:xfrm>
+            <a:off x="4297680" y="4754880"/>
+            <a:ext cx="2377440" cy="292608"/>
+          </a:xfrm>
+          <a:prstGeom prst="rect">
+            <a:avLst/>
+          </a:prstGeom>
+          <a:noFill/>
+        </p:spPr>
+        <p:txBody>
+          <a:bodyPr wrap="square" anchor="t"/>
+          <a:lstStyle/>
+          <a:p>
+            <a:pPr algn="ctr"/>
+            <a:r>
+              <a:rPr sz="1600" b="1" i="0">
+                <a:solidFill>
+                  <a:srgbClr val="0A6B63"/>
+                </a:solidFill>
+                <a:latin typeface="Georgia"/>
+              </a:rPr>
+              <a:t>x</a:t>
+            </a:r>
+          </a:p>
+        </p:txBody>
+      </p:sp>
+      <p:sp>
+        <p:nvSpPr>
+          <p:cNvPr id="55" name="TextBox 54"/>
+          <p:cNvSpPr txBox="1"/>
+          <p:nvPr/>
+        </p:nvSpPr>
+        <p:spPr>
+          <a:xfrm>
+            <a:off x="6903720" y="4754880"/>
+            <a:ext cx="2377440" cy="292608"/>
+          </a:xfrm>
+          <a:prstGeom prst="rect">
+            <a:avLst/>
+          </a:prstGeom>
+          <a:noFill/>
+        </p:spPr>
+        <p:txBody>
+          <a:bodyPr wrap="square" anchor="t"/>
+          <a:lstStyle/>
+          <a:p>
+            <a:pPr algn="ctr"/>
+            <a:r>
+              <a:rPr sz="1600" b="1" i="0">
+                <a:solidFill>
+                  <a:srgbClr val="0A6B63"/>
+                </a:solidFill>
+                <a:latin typeface="Georgia"/>
+              </a:rPr>
+              <a:t>x</a:t>
+            </a:r>
+          </a:p>
+        </p:txBody>
+      </p:sp>
+      <p:sp>
+        <p:nvSpPr>
+          <p:cNvPr id="56" name="TextBox 55"/>
+          <p:cNvSpPr txBox="1"/>
+          <p:nvPr/>
+        </p:nvSpPr>
+        <p:spPr>
+          <a:xfrm>
+            <a:off x="9509760" y="4754880"/>
+            <a:ext cx="2377440" cy="292608"/>
+          </a:xfrm>
+          <a:prstGeom prst="rect">
+            <a:avLst/>
+          </a:prstGeom>
+          <a:noFill/>
+        </p:spPr>
+        <p:txBody>
+          <a:bodyPr wrap="square" anchor="t"/>
+          <a:lstStyle/>
+          <a:p>
+            <a:pPr algn="ctr"/>
+            <a:r>
+              <a:rPr sz="1600" b="1" i="0">
+                <a:solidFill>
+                  <a:srgbClr val="0A6B63"/>
+                </a:solidFill>
+                <a:latin typeface="Georgia"/>
+              </a:rPr>
+              <a:t>x</a:t>
+            </a:r>
+          </a:p>
+        </p:txBody>
+      </p:sp>
+      <p:sp>
+        <p:nvSpPr>
+          <p:cNvPr id="57" name="Rectangle 56"/>
+          <p:cNvSpPr/>
+          <p:nvPr/>
+        </p:nvSpPr>
+        <p:spPr>
+          <a:xfrm>
+            <a:off x="576072" y="5047488"/>
+            <a:ext cx="11036808" cy="292608"/>
+          </a:xfrm>
+          <a:prstGeom prst="rect">
+            <a:avLst/>
+          </a:prstGeom>
+          <a:solidFill>
+            <a:srgbClr val="EEF3F8"/>
+          </a:solidFill>
+          <a:ln>
+            <a:noFill/>
+          </a:ln>
+        </p:spPr>
+        <p:style>
+          <a:lnRef idx="1">
+            <a:schemeClr val="accent1"/>
+          </a:lnRef>
+          <a:fillRef idx="3">
+            <a:schemeClr val="accent1"/>
+          </a:fillRef>
+          <a:effectRef idx="2">
+            <a:schemeClr val="accent1"/>
+          </a:effectRef>
+          <a:fontRef idx="minor">
+            <a:schemeClr val="lt1"/>
+          </a:fontRef>
+        </p:style>
+        <p:txBody>
+          <a:bodyPr rtlCol="0" anchor="ctr"/>
+          <a:lstStyle/>
+          <a:p>
+            <a:pPr algn="ctr"/>
+          </a:p>
+        </p:txBody>
+      </p:sp>
+      <p:sp>
+        <p:nvSpPr>
+          <p:cNvPr id="58" name="TextBox 57"/>
+          <p:cNvSpPr txBox="1"/>
+          <p:nvPr/>
+        </p:nvSpPr>
+        <p:spPr>
+          <a:xfrm>
+            <a:off x="749808" y="5056632"/>
+            <a:ext cx="3383280" cy="274320"/>
+          </a:xfrm>
+          <a:prstGeom prst="rect">
+            <a:avLst/>
+          </a:prstGeom>
+          <a:noFill/>
+        </p:spPr>
+        <p:txBody>
+          <a:bodyPr wrap="square" anchor="t"/>
+          <a:lstStyle/>
+          <a:p>
+            <a:pPr algn="l"/>
+            <a:r>
+              <a:rPr sz="1300" b="1" i="0">
+                <a:solidFill>
+                  <a:srgbClr val="0B1F33"/>
+                </a:solidFill>
+                <a:latin typeface="Segoe UI"/>
+              </a:rPr>
+              <a:t>Gross profit</a:t>
+            </a:r>
+          </a:p>
+        </p:txBody>
+      </p:sp>
+      <p:sp>
+        <p:nvSpPr>
+          <p:cNvPr id="59" name="TextBox 58"/>
+          <p:cNvSpPr txBox="1"/>
+          <p:nvPr/>
+        </p:nvSpPr>
+        <p:spPr>
+          <a:xfrm>
+            <a:off x="4297680" y="5047488"/>
+            <a:ext cx="2377440" cy="292608"/>
+          </a:xfrm>
+          <a:prstGeom prst="rect">
+            <a:avLst/>
+          </a:prstGeom>
+          <a:noFill/>
+        </p:spPr>
+        <p:txBody>
+          <a:bodyPr wrap="square" anchor="t"/>
+          <a:lstStyle/>
+          <a:p>
+            <a:pPr algn="ctr"/>
+            <a:r>
+              <a:rPr sz="1600" b="1" i="0">
+                <a:solidFill>
+                  <a:srgbClr val="0A6B63"/>
+                </a:solidFill>
+                <a:latin typeface="Georgia"/>
+              </a:rPr>
+              <a:t>x</a:t>
+            </a:r>
+          </a:p>
+        </p:txBody>
+      </p:sp>
+      <p:sp>
+        <p:nvSpPr>
+          <p:cNvPr id="60" name="TextBox 59"/>
+          <p:cNvSpPr txBox="1"/>
+          <p:nvPr/>
+        </p:nvSpPr>
+        <p:spPr>
+          <a:xfrm>
+            <a:off x="6903720" y="5047488"/>
+            <a:ext cx="2377440" cy="292608"/>
+          </a:xfrm>
+          <a:prstGeom prst="rect">
+            <a:avLst/>
+          </a:prstGeom>
+          <a:noFill/>
+        </p:spPr>
+        <p:txBody>
+          <a:bodyPr wrap="square" anchor="t"/>
+          <a:lstStyle/>
+          <a:p>
+            <a:pPr algn="ctr"/>
+            <a:r>
+              <a:rPr sz="1600" b="1" i="0">
+                <a:solidFill>
+                  <a:srgbClr val="0A6B63"/>
+                </a:solidFill>
+                <a:latin typeface="Georgia"/>
+              </a:rPr>
+              <a:t>x</a:t>
+            </a:r>
+          </a:p>
+        </p:txBody>
+      </p:sp>
+      <p:sp>
+        <p:nvSpPr>
+          <p:cNvPr id="61" name="TextBox 60"/>
+          <p:cNvSpPr txBox="1"/>
+          <p:nvPr/>
+        </p:nvSpPr>
+        <p:spPr>
+          <a:xfrm>
+            <a:off x="9509760" y="5047488"/>
+            <a:ext cx="2377440" cy="292608"/>
+          </a:xfrm>
+          <a:prstGeom prst="rect">
+            <a:avLst/>
+          </a:prstGeom>
+          <a:noFill/>
+        </p:spPr>
+        <p:txBody>
+          <a:bodyPr wrap="square" anchor="t"/>
+          <a:lstStyle/>
+          <a:p>
+            <a:pPr algn="ctr"/>
+            <a:r>
+              <a:rPr sz="1600" b="1" i="0">
+                <a:solidFill>
+                  <a:srgbClr val="0A6B63"/>
+                </a:solidFill>
+                <a:latin typeface="Georgia"/>
+              </a:rPr>
+              <a:t>x</a:t>
+            </a:r>
+          </a:p>
+        </p:txBody>
+      </p:sp>
+      <p:sp>
+        <p:nvSpPr>
+          <p:cNvPr id="62" name="Rectangle 61"/>
+          <p:cNvSpPr/>
+          <p:nvPr/>
+        </p:nvSpPr>
+        <p:spPr>
+          <a:xfrm>
+            <a:off x="576072" y="5340096"/>
+            <a:ext cx="11036808" cy="292608"/>
+          </a:xfrm>
+          <a:prstGeom prst="rect">
+            <a:avLst/>
+          </a:prstGeom>
+          <a:solidFill>
+            <a:srgbClr val="EEF3F8"/>
+          </a:solidFill>
+          <a:ln>
+            <a:noFill/>
+          </a:ln>
+        </p:spPr>
+        <p:style>
+          <a:lnRef idx="1">
+            <a:schemeClr val="accent1"/>
+          </a:lnRef>
+          <a:fillRef idx="3">
+            <a:schemeClr val="accent1"/>
+          </a:fillRef>
+          <a:effectRef idx="2">
+            <a:schemeClr val="accent1"/>
+          </a:effectRef>
+          <a:fontRef idx="minor">
+            <a:schemeClr val="lt1"/>
+          </a:fontRef>
+        </p:style>
+        <p:txBody>
+          <a:bodyPr rtlCol="0" anchor="ctr"/>
+          <a:lstStyle/>
+          <a:p>
+            <a:pPr algn="ctr"/>
+          </a:p>
+        </p:txBody>
+      </p:sp>
+      <p:sp>
+        <p:nvSpPr>
+          <p:cNvPr id="63" name="TextBox 62"/>
+          <p:cNvSpPr txBox="1"/>
+          <p:nvPr/>
+        </p:nvSpPr>
+        <p:spPr>
+          <a:xfrm>
+            <a:off x="749808" y="5349240"/>
+            <a:ext cx="3383280" cy="274320"/>
+          </a:xfrm>
+          <a:prstGeom prst="rect">
+            <a:avLst/>
+          </a:prstGeom>
+          <a:noFill/>
+        </p:spPr>
+        <p:txBody>
+          <a:bodyPr wrap="square" anchor="t"/>
+          <a:lstStyle/>
+          <a:p>
+            <a:pPr algn="l"/>
+            <a:r>
+              <a:rPr sz="1300" b="1" i="0">
+                <a:solidFill>
+                  <a:srgbClr val="0B1F33"/>
+                </a:solidFill>
+                <a:latin typeface="Segoe UI"/>
+              </a:rPr>
+              <a:t>EBITDA</a:t>
+            </a:r>
+          </a:p>
+        </p:txBody>
+      </p:sp>
+      <p:sp>
+        <p:nvSpPr>
+          <p:cNvPr id="64" name="TextBox 63"/>
+          <p:cNvSpPr txBox="1"/>
+          <p:nvPr/>
+        </p:nvSpPr>
+        <p:spPr>
+          <a:xfrm>
+            <a:off x="4297680" y="5340096"/>
+            <a:ext cx="2377440" cy="292608"/>
+          </a:xfrm>
+          <a:prstGeom prst="rect">
+            <a:avLst/>
+          </a:prstGeom>
+          <a:noFill/>
+        </p:spPr>
+        <p:txBody>
+          <a:bodyPr wrap="square" anchor="t"/>
+          <a:lstStyle/>
+          <a:p>
+            <a:pPr algn="ctr"/>
+            <a:r>
+              <a:rPr sz="1600" b="1" i="0">
+                <a:solidFill>
+                  <a:srgbClr val="0A6B63"/>
+                </a:solidFill>
+                <a:latin typeface="Georgia"/>
+              </a:rPr>
+              <a:t>x</a:t>
+            </a:r>
+          </a:p>
+        </p:txBody>
+      </p:sp>
+      <p:sp>
+        <p:nvSpPr>
+          <p:cNvPr id="65" name="TextBox 64"/>
+          <p:cNvSpPr txBox="1"/>
+          <p:nvPr/>
+        </p:nvSpPr>
+        <p:spPr>
+          <a:xfrm>
+            <a:off x="6903720" y="5340096"/>
+            <a:ext cx="2377440" cy="292608"/>
+          </a:xfrm>
+          <a:prstGeom prst="rect">
+            <a:avLst/>
+          </a:prstGeom>
+          <a:noFill/>
+        </p:spPr>
+        <p:txBody>
+          <a:bodyPr wrap="square" anchor="t"/>
+          <a:lstStyle/>
+          <a:p>
+            <a:pPr algn="ctr"/>
+            <a:r>
+              <a:rPr sz="1600" b="1" i="0">
+                <a:solidFill>
+                  <a:srgbClr val="0A6B63"/>
+                </a:solidFill>
+                <a:latin typeface="Georgia"/>
+              </a:rPr>
+              <a:t>x</a:t>
+            </a:r>
+          </a:p>
+        </p:txBody>
+      </p:sp>
+      <p:sp>
+        <p:nvSpPr>
+          <p:cNvPr id="66" name="TextBox 65"/>
+          <p:cNvSpPr txBox="1"/>
+          <p:nvPr/>
+        </p:nvSpPr>
+        <p:spPr>
+          <a:xfrm>
+            <a:off x="9509760" y="5340096"/>
+            <a:ext cx="2377440" cy="292608"/>
+          </a:xfrm>
+          <a:prstGeom prst="rect">
+            <a:avLst/>
+          </a:prstGeom>
+          <a:noFill/>
+        </p:spPr>
+        <p:txBody>
+          <a:bodyPr wrap="square" anchor="t"/>
+          <a:lstStyle/>
+          <a:p>
+            <a:pPr algn="ctr"/>
+            <a:r>
+              <a:rPr sz="1600" b="1" i="0">
+                <a:solidFill>
+                  <a:srgbClr val="0A6B63"/>
+                </a:solidFill>
+                <a:latin typeface="Georgia"/>
+              </a:rPr>
+              <a:t>x</a:t>
+            </a:r>
+          </a:p>
+        </p:txBody>
+      </p:sp>
+      <p:sp>
+        <p:nvSpPr>
+          <p:cNvPr id="67" name="TextBox 66"/>
+          <p:cNvSpPr txBox="1"/>
+          <p:nvPr/>
+        </p:nvSpPr>
+        <p:spPr>
+          <a:xfrm>
+            <a:off x="749808" y="5833872"/>
+            <a:ext cx="10515600" cy="274320"/>
+          </a:xfrm>
+          <a:prstGeom prst="rect">
+            <a:avLst/>
+          </a:prstGeom>
+          <a:noFill/>
+        </p:spPr>
+        <p:txBody>
+          <a:bodyPr wrap="square" anchor="t"/>
+          <a:lstStyle/>
+          <a:p>
+            <a:pPr algn="l"/>
+            <a:r>
+              <a:rPr sz="1100" b="0" i="0">
+                <a:solidFill>
+                  <a:srgbClr val="5E6E80"/>
+                </a:solidFill>
+                <a:latin typeface="Segoe UI"/>
+              </a:rPr>
+              <a:t>Confidential discussion framework. Year 1 is the first 12 months post-financing. Figures to be completed in diligence.</a:t>
+            </a:r>
+          </a:p>
+        </p:txBody>
+      </p:sp>
+      <p:sp>
+        <p:nvSpPr>
+          <p:cNvPr id="68" name="Rectangle 67"/>
+          <p:cNvSpPr/>
+          <p:nvPr/>
+        </p:nvSpPr>
+        <p:spPr>
+          <a:xfrm>
+            <a:off x="0" y="0"/>
+            <a:ext cx="12191695" cy="73152"/>
+          </a:xfrm>
+          <a:prstGeom prst="rect">
+            <a:avLst/>
+          </a:prstGeom>
+          <a:solidFill>
+            <a:srgbClr val="0A6B63"/>
+          </a:solidFill>
+          <a:ln>
+            <a:noFill/>
+          </a:ln>
+        </p:spPr>
+        <p:style>
+          <a:lnRef idx="1">
+            <a:schemeClr val="accent1"/>
+          </a:lnRef>
+          <a:fillRef idx="3">
+            <a:schemeClr val="accent1"/>
+          </a:fillRef>
+          <a:effectRef idx="2">
+            <a:schemeClr val="accent1"/>
+          </a:effectRef>
+          <a:fontRef idx="minor">
+            <a:schemeClr val="lt1"/>
+          </a:fontRef>
+        </p:style>
+        <p:txBody>
+          <a:bodyPr rtlCol="0" anchor="ctr"/>
+          <a:lstStyle/>
+          <a:p>
+            <a:pPr algn="ctr"/>
+          </a:p>
+        </p:txBody>
+      </p:sp>
+      <p:sp>
+        <p:nvSpPr>
+          <p:cNvPr id="69" name="Rectangle 68"/>
+          <p:cNvSpPr/>
+          <p:nvPr/>
+        </p:nvSpPr>
+        <p:spPr>
+          <a:xfrm>
+            <a:off x="0" y="6473952"/>
+            <a:ext cx="12191695" cy="384048"/>
+          </a:xfrm>
+          <a:prstGeom prst="rect">
+            <a:avLst/>
+          </a:prstGeom>
+          <a:solidFill>
+            <a:srgbClr val="F5F8FB"/>
+          </a:solidFill>
+          <a:ln>
+            <a:noFill/>
+          </a:ln>
+        </p:spPr>
+        <p:style>
+          <a:lnRef idx="1">
+            <a:schemeClr val="accent1"/>
+          </a:lnRef>
+          <a:fillRef idx="3">
+            <a:schemeClr val="accent1"/>
+          </a:fillRef>
+          <a:effectRef idx="2">
+            <a:schemeClr val="accent1"/>
+          </a:effectRef>
+          <a:fontRef idx="minor">
+            <a:schemeClr val="lt1"/>
+          </a:fontRef>
+        </p:style>
+        <p:txBody>
+          <a:bodyPr rtlCol="0" anchor="ctr"/>
+          <a:lstStyle/>
+          <a:p>
+            <a:pPr algn="ctr"/>
+          </a:p>
+        </p:txBody>
+      </p:sp>
+      <p:sp>
+        <p:nvSpPr>
+          <p:cNvPr id="70" name="Rectangle 69"/>
+          <p:cNvSpPr/>
+          <p:nvPr/>
+        </p:nvSpPr>
+        <p:spPr>
+          <a:xfrm>
+            <a:off x="0" y="6473952"/>
+            <a:ext cx="12191695" cy="9144"/>
+          </a:xfrm>
+          <a:prstGeom prst="rect">
+            <a:avLst/>
+          </a:prstGeom>
+          <a:solidFill>
+            <a:srgbClr val="D4DEE8"/>
+          </a:solidFill>
+          <a:ln>
+            <a:noFill/>
+          </a:ln>
+        </p:spPr>
+        <p:style>
+          <a:lnRef idx="1">
+            <a:schemeClr val="accent1"/>
+          </a:lnRef>
+          <a:fillRef idx="3">
+            <a:schemeClr val="accent1"/>
+          </a:fillRef>
+          <a:effectRef idx="2">
+            <a:schemeClr val="accent1"/>
+          </a:effectRef>
+          <a:fontRef idx="minor">
+            <a:schemeClr val="lt1"/>
+          </a:fontRef>
+        </p:style>
+        <p:txBody>
+          <a:bodyPr rtlCol="0" anchor="ctr"/>
+          <a:lstStyle/>
+          <a:p>
+            <a:pPr algn="ctr"/>
+          </a:p>
+        </p:txBody>
+      </p:sp>
+      <p:sp>
+        <p:nvSpPr>
+          <p:cNvPr id="71" name="TextBox 70"/>
           <p:cNvSpPr txBox="1"/>
           <p:nvPr/>
         </p:nvSpPr>
@@ -25476,7 +26518,7 @@
       </p:sp>
       <p:sp>
         <p:nvSpPr>
-          <p:cNvPr id="10" name="TextBox 9"/>
+          <p:cNvPr id="72" name="TextBox 71"/>
           <p:cNvSpPr txBox="1"/>
           <p:nvPr/>
         </p:nvSpPr>
@@ -33842,7 +34884,7 @@
                 </a:solidFill>
                 <a:latin typeface="Georgia"/>
               </a:rPr>
-              <a:t>RMB 6.2M</a:t>
+              <a:t>RMB  x</a:t>
             </a:r>
           </a:p>
         </p:txBody>
@@ -33875,7 +34917,7 @@
                 </a:solidFill>
                 <a:latin typeface="Segoe UI"/>
               </a:rPr>
-              <a:t>≈ US$0.9M</a:t>
+              <a:t>≈  US$  x</a:t>
             </a:r>
           </a:p>
         </p:txBody>
@@ -33941,7 +34983,7 @@
                 </a:solidFill>
                 <a:latin typeface="Georgia"/>
               </a:rPr>
-              <a:t>RMB 25.9M</a:t>
+              <a:t>RMB  x</a:t>
             </a:r>
           </a:p>
         </p:txBody>
@@ -33974,7 +35016,7 @@
                 </a:solidFill>
                 <a:latin typeface="Segoe UI"/>
               </a:rPr>
-              <a:t>≈ US$3.8M</a:t>
+              <a:t>≈  US$  x</a:t>
             </a:r>
           </a:p>
         </p:txBody>
@@ -34040,7 +35082,7 @@
                 </a:solidFill>
                 <a:latin typeface="Georgia"/>
               </a:rPr>
-              <a:t>RMB 74.5M</a:t>
+              <a:t>RMB  x</a:t>
             </a:r>
           </a:p>
         </p:txBody>
@@ -34073,7 +35115,7 @@
                 </a:solidFill>
                 <a:latin typeface="Segoe UI"/>
               </a:rPr>
-              <a:t>≈ US$11.1M</a:t>
+              <a:t>≈  US$  x</a:t>
             </a:r>
           </a:p>
         </p:txBody>
@@ -34106,7 +35148,7 @@
                 </a:solidFill>
                 <a:latin typeface="Segoe UI"/>
               </a:rPr>
-              <a:t>Logic: global job seekers → addressable AI Resume users → paid conversion → stacked revenue (AI + services + commission + B2B + ads).  USD at an illustrative RMB 6.73 / US$1. Figures labeled illustrative are management projections, not forecasts.</a:t>
+              <a:t>Logic: global job seekers → addressable AI Resume users → paid conversion → stacked revenue (AI + services + commission + B2B + ads). Revenue figures to be completed.</a:t>
             </a:r>
           </a:p>
         </p:txBody>

</xml_diff>

<commit_message>
Tighten solution and vision slides to use remaining canvas
Co-authored-by: anthonyleedu <anthonyleedu@users.noreply.github.com>
</commit_message>
<xml_diff>
--- a/51Careers_Addition.pptx
+++ b/51Careers_Addition.pptx
@@ -30488,7 +30488,7 @@
         </p:nvSpPr>
         <p:spPr>
           <a:xfrm>
-            <a:off x="822960" y="5029200"/>
+            <a:off x="822960" y="4983480"/>
             <a:ext cx="10515600" cy="457200"/>
           </a:xfrm>
           <a:prstGeom prst="rect">
@@ -30515,13 +30515,89 @@
       </p:sp>
       <p:sp>
         <p:nvSpPr>
-          <p:cNvPr id="9" name="TextBox 8"/>
-          <p:cNvSpPr txBox="1"/>
-          <p:nvPr/>
-        </p:nvSpPr>
-        <p:spPr>
-          <a:xfrm>
-            <a:off x="822960" y="6126480"/>
+          <p:cNvPr id="9" name="Rectangle 8"/>
+          <p:cNvSpPr/>
+          <p:nvPr/>
+        </p:nvSpPr>
+        <p:spPr>
+          <a:xfrm>
+            <a:off x="0" y="5806440"/>
+            <a:ext cx="12191695" cy="1051560"/>
+          </a:xfrm>
+          <a:prstGeom prst="rect">
+            <a:avLst/>
+          </a:prstGeom>
+          <a:solidFill>
+            <a:srgbClr val="081828"/>
+          </a:solidFill>
+          <a:ln>
+            <a:noFill/>
+          </a:ln>
+        </p:spPr>
+        <p:style>
+          <a:lnRef idx="1">
+            <a:schemeClr val="accent1"/>
+          </a:lnRef>
+          <a:fillRef idx="3">
+            <a:schemeClr val="accent1"/>
+          </a:fillRef>
+          <a:effectRef idx="2">
+            <a:schemeClr val="accent1"/>
+          </a:effectRef>
+          <a:fontRef idx="minor">
+            <a:schemeClr val="lt1"/>
+          </a:fontRef>
+        </p:style>
+        <p:txBody>
+          <a:bodyPr rtlCol="0" anchor="ctr"/>
+          <a:lstStyle/>
+          <a:p>
+            <a:pPr algn="ctr"/>
+          </a:p>
+        </p:txBody>
+      </p:sp>
+      <p:sp>
+        <p:nvSpPr>
+          <p:cNvPr id="10" name="TextBox 9"/>
+          <p:cNvSpPr txBox="1"/>
+          <p:nvPr/>
+        </p:nvSpPr>
+        <p:spPr>
+          <a:xfrm>
+            <a:off x="822960" y="6016752"/>
+            <a:ext cx="10515600" cy="292608"/>
+          </a:xfrm>
+          <a:prstGeom prst="rect">
+            <a:avLst/>
+          </a:prstGeom>
+          <a:noFill/>
+        </p:spPr>
+        <p:txBody>
+          <a:bodyPr wrap="square" anchor="t"/>
+          <a:lstStyle/>
+          <a:p>
+            <a:pPr algn="l"/>
+            <a:r>
+              <a:rPr sz="1400" b="1" i="0">
+                <a:solidFill>
+                  <a:srgbClr val="D7EBE8"/>
+                </a:solidFill>
+                <a:latin typeface="Segoe UI"/>
+              </a:rPr>
+              <a:t>CHINA R&amp;D   ·   U.S. COMMERCIALIZATION   ·   GLOBAL DISTRIBUTION</a:t>
+            </a:r>
+          </a:p>
+        </p:txBody>
+      </p:sp>
+      <p:sp>
+        <p:nvSpPr>
+          <p:cNvPr id="11" name="TextBox 10"/>
+          <p:cNvSpPr txBox="1"/>
+          <p:nvPr/>
+        </p:nvSpPr>
+        <p:spPr>
+          <a:xfrm>
+            <a:off x="822960" y="6355080"/>
             <a:ext cx="10515600" cy="292608"/>
           </a:xfrm>
           <a:prstGeom prst="rect">
@@ -35439,7 +35515,7 @@
         <p:spPr>
           <a:xfrm>
             <a:off x="502920" y="1115568"/>
-            <a:ext cx="6949440" cy="548640"/>
+            <a:ext cx="6949440" cy="658368"/>
           </a:xfrm>
           <a:prstGeom prst="roundRect">
             <a:avLst>
@@ -35484,7 +35560,7 @@
         <p:spPr>
           <a:xfrm>
             <a:off x="502920" y="1115568"/>
-            <a:ext cx="73152" cy="548640"/>
+            <a:ext cx="73152" cy="658368"/>
           </a:xfrm>
           <a:prstGeom prst="rect">
             <a:avLst/>
@@ -35526,21 +35602,21 @@
         </p:nvSpPr>
         <p:spPr>
           <a:xfrm>
-            <a:off x="777240" y="1225296"/>
-            <a:ext cx="457200" cy="329184"/>
-          </a:xfrm>
-          <a:prstGeom prst="rect">
-            <a:avLst/>
-          </a:prstGeom>
-          <a:noFill/>
-        </p:spPr>
-        <p:txBody>
-          <a:bodyPr wrap="square" anchor="t"/>
-          <a:lstStyle/>
-          <a:p>
-            <a:pPr algn="l"/>
-            <a:r>
-              <a:rPr sz="1400" b="1" i="0">
+            <a:off x="777240" y="1261872"/>
+            <a:ext cx="457200" cy="384048"/>
+          </a:xfrm>
+          <a:prstGeom prst="rect">
+            <a:avLst/>
+          </a:prstGeom>
+          <a:noFill/>
+        </p:spPr>
+        <p:txBody>
+          <a:bodyPr wrap="square" anchor="t"/>
+          <a:lstStyle/>
+          <a:p>
+            <a:pPr algn="l"/>
+            <a:r>
+              <a:rPr sz="1600" b="1" i="0">
                 <a:solidFill>
                   <a:srgbClr val="0A6B63"/>
                 </a:solidFill>
@@ -35559,21 +35635,21 @@
         </p:nvSpPr>
         <p:spPr>
           <a:xfrm>
-            <a:off x="1325880" y="1225296"/>
-            <a:ext cx="5852160" cy="329184"/>
-          </a:xfrm>
-          <a:prstGeom prst="rect">
-            <a:avLst/>
-          </a:prstGeom>
-          <a:noFill/>
-        </p:spPr>
-        <p:txBody>
-          <a:bodyPr wrap="square" anchor="t"/>
-          <a:lstStyle/>
-          <a:p>
-            <a:pPr algn="l"/>
-            <a:r>
-              <a:rPr sz="1600" b="1" i="0">
+            <a:off x="1325880" y="1261872"/>
+            <a:ext cx="5852160" cy="384048"/>
+          </a:xfrm>
+          <a:prstGeom prst="rect">
+            <a:avLst/>
+          </a:prstGeom>
+          <a:noFill/>
+        </p:spPr>
+        <p:txBody>
+          <a:bodyPr wrap="square" anchor="t"/>
+          <a:lstStyle/>
+          <a:p>
+            <a:pPr algn="l"/>
+            <a:r>
+              <a:rPr sz="1700" b="1" i="0">
                 <a:solidFill>
                   <a:srgbClr val="0B1F33"/>
                 </a:solidFill>
@@ -35592,8 +35668,8 @@
         </p:nvSpPr>
         <p:spPr>
           <a:xfrm>
-            <a:off x="502920" y="1737360"/>
-            <a:ext cx="6949440" cy="548640"/>
+            <a:off x="502920" y="1828800"/>
+            <a:ext cx="6949440" cy="658368"/>
           </a:xfrm>
           <a:prstGeom prst="roundRect">
             <a:avLst>
@@ -35637,8 +35713,8 @@
         </p:nvSpPr>
         <p:spPr>
           <a:xfrm>
-            <a:off x="502920" y="1737360"/>
-            <a:ext cx="73152" cy="548640"/>
+            <a:off x="502920" y="1828800"/>
+            <a:ext cx="73152" cy="658368"/>
           </a:xfrm>
           <a:prstGeom prst="rect">
             <a:avLst/>
@@ -35680,21 +35756,21 @@
         </p:nvSpPr>
         <p:spPr>
           <a:xfrm>
-            <a:off x="777240" y="1847088"/>
-            <a:ext cx="457200" cy="329184"/>
-          </a:xfrm>
-          <a:prstGeom prst="rect">
-            <a:avLst/>
-          </a:prstGeom>
-          <a:noFill/>
-        </p:spPr>
-        <p:txBody>
-          <a:bodyPr wrap="square" anchor="t"/>
-          <a:lstStyle/>
-          <a:p>
-            <a:pPr algn="l"/>
-            <a:r>
-              <a:rPr sz="1400" b="1" i="0">
+            <a:off x="777240" y="1975104"/>
+            <a:ext cx="457200" cy="384048"/>
+          </a:xfrm>
+          <a:prstGeom prst="rect">
+            <a:avLst/>
+          </a:prstGeom>
+          <a:noFill/>
+        </p:spPr>
+        <p:txBody>
+          <a:bodyPr wrap="square" anchor="t"/>
+          <a:lstStyle/>
+          <a:p>
+            <a:pPr algn="l"/>
+            <a:r>
+              <a:rPr sz="1600" b="1" i="0">
                 <a:solidFill>
                   <a:srgbClr val="0A6B63"/>
                 </a:solidFill>
@@ -35713,21 +35789,21 @@
         </p:nvSpPr>
         <p:spPr>
           <a:xfrm>
-            <a:off x="1325880" y="1847088"/>
-            <a:ext cx="5852160" cy="329184"/>
-          </a:xfrm>
-          <a:prstGeom prst="rect">
-            <a:avLst/>
-          </a:prstGeom>
-          <a:noFill/>
-        </p:spPr>
-        <p:txBody>
-          <a:bodyPr wrap="square" anchor="t"/>
-          <a:lstStyle/>
-          <a:p>
-            <a:pPr algn="l"/>
-            <a:r>
-              <a:rPr sz="1600" b="1" i="0">
+            <a:off x="1325880" y="1975104"/>
+            <a:ext cx="5852160" cy="384048"/>
+          </a:xfrm>
+          <a:prstGeom prst="rect">
+            <a:avLst/>
+          </a:prstGeom>
+          <a:noFill/>
+        </p:spPr>
+        <p:txBody>
+          <a:bodyPr wrap="square" anchor="t"/>
+          <a:lstStyle/>
+          <a:p>
+            <a:pPr algn="l"/>
+            <a:r>
+              <a:rPr sz="1700" b="1" i="0">
                 <a:solidFill>
                   <a:srgbClr val="0B1F33"/>
                 </a:solidFill>
@@ -35746,8 +35822,8 @@
         </p:nvSpPr>
         <p:spPr>
           <a:xfrm>
-            <a:off x="502920" y="2359152"/>
-            <a:ext cx="6949440" cy="548640"/>
+            <a:off x="502920" y="2542032"/>
+            <a:ext cx="6949440" cy="658368"/>
           </a:xfrm>
           <a:prstGeom prst="roundRect">
             <a:avLst>
@@ -35791,8 +35867,8 @@
         </p:nvSpPr>
         <p:spPr>
           <a:xfrm>
-            <a:off x="502920" y="2359152"/>
-            <a:ext cx="73152" cy="548640"/>
+            <a:off x="502920" y="2542032"/>
+            <a:ext cx="73152" cy="658368"/>
           </a:xfrm>
           <a:prstGeom prst="rect">
             <a:avLst/>
@@ -35834,21 +35910,21 @@
         </p:nvSpPr>
         <p:spPr>
           <a:xfrm>
-            <a:off x="777240" y="2468880"/>
-            <a:ext cx="457200" cy="329184"/>
-          </a:xfrm>
-          <a:prstGeom prst="rect">
-            <a:avLst/>
-          </a:prstGeom>
-          <a:noFill/>
-        </p:spPr>
-        <p:txBody>
-          <a:bodyPr wrap="square" anchor="t"/>
-          <a:lstStyle/>
-          <a:p>
-            <a:pPr algn="l"/>
-            <a:r>
-              <a:rPr sz="1400" b="1" i="0">
+            <a:off x="777240" y="2688336"/>
+            <a:ext cx="457200" cy="384048"/>
+          </a:xfrm>
+          <a:prstGeom prst="rect">
+            <a:avLst/>
+          </a:prstGeom>
+          <a:noFill/>
+        </p:spPr>
+        <p:txBody>
+          <a:bodyPr wrap="square" anchor="t"/>
+          <a:lstStyle/>
+          <a:p>
+            <a:pPr algn="l"/>
+            <a:r>
+              <a:rPr sz="1600" b="1" i="0">
                 <a:solidFill>
                   <a:srgbClr val="0A6B63"/>
                 </a:solidFill>
@@ -35867,21 +35943,21 @@
         </p:nvSpPr>
         <p:spPr>
           <a:xfrm>
-            <a:off x="1325880" y="2468880"/>
-            <a:ext cx="5852160" cy="329184"/>
-          </a:xfrm>
-          <a:prstGeom prst="rect">
-            <a:avLst/>
-          </a:prstGeom>
-          <a:noFill/>
-        </p:spPr>
-        <p:txBody>
-          <a:bodyPr wrap="square" anchor="t"/>
-          <a:lstStyle/>
-          <a:p>
-            <a:pPr algn="l"/>
-            <a:r>
-              <a:rPr sz="1600" b="1" i="0">
+            <a:off x="1325880" y="2688336"/>
+            <a:ext cx="5852160" cy="384048"/>
+          </a:xfrm>
+          <a:prstGeom prst="rect">
+            <a:avLst/>
+          </a:prstGeom>
+          <a:noFill/>
+        </p:spPr>
+        <p:txBody>
+          <a:bodyPr wrap="square" anchor="t"/>
+          <a:lstStyle/>
+          <a:p>
+            <a:pPr algn="l"/>
+            <a:r>
+              <a:rPr sz="1700" b="1" i="0">
                 <a:solidFill>
                   <a:srgbClr val="0B1F33"/>
                 </a:solidFill>
@@ -35900,8 +35976,8 @@
         </p:nvSpPr>
         <p:spPr>
           <a:xfrm>
-            <a:off x="502920" y="2980944"/>
-            <a:ext cx="6949440" cy="548640"/>
+            <a:off x="502920" y="3255264"/>
+            <a:ext cx="6949440" cy="658368"/>
           </a:xfrm>
           <a:prstGeom prst="roundRect">
             <a:avLst>
@@ -35945,8 +36021,8 @@
         </p:nvSpPr>
         <p:spPr>
           <a:xfrm>
-            <a:off x="502920" y="2980944"/>
-            <a:ext cx="73152" cy="548640"/>
+            <a:off x="502920" y="3255264"/>
+            <a:ext cx="73152" cy="658368"/>
           </a:xfrm>
           <a:prstGeom prst="rect">
             <a:avLst/>
@@ -35988,21 +36064,21 @@
         </p:nvSpPr>
         <p:spPr>
           <a:xfrm>
-            <a:off x="777240" y="3090672"/>
-            <a:ext cx="457200" cy="329184"/>
-          </a:xfrm>
-          <a:prstGeom prst="rect">
-            <a:avLst/>
-          </a:prstGeom>
-          <a:noFill/>
-        </p:spPr>
-        <p:txBody>
-          <a:bodyPr wrap="square" anchor="t"/>
-          <a:lstStyle/>
-          <a:p>
-            <a:pPr algn="l"/>
-            <a:r>
-              <a:rPr sz="1400" b="1" i="0">
+            <a:off x="777240" y="3401568"/>
+            <a:ext cx="457200" cy="384048"/>
+          </a:xfrm>
+          <a:prstGeom prst="rect">
+            <a:avLst/>
+          </a:prstGeom>
+          <a:noFill/>
+        </p:spPr>
+        <p:txBody>
+          <a:bodyPr wrap="square" anchor="t"/>
+          <a:lstStyle/>
+          <a:p>
+            <a:pPr algn="l"/>
+            <a:r>
+              <a:rPr sz="1600" b="1" i="0">
                 <a:solidFill>
                   <a:srgbClr val="0A6B63"/>
                 </a:solidFill>
@@ -36021,21 +36097,21 @@
         </p:nvSpPr>
         <p:spPr>
           <a:xfrm>
-            <a:off x="1325880" y="3090672"/>
-            <a:ext cx="5852160" cy="329184"/>
-          </a:xfrm>
-          <a:prstGeom prst="rect">
-            <a:avLst/>
-          </a:prstGeom>
-          <a:noFill/>
-        </p:spPr>
-        <p:txBody>
-          <a:bodyPr wrap="square" anchor="t"/>
-          <a:lstStyle/>
-          <a:p>
-            <a:pPr algn="l"/>
-            <a:r>
-              <a:rPr sz="1600" b="1" i="0">
+            <a:off x="1325880" y="3401568"/>
+            <a:ext cx="5852160" cy="384048"/>
+          </a:xfrm>
+          <a:prstGeom prst="rect">
+            <a:avLst/>
+          </a:prstGeom>
+          <a:noFill/>
+        </p:spPr>
+        <p:txBody>
+          <a:bodyPr wrap="square" anchor="t"/>
+          <a:lstStyle/>
+          <a:p>
+            <a:pPr algn="l"/>
+            <a:r>
+              <a:rPr sz="1700" b="1" i="0">
                 <a:solidFill>
                   <a:srgbClr val="0B1F33"/>
                 </a:solidFill>
@@ -36054,8 +36130,8 @@
         </p:nvSpPr>
         <p:spPr>
           <a:xfrm>
-            <a:off x="502920" y="3602736"/>
-            <a:ext cx="6949440" cy="548640"/>
+            <a:off x="502920" y="3968496"/>
+            <a:ext cx="6949440" cy="658368"/>
           </a:xfrm>
           <a:prstGeom prst="roundRect">
             <a:avLst>
@@ -36099,8 +36175,8 @@
         </p:nvSpPr>
         <p:spPr>
           <a:xfrm>
-            <a:off x="502920" y="3602736"/>
-            <a:ext cx="73152" cy="548640"/>
+            <a:off x="502920" y="3968496"/>
+            <a:ext cx="73152" cy="658368"/>
           </a:xfrm>
           <a:prstGeom prst="rect">
             <a:avLst/>
@@ -36142,21 +36218,21 @@
         </p:nvSpPr>
         <p:spPr>
           <a:xfrm>
-            <a:off x="777240" y="3712464"/>
-            <a:ext cx="457200" cy="329184"/>
-          </a:xfrm>
-          <a:prstGeom prst="rect">
-            <a:avLst/>
-          </a:prstGeom>
-          <a:noFill/>
-        </p:spPr>
-        <p:txBody>
-          <a:bodyPr wrap="square" anchor="t"/>
-          <a:lstStyle/>
-          <a:p>
-            <a:pPr algn="l"/>
-            <a:r>
-              <a:rPr sz="1400" b="1" i="0">
+            <a:off x="777240" y="4114800"/>
+            <a:ext cx="457200" cy="384048"/>
+          </a:xfrm>
+          <a:prstGeom prst="rect">
+            <a:avLst/>
+          </a:prstGeom>
+          <a:noFill/>
+        </p:spPr>
+        <p:txBody>
+          <a:bodyPr wrap="square" anchor="t"/>
+          <a:lstStyle/>
+          <a:p>
+            <a:pPr algn="l"/>
+            <a:r>
+              <a:rPr sz="1600" b="1" i="0">
                 <a:solidFill>
                   <a:srgbClr val="0A6B63"/>
                 </a:solidFill>
@@ -36175,21 +36251,21 @@
         </p:nvSpPr>
         <p:spPr>
           <a:xfrm>
-            <a:off x="1325880" y="3712464"/>
-            <a:ext cx="5852160" cy="329184"/>
-          </a:xfrm>
-          <a:prstGeom prst="rect">
-            <a:avLst/>
-          </a:prstGeom>
-          <a:noFill/>
-        </p:spPr>
-        <p:txBody>
-          <a:bodyPr wrap="square" anchor="t"/>
-          <a:lstStyle/>
-          <a:p>
-            <a:pPr algn="l"/>
-            <a:r>
-              <a:rPr sz="1600" b="1" i="0">
+            <a:off x="1325880" y="4114800"/>
+            <a:ext cx="5852160" cy="384048"/>
+          </a:xfrm>
+          <a:prstGeom prst="rect">
+            <a:avLst/>
+          </a:prstGeom>
+          <a:noFill/>
+        </p:spPr>
+        <p:txBody>
+          <a:bodyPr wrap="square" anchor="t"/>
+          <a:lstStyle/>
+          <a:p>
+            <a:pPr algn="l"/>
+            <a:r>
+              <a:rPr sz="1700" b="1" i="0">
                 <a:solidFill>
                   <a:srgbClr val="0B1F33"/>
                 </a:solidFill>
@@ -36208,8 +36284,8 @@
         </p:nvSpPr>
         <p:spPr>
           <a:xfrm>
-            <a:off x="502920" y="4224528"/>
-            <a:ext cx="6949440" cy="548640"/>
+            <a:off x="502920" y="4681728"/>
+            <a:ext cx="6949440" cy="658368"/>
           </a:xfrm>
           <a:prstGeom prst="roundRect">
             <a:avLst>
@@ -36253,8 +36329,8 @@
         </p:nvSpPr>
         <p:spPr>
           <a:xfrm>
-            <a:off x="502920" y="4224528"/>
-            <a:ext cx="73152" cy="548640"/>
+            <a:off x="502920" y="4681728"/>
+            <a:ext cx="73152" cy="658368"/>
           </a:xfrm>
           <a:prstGeom prst="rect">
             <a:avLst/>
@@ -36296,21 +36372,21 @@
         </p:nvSpPr>
         <p:spPr>
           <a:xfrm>
-            <a:off x="777240" y="4334256"/>
-            <a:ext cx="457200" cy="329184"/>
-          </a:xfrm>
-          <a:prstGeom prst="rect">
-            <a:avLst/>
-          </a:prstGeom>
-          <a:noFill/>
-        </p:spPr>
-        <p:txBody>
-          <a:bodyPr wrap="square" anchor="t"/>
-          <a:lstStyle/>
-          <a:p>
-            <a:pPr algn="l"/>
-            <a:r>
-              <a:rPr sz="1400" b="1" i="0">
+            <a:off x="777240" y="4828032"/>
+            <a:ext cx="457200" cy="384048"/>
+          </a:xfrm>
+          <a:prstGeom prst="rect">
+            <a:avLst/>
+          </a:prstGeom>
+          <a:noFill/>
+        </p:spPr>
+        <p:txBody>
+          <a:bodyPr wrap="square" anchor="t"/>
+          <a:lstStyle/>
+          <a:p>
+            <a:pPr algn="l"/>
+            <a:r>
+              <a:rPr sz="1600" b="1" i="0">
                 <a:solidFill>
                   <a:srgbClr val="0A6B63"/>
                 </a:solidFill>
@@ -36329,21 +36405,21 @@
         </p:nvSpPr>
         <p:spPr>
           <a:xfrm>
-            <a:off x="1325880" y="4334256"/>
-            <a:ext cx="5852160" cy="329184"/>
-          </a:xfrm>
-          <a:prstGeom prst="rect">
-            <a:avLst/>
-          </a:prstGeom>
-          <a:noFill/>
-        </p:spPr>
-        <p:txBody>
-          <a:bodyPr wrap="square" anchor="t"/>
-          <a:lstStyle/>
-          <a:p>
-            <a:pPr algn="l"/>
-            <a:r>
-              <a:rPr sz="1600" b="1" i="0">
+            <a:off x="1325880" y="4828032"/>
+            <a:ext cx="5852160" cy="384048"/>
+          </a:xfrm>
+          <a:prstGeom prst="rect">
+            <a:avLst/>
+          </a:prstGeom>
+          <a:noFill/>
+        </p:spPr>
+        <p:txBody>
+          <a:bodyPr wrap="square" anchor="t"/>
+          <a:lstStyle/>
+          <a:p>
+            <a:pPr algn="l"/>
+            <a:r>
+              <a:rPr sz="1700" b="1" i="0">
                 <a:solidFill>
                   <a:srgbClr val="0B1F33"/>
                 </a:solidFill>
@@ -36362,8 +36438,8 @@
         </p:nvSpPr>
         <p:spPr>
           <a:xfrm>
-            <a:off x="502920" y="4846320"/>
-            <a:ext cx="6949440" cy="548640"/>
+            <a:off x="502920" y="5394960"/>
+            <a:ext cx="6949440" cy="658368"/>
           </a:xfrm>
           <a:prstGeom prst="roundRect">
             <a:avLst>
@@ -36407,8 +36483,8 @@
         </p:nvSpPr>
         <p:spPr>
           <a:xfrm>
-            <a:off x="502920" y="4846320"/>
-            <a:ext cx="73152" cy="548640"/>
+            <a:off x="502920" y="5394960"/>
+            <a:ext cx="73152" cy="658368"/>
           </a:xfrm>
           <a:prstGeom prst="rect">
             <a:avLst/>
@@ -36450,21 +36526,21 @@
         </p:nvSpPr>
         <p:spPr>
           <a:xfrm>
-            <a:off x="777240" y="4956048"/>
-            <a:ext cx="457200" cy="329184"/>
-          </a:xfrm>
-          <a:prstGeom prst="rect">
-            <a:avLst/>
-          </a:prstGeom>
-          <a:noFill/>
-        </p:spPr>
-        <p:txBody>
-          <a:bodyPr wrap="square" anchor="t"/>
-          <a:lstStyle/>
-          <a:p>
-            <a:pPr algn="l"/>
-            <a:r>
-              <a:rPr sz="1400" b="1" i="0">
+            <a:off x="777240" y="5541264"/>
+            <a:ext cx="457200" cy="384048"/>
+          </a:xfrm>
+          <a:prstGeom prst="rect">
+            <a:avLst/>
+          </a:prstGeom>
+          <a:noFill/>
+        </p:spPr>
+        <p:txBody>
+          <a:bodyPr wrap="square" anchor="t"/>
+          <a:lstStyle/>
+          <a:p>
+            <a:pPr algn="l"/>
+            <a:r>
+              <a:rPr sz="1600" b="1" i="0">
                 <a:solidFill>
                   <a:srgbClr val="0A6B63"/>
                 </a:solidFill>
@@ -36483,21 +36559,21 @@
         </p:nvSpPr>
         <p:spPr>
           <a:xfrm>
-            <a:off x="1325880" y="4956048"/>
-            <a:ext cx="5852160" cy="329184"/>
-          </a:xfrm>
-          <a:prstGeom prst="rect">
-            <a:avLst/>
-          </a:prstGeom>
-          <a:noFill/>
-        </p:spPr>
-        <p:txBody>
-          <a:bodyPr wrap="square" anchor="t"/>
-          <a:lstStyle/>
-          <a:p>
-            <a:pPr algn="l"/>
-            <a:r>
-              <a:rPr sz="1600" b="1" i="0">
+            <a:off x="1325880" y="5541264"/>
+            <a:ext cx="5852160" cy="384048"/>
+          </a:xfrm>
+          <a:prstGeom prst="rect">
+            <a:avLst/>
+          </a:prstGeom>
+          <a:noFill/>
+        </p:spPr>
+        <p:txBody>
+          <a:bodyPr wrap="square" anchor="t"/>
+          <a:lstStyle/>
+          <a:p>
+            <a:pPr algn="l"/>
+            <a:r>
+              <a:rPr sz="1700" b="1" i="0">
                 <a:solidFill>
                   <a:srgbClr val="0B1F33"/>
                 </a:solidFill>
@@ -36517,7 +36593,7 @@
         <p:spPr>
           <a:xfrm>
             <a:off x="7680960" y="1115568"/>
-            <a:ext cx="4005072" cy="5102352"/>
+            <a:ext cx="4005072" cy="5175504"/>
           </a:xfrm>
           <a:prstGeom prst="roundRect">
             <a:avLst>

</xml_diff>

<commit_message>
Clean slide 6 market-size numbers to match slide 5
Label TAM / SAM / SOM as 01–03, use a consistent US$ / RMB
format in Georgia, and align the 2027E–2029E revenue strip.

Co-authored-by: anthonyleedu <anthonyleedu@users.noreply.github.com>
</commit_message>
<xml_diff>
--- a/51Careers_Addition.pptx
+++ b/51Careers_Addition.pptx
@@ -35196,7 +35196,7 @@
           <a:p>
             <a:pPr algn="l"/>
             <a:r>
-              <a:rPr sz="2000" b="1" i="0">
+              <a:rPr sz="2400" b="1" i="0">
                 <a:solidFill>
                   <a:srgbClr val="0B1F33"/>
                 </a:solidFill>
@@ -35204,7 +35204,7 @@
                 <a:ea typeface="Georgia"/>
                 <a:cs typeface="Georgia"/>
               </a:rPr>
-              <a:t>TAM  →  SAM  →  SOM  →  Three-Year Revenue Opportunity</a:t>
+              <a:t>TAM  →  SAM  →  SOM  →  Three-Year Revenue</a:t>
             </a:r>
           </a:p>
         </p:txBody>
@@ -35340,8 +35340,8 @@
         </p:nvSpPr>
         <p:spPr>
           <a:xfrm>
-            <a:off x="704088" y="1316736"/>
-            <a:ext cx="3182112" cy="237744"/>
+            <a:off x="704088" y="1280160"/>
+            <a:ext cx="3182112" cy="256032"/>
           </a:xfrm>
           <a:prstGeom prst="rect">
             <a:avLst/>
@@ -35357,47 +35357,47 @@
               <a:rPr sz="1300" b="1" i="0">
                 <a:solidFill>
                   <a:srgbClr val="0A6B63"/>
-                </a:solidFill>
-                <a:latin typeface="Segoe UI"/>
-                <a:ea typeface="Segoe UI"/>
-                <a:cs typeface="Segoe UI"/>
-              </a:rPr>
-              <a:t>TAM</a:t>
-            </a:r>
-          </a:p>
-        </p:txBody>
-      </p:sp>
-      <p:sp>
-        <p:nvSpPr>
-          <p:cNvPr id="8" name="TextBox 7"/>
-          <p:cNvSpPr txBox="1"/>
-          <p:nvPr/>
-        </p:nvSpPr>
-        <p:spPr>
-          <a:xfrm>
-            <a:off x="704088" y="1609344"/>
-            <a:ext cx="3182112" cy="530352"/>
-          </a:xfrm>
-          <a:prstGeom prst="rect">
-            <a:avLst/>
-          </a:prstGeom>
-          <a:noFill/>
-        </p:spPr>
-        <p:txBody>
-          <a:bodyPr wrap="square" anchor="t"/>
-          <a:lstStyle/>
-          <a:p>
-            <a:pPr algn="l"/>
-            <a:r>
-              <a:rPr sz="3000" b="1" i="0">
-                <a:solidFill>
-                  <a:srgbClr val="0B1F33"/>
                 </a:solidFill>
                 <a:latin typeface="Georgia"/>
                 <a:ea typeface="Georgia"/>
                 <a:cs typeface="Georgia"/>
               </a:rPr>
-              <a:t>US$200B+</a:t>
+              <a:t>01   ·   TAM</a:t>
+            </a:r>
+          </a:p>
+        </p:txBody>
+      </p:sp>
+      <p:sp>
+        <p:nvSpPr>
+          <p:cNvPr id="8" name="TextBox 7"/>
+          <p:cNvSpPr txBox="1"/>
+          <p:nvPr/>
+        </p:nvSpPr>
+        <p:spPr>
+          <a:xfrm>
+            <a:off x="704088" y="1591056"/>
+            <a:ext cx="3182112" cy="530352"/>
+          </a:xfrm>
+          <a:prstGeom prst="rect">
+            <a:avLst/>
+          </a:prstGeom>
+          <a:noFill/>
+        </p:spPr>
+        <p:txBody>
+          <a:bodyPr wrap="square" anchor="t"/>
+          <a:lstStyle/>
+          <a:p>
+            <a:pPr algn="l"/>
+            <a:r>
+              <a:rPr sz="2800" b="1" i="0">
+                <a:solidFill>
+                  <a:srgbClr val="0B1F33"/>
+                </a:solidFill>
+                <a:latin typeface="Georgia"/>
+                <a:ea typeface="Georgia"/>
+                <a:cs typeface="Georgia"/>
+              </a:rPr>
+              <a:t>US$ 200B+</a:t>
             </a:r>
           </a:p>
         </p:txBody>
@@ -35410,7 +35410,7 @@
         </p:nvSpPr>
         <p:spPr>
           <a:xfrm>
-            <a:off x="704088" y="2176272"/>
+            <a:off x="704088" y="2157984"/>
             <a:ext cx="3182112" cy="274320"/>
           </a:xfrm>
           <a:prstGeom prst="rect">
@@ -35428,11 +35428,11 @@
                 <a:solidFill>
                   <a:srgbClr val="14283C"/>
                 </a:solidFill>
-                <a:latin typeface="Segoe UI"/>
-                <a:ea typeface="Segoe UI"/>
-                <a:cs typeface="Segoe UI"/>
-              </a:rPr>
-              <a:t>RMB 1.35 trillion+</a:t>
+                <a:latin typeface="Georgia"/>
+                <a:ea typeface="Georgia"/>
+                <a:cs typeface="Georgia"/>
+              </a:rPr>
+              <a:t>RMB 1.35T+</a:t>
             </a:r>
           </a:p>
         </p:txBody>
@@ -35445,7 +35445,7 @@
         </p:nvSpPr>
         <p:spPr>
           <a:xfrm>
-            <a:off x="704088" y="2523744"/>
+            <a:off x="704088" y="2505456"/>
             <a:ext cx="3182112" cy="1371600"/>
           </a:xfrm>
           <a:prstGeom prst="rect">
@@ -35568,8 +35568,8 @@
         </p:nvSpPr>
         <p:spPr>
           <a:xfrm>
-            <a:off x="4434840" y="1316736"/>
-            <a:ext cx="3182112" cy="237744"/>
+            <a:off x="4434840" y="1280160"/>
+            <a:ext cx="3182112" cy="256032"/>
           </a:xfrm>
           <a:prstGeom prst="rect">
             <a:avLst/>
@@ -35585,47 +35585,47 @@
               <a:rPr sz="1300" b="1" i="0">
                 <a:solidFill>
                   <a:srgbClr val="0A6B63"/>
-                </a:solidFill>
-                <a:latin typeface="Segoe UI"/>
-                <a:ea typeface="Segoe UI"/>
-                <a:cs typeface="Segoe UI"/>
-              </a:rPr>
-              <a:t>SAM</a:t>
-            </a:r>
-          </a:p>
-        </p:txBody>
-      </p:sp>
-      <p:sp>
-        <p:nvSpPr>
-          <p:cNvPr id="14" name="TextBox 13"/>
-          <p:cNvSpPr txBox="1"/>
-          <p:nvPr/>
-        </p:nvSpPr>
-        <p:spPr>
-          <a:xfrm>
-            <a:off x="4434840" y="1609344"/>
-            <a:ext cx="3182112" cy="530352"/>
-          </a:xfrm>
-          <a:prstGeom prst="rect">
-            <a:avLst/>
-          </a:prstGeom>
-          <a:noFill/>
-        </p:spPr>
-        <p:txBody>
-          <a:bodyPr wrap="square" anchor="t"/>
-          <a:lstStyle/>
-          <a:p>
-            <a:pPr algn="l"/>
-            <a:r>
-              <a:rPr sz="3000" b="1" i="0">
-                <a:solidFill>
-                  <a:srgbClr val="0B1F33"/>
                 </a:solidFill>
                 <a:latin typeface="Georgia"/>
                 <a:ea typeface="Georgia"/>
                 <a:cs typeface="Georgia"/>
               </a:rPr>
-              <a:t>US$30B+</a:t>
+              <a:t>02   ·   SAM</a:t>
+            </a:r>
+          </a:p>
+        </p:txBody>
+      </p:sp>
+      <p:sp>
+        <p:nvSpPr>
+          <p:cNvPr id="14" name="TextBox 13"/>
+          <p:cNvSpPr txBox="1"/>
+          <p:nvPr/>
+        </p:nvSpPr>
+        <p:spPr>
+          <a:xfrm>
+            <a:off x="4434840" y="1591056"/>
+            <a:ext cx="3182112" cy="530352"/>
+          </a:xfrm>
+          <a:prstGeom prst="rect">
+            <a:avLst/>
+          </a:prstGeom>
+          <a:noFill/>
+        </p:spPr>
+        <p:txBody>
+          <a:bodyPr wrap="square" anchor="t"/>
+          <a:lstStyle/>
+          <a:p>
+            <a:pPr algn="l"/>
+            <a:r>
+              <a:rPr sz="2800" b="1" i="0">
+                <a:solidFill>
+                  <a:srgbClr val="0B1F33"/>
+                </a:solidFill>
+                <a:latin typeface="Georgia"/>
+                <a:ea typeface="Georgia"/>
+                <a:cs typeface="Georgia"/>
+              </a:rPr>
+              <a:t>US$ 30B+</a:t>
             </a:r>
           </a:p>
         </p:txBody>
@@ -35638,7 +35638,7 @@
         </p:nvSpPr>
         <p:spPr>
           <a:xfrm>
-            <a:off x="4434840" y="2176272"/>
+            <a:off x="4434840" y="2157984"/>
             <a:ext cx="3182112" cy="274320"/>
           </a:xfrm>
           <a:prstGeom prst="rect">
@@ -35656,11 +35656,11 @@
                 <a:solidFill>
                   <a:srgbClr val="14283C"/>
                 </a:solidFill>
-                <a:latin typeface="Segoe UI"/>
-                <a:ea typeface="Segoe UI"/>
-                <a:cs typeface="Segoe UI"/>
-              </a:rPr>
-              <a:t>RMB 200 billion+</a:t>
+                <a:latin typeface="Georgia"/>
+                <a:ea typeface="Georgia"/>
+                <a:cs typeface="Georgia"/>
+              </a:rPr>
+              <a:t>RMB 200B+</a:t>
             </a:r>
           </a:p>
         </p:txBody>
@@ -35673,7 +35673,7 @@
         </p:nvSpPr>
         <p:spPr>
           <a:xfrm>
-            <a:off x="4434840" y="2523744"/>
+            <a:off x="4434840" y="2505456"/>
             <a:ext cx="3182112" cy="1371600"/>
           </a:xfrm>
           <a:prstGeom prst="rect">
@@ -35796,8 +35796,8 @@
         </p:nvSpPr>
         <p:spPr>
           <a:xfrm>
-            <a:off x="8165592" y="1316736"/>
-            <a:ext cx="3182112" cy="237744"/>
+            <a:off x="8165592" y="1280160"/>
+            <a:ext cx="3182112" cy="256032"/>
           </a:xfrm>
           <a:prstGeom prst="rect">
             <a:avLst/>
@@ -35813,47 +35813,47 @@
               <a:rPr sz="1300" b="1" i="0">
                 <a:solidFill>
                   <a:srgbClr val="0A6B63"/>
-                </a:solidFill>
-                <a:latin typeface="Segoe UI"/>
-                <a:ea typeface="Segoe UI"/>
-                <a:cs typeface="Segoe UI"/>
-              </a:rPr>
-              <a:t>SOM</a:t>
-            </a:r>
-          </a:p>
-        </p:txBody>
-      </p:sp>
-      <p:sp>
-        <p:nvSpPr>
-          <p:cNvPr id="20" name="TextBox 19"/>
-          <p:cNvSpPr txBox="1"/>
-          <p:nvPr/>
-        </p:nvSpPr>
-        <p:spPr>
-          <a:xfrm>
-            <a:off x="8165592" y="1609344"/>
-            <a:ext cx="3182112" cy="530352"/>
-          </a:xfrm>
-          <a:prstGeom prst="rect">
-            <a:avLst/>
-          </a:prstGeom>
-          <a:noFill/>
-        </p:spPr>
-        <p:txBody>
-          <a:bodyPr wrap="square" anchor="t"/>
-          <a:lstStyle/>
-          <a:p>
-            <a:pPr algn="l"/>
-            <a:r>
-              <a:rPr sz="3000" b="1" i="0">
-                <a:solidFill>
-                  <a:srgbClr val="0B1F33"/>
                 </a:solidFill>
                 <a:latin typeface="Georgia"/>
                 <a:ea typeface="Georgia"/>
                 <a:cs typeface="Georgia"/>
               </a:rPr>
-              <a:t>US$1.5B+</a:t>
+              <a:t>03   ·   SOM</a:t>
+            </a:r>
+          </a:p>
+        </p:txBody>
+      </p:sp>
+      <p:sp>
+        <p:nvSpPr>
+          <p:cNvPr id="20" name="TextBox 19"/>
+          <p:cNvSpPr txBox="1"/>
+          <p:nvPr/>
+        </p:nvSpPr>
+        <p:spPr>
+          <a:xfrm>
+            <a:off x="8165592" y="1591056"/>
+            <a:ext cx="3182112" cy="530352"/>
+          </a:xfrm>
+          <a:prstGeom prst="rect">
+            <a:avLst/>
+          </a:prstGeom>
+          <a:noFill/>
+        </p:spPr>
+        <p:txBody>
+          <a:bodyPr wrap="square" anchor="t"/>
+          <a:lstStyle/>
+          <a:p>
+            <a:pPr algn="l"/>
+            <a:r>
+              <a:rPr sz="2800" b="1" i="0">
+                <a:solidFill>
+                  <a:srgbClr val="0B1F33"/>
+                </a:solidFill>
+                <a:latin typeface="Georgia"/>
+                <a:ea typeface="Georgia"/>
+                <a:cs typeface="Georgia"/>
+              </a:rPr>
+              <a:t>US$ 1.5B+</a:t>
             </a:r>
           </a:p>
         </p:txBody>
@@ -35866,7 +35866,7 @@
         </p:nvSpPr>
         <p:spPr>
           <a:xfrm>
-            <a:off x="8165592" y="2176272"/>
+            <a:off x="8165592" y="2157984"/>
             <a:ext cx="3182112" cy="274320"/>
           </a:xfrm>
           <a:prstGeom prst="rect">
@@ -35884,11 +35884,11 @@
                 <a:solidFill>
                   <a:srgbClr val="14283C"/>
                 </a:solidFill>
-                <a:latin typeface="Segoe UI"/>
-                <a:ea typeface="Segoe UI"/>
-                <a:cs typeface="Segoe UI"/>
-              </a:rPr>
-              <a:t>RMB 10 billion+</a:t>
+                <a:latin typeface="Georgia"/>
+                <a:ea typeface="Georgia"/>
+                <a:cs typeface="Georgia"/>
+              </a:rPr>
+              <a:t>RMB 10B+</a:t>
             </a:r>
           </a:p>
         </p:txBody>
@@ -35901,7 +35901,7 @@
         </p:nvSpPr>
         <p:spPr>
           <a:xfrm>
-            <a:off x="8165592" y="2523744"/>
+            <a:off x="8165592" y="2505456"/>
             <a:ext cx="3182112" cy="1371600"/>
           </a:xfrm>
           <a:prstGeom prst="rect">
@@ -35923,7 +35923,7 @@
                 <a:ea typeface="Segoe UI"/>
                 <a:cs typeface="Segoe UI"/>
               </a:rPr>
-              <a:t>AI resume &amp; career-assistant demand in initial markets: China, U.S., and English-speaking Asia.</a:t>
+              <a:t>AI resume and career-assistant demand in initial markets: China, the U.S., and English-speaking Asia.</a:t>
             </a:r>
           </a:p>
         </p:txBody>
@@ -36024,8 +36024,8 @@
         </p:nvSpPr>
         <p:spPr>
           <a:xfrm>
-            <a:off x="777240" y="4370832"/>
-            <a:ext cx="10607040" cy="256032"/>
+            <a:off x="777240" y="4334256"/>
+            <a:ext cx="10607040" cy="237744"/>
           </a:xfrm>
           <a:prstGeom prst="rect">
             <a:avLst/>
@@ -36046,7 +36046,7 @@
                 <a:ea typeface="Segoe UI"/>
                 <a:cs typeface="Segoe UI"/>
               </a:rPr>
-              <a:t>51 CAREERS  ·  ILLUSTRATIVE 3-YEAR REVENUE OPPORTUNITY</a:t>
+              <a:t>51 CAREERS  ·  2027E–2029E REVENUE</a:t>
             </a:r>
           </a:p>
         </p:txBody>
@@ -36059,161 +36059,56 @@
         </p:nvSpPr>
         <p:spPr>
           <a:xfrm>
-            <a:off x="822960" y="4736592"/>
-            <a:ext cx="3291840" cy="219456"/>
-          </a:xfrm>
-          <a:prstGeom prst="rect">
-            <a:avLst/>
-          </a:prstGeom>
-          <a:noFill/>
-        </p:spPr>
-        <p:txBody>
-          <a:bodyPr wrap="square" anchor="t"/>
-          <a:lstStyle/>
-          <a:p>
-            <a:pPr algn="l"/>
-            <a:r>
-              <a:rPr sz="1200" b="1" i="0">
-                <a:solidFill>
-                  <a:srgbClr val="5E6E80"/>
-                </a:solidFill>
-                <a:latin typeface="Segoe UI"/>
-                <a:ea typeface="Segoe UI"/>
-                <a:cs typeface="Segoe UI"/>
-              </a:rPr>
-              <a:t>2027E</a:t>
-            </a:r>
-          </a:p>
-        </p:txBody>
-      </p:sp>
-      <p:sp>
-        <p:nvSpPr>
-          <p:cNvPr id="27" name="TextBox 26"/>
-          <p:cNvSpPr txBox="1"/>
-          <p:nvPr/>
-        </p:nvSpPr>
-        <p:spPr>
-          <a:xfrm>
-            <a:off x="822960" y="4956048"/>
-            <a:ext cx="3291840" cy="457200"/>
-          </a:xfrm>
-          <a:prstGeom prst="rect">
-            <a:avLst/>
-          </a:prstGeom>
-          <a:noFill/>
-        </p:spPr>
-        <p:txBody>
-          <a:bodyPr wrap="square" anchor="t"/>
-          <a:lstStyle/>
-          <a:p>
-            <a:pPr algn="l"/>
-            <a:r>
-              <a:rPr sz="2400" b="1" i="0">
-                <a:solidFill>
-                  <a:srgbClr val="0B1F33"/>
+            <a:off x="713232" y="4663440"/>
+            <a:ext cx="3383280" cy="219456"/>
+          </a:xfrm>
+          <a:prstGeom prst="rect">
+            <a:avLst/>
+          </a:prstGeom>
+          <a:noFill/>
+        </p:spPr>
+        <p:txBody>
+          <a:bodyPr wrap="square" anchor="t"/>
+          <a:lstStyle/>
+          <a:p>
+            <a:pPr algn="l"/>
+            <a:r>
+              <a:rPr sz="1300" b="1" i="0">
+                <a:solidFill>
+                  <a:srgbClr val="0A6B63"/>
                 </a:solidFill>
                 <a:latin typeface="Georgia"/>
                 <a:ea typeface="Georgia"/>
                 <a:cs typeface="Georgia"/>
               </a:rPr>
-              <a:t>US$ 2.0M</a:t>
-            </a:r>
-          </a:p>
-        </p:txBody>
-      </p:sp>
-      <p:sp>
-        <p:nvSpPr>
-          <p:cNvPr id="28" name="TextBox 27"/>
-          <p:cNvSpPr txBox="1"/>
-          <p:nvPr/>
-        </p:nvSpPr>
-        <p:spPr>
-          <a:xfrm>
-            <a:off x="822960" y="5440680"/>
-            <a:ext cx="3291840" cy="256032"/>
-          </a:xfrm>
-          <a:prstGeom prst="rect">
-            <a:avLst/>
-          </a:prstGeom>
-          <a:noFill/>
-        </p:spPr>
-        <p:txBody>
-          <a:bodyPr wrap="square" anchor="t"/>
-          <a:lstStyle/>
-          <a:p>
-            <a:pPr algn="l"/>
-            <a:r>
-              <a:rPr sz="1300" b="0" i="0">
-                <a:solidFill>
-                  <a:srgbClr val="5E6E80"/>
-                </a:solidFill>
-                <a:latin typeface="Segoe UI"/>
-                <a:ea typeface="Segoe UI"/>
-                <a:cs typeface="Segoe UI"/>
-              </a:rPr>
-              <a:t>≈ RMB 13.5M</a:t>
-            </a:r>
-          </a:p>
-        </p:txBody>
-      </p:sp>
-      <p:sp>
-        <p:nvSpPr>
-          <p:cNvPr id="29" name="TextBox 28"/>
-          <p:cNvSpPr txBox="1"/>
-          <p:nvPr/>
-        </p:nvSpPr>
-        <p:spPr>
-          <a:xfrm>
-            <a:off x="4480560" y="4736592"/>
-            <a:ext cx="3291840" cy="219456"/>
-          </a:xfrm>
-          <a:prstGeom prst="rect">
-            <a:avLst/>
-          </a:prstGeom>
-          <a:noFill/>
-        </p:spPr>
-        <p:txBody>
-          <a:bodyPr wrap="square" anchor="t"/>
-          <a:lstStyle/>
-          <a:p>
-            <a:pPr algn="l"/>
-            <a:r>
-              <a:rPr sz="1200" b="1" i="0">
-                <a:solidFill>
-                  <a:srgbClr val="5E6E80"/>
-                </a:solidFill>
-                <a:latin typeface="Segoe UI"/>
-                <a:ea typeface="Segoe UI"/>
-                <a:cs typeface="Segoe UI"/>
-              </a:rPr>
-              <a:t>2028E</a:t>
-            </a:r>
-          </a:p>
-        </p:txBody>
-      </p:sp>
-      <p:sp>
-        <p:nvSpPr>
-          <p:cNvPr id="30" name="TextBox 29"/>
-          <p:cNvSpPr txBox="1"/>
-          <p:nvPr/>
-        </p:nvSpPr>
-        <p:spPr>
-          <a:xfrm>
-            <a:off x="4480560" y="4956048"/>
-            <a:ext cx="3291840" cy="457200"/>
-          </a:xfrm>
-          <a:prstGeom prst="rect">
-            <a:avLst/>
-          </a:prstGeom>
-          <a:noFill/>
-        </p:spPr>
-        <p:txBody>
-          <a:bodyPr wrap="square" anchor="t"/>
-          <a:lstStyle/>
-          <a:p>
-            <a:pPr algn="l"/>
-            <a:r>
-              <a:rPr sz="2400" b="1" i="0">
+              <a:t>2027E</a:t>
+            </a:r>
+          </a:p>
+        </p:txBody>
+      </p:sp>
+      <p:sp>
+        <p:nvSpPr>
+          <p:cNvPr id="27" name="TextBox 26"/>
+          <p:cNvSpPr txBox="1"/>
+          <p:nvPr/>
+        </p:nvSpPr>
+        <p:spPr>
+          <a:xfrm>
+            <a:off x="713232" y="4901184"/>
+            <a:ext cx="3383280" cy="457200"/>
+          </a:xfrm>
+          <a:prstGeom prst="rect">
+            <a:avLst/>
+          </a:prstGeom>
+          <a:noFill/>
+        </p:spPr>
+        <p:txBody>
+          <a:bodyPr wrap="square" anchor="t"/>
+          <a:lstStyle/>
+          <a:p>
+            <a:pPr algn="l"/>
+            <a:r>
+              <a:rPr sz="2600" b="1" i="0">
                 <a:solidFill>
                   <a:srgbClr val="0B1F33"/>
                 </a:solidFill>
@@ -36221,111 +36116,216 @@
                 <a:ea typeface="Georgia"/>
                 <a:cs typeface="Georgia"/>
               </a:rPr>
-              <a:t>US$ 8.0M</a:t>
-            </a:r>
-          </a:p>
-        </p:txBody>
-      </p:sp>
-      <p:sp>
-        <p:nvSpPr>
-          <p:cNvPr id="31" name="TextBox 30"/>
-          <p:cNvSpPr txBox="1"/>
-          <p:nvPr/>
-        </p:nvSpPr>
-        <p:spPr>
-          <a:xfrm>
-            <a:off x="4480560" y="5440680"/>
-            <a:ext cx="3291840" cy="256032"/>
-          </a:xfrm>
-          <a:prstGeom prst="rect">
-            <a:avLst/>
-          </a:prstGeom>
-          <a:noFill/>
-        </p:spPr>
-        <p:txBody>
-          <a:bodyPr wrap="square" anchor="t"/>
-          <a:lstStyle/>
-          <a:p>
-            <a:pPr algn="l"/>
-            <a:r>
-              <a:rPr sz="1300" b="0" i="0">
+              <a:t>US$ 2.0M</a:t>
+            </a:r>
+          </a:p>
+        </p:txBody>
+      </p:sp>
+      <p:sp>
+        <p:nvSpPr>
+          <p:cNvPr id="28" name="TextBox 27"/>
+          <p:cNvSpPr txBox="1"/>
+          <p:nvPr/>
+        </p:nvSpPr>
+        <p:spPr>
+          <a:xfrm>
+            <a:off x="713232" y="5394960"/>
+            <a:ext cx="3383280" cy="256032"/>
+          </a:xfrm>
+          <a:prstGeom prst="rect">
+            <a:avLst/>
+          </a:prstGeom>
+          <a:noFill/>
+        </p:spPr>
+        <p:txBody>
+          <a:bodyPr wrap="square" anchor="t"/>
+          <a:lstStyle/>
+          <a:p>
+            <a:pPr algn="l"/>
+            <a:r>
+              <a:rPr sz="1400" b="0" i="0">
                 <a:solidFill>
                   <a:srgbClr val="5E6E80"/>
-                </a:solidFill>
-                <a:latin typeface="Segoe UI"/>
-                <a:ea typeface="Segoe UI"/>
-                <a:cs typeface="Segoe UI"/>
-              </a:rPr>
-              <a:t>≈ RMB 53.8M</a:t>
-            </a:r>
-          </a:p>
-        </p:txBody>
-      </p:sp>
-      <p:sp>
-        <p:nvSpPr>
-          <p:cNvPr id="32" name="TextBox 31"/>
-          <p:cNvSpPr txBox="1"/>
-          <p:nvPr/>
-        </p:nvSpPr>
-        <p:spPr>
-          <a:xfrm>
-            <a:off x="8138160" y="4736592"/>
-            <a:ext cx="3291840" cy="219456"/>
-          </a:xfrm>
-          <a:prstGeom prst="rect">
-            <a:avLst/>
-          </a:prstGeom>
-          <a:noFill/>
-        </p:spPr>
-        <p:txBody>
-          <a:bodyPr wrap="square" anchor="t"/>
-          <a:lstStyle/>
-          <a:p>
-            <a:pPr algn="l"/>
-            <a:r>
-              <a:rPr sz="1200" b="1" i="0">
-                <a:solidFill>
-                  <a:srgbClr val="5E6E80"/>
-                </a:solidFill>
-                <a:latin typeface="Segoe UI"/>
-                <a:ea typeface="Segoe UI"/>
-                <a:cs typeface="Segoe UI"/>
-              </a:rPr>
-              <a:t>2029E</a:t>
-            </a:r>
-          </a:p>
-        </p:txBody>
-      </p:sp>
-      <p:sp>
-        <p:nvSpPr>
-          <p:cNvPr id="33" name="TextBox 32"/>
-          <p:cNvSpPr txBox="1"/>
-          <p:nvPr/>
-        </p:nvSpPr>
-        <p:spPr>
-          <a:xfrm>
-            <a:off x="8138160" y="4956048"/>
-            <a:ext cx="3291840" cy="457200"/>
-          </a:xfrm>
-          <a:prstGeom prst="rect">
-            <a:avLst/>
-          </a:prstGeom>
-          <a:noFill/>
-        </p:spPr>
-        <p:txBody>
-          <a:bodyPr wrap="square" anchor="t"/>
-          <a:lstStyle/>
-          <a:p>
-            <a:pPr algn="l"/>
-            <a:r>
-              <a:rPr sz="2400" b="1" i="0">
-                <a:solidFill>
-                  <a:srgbClr val="0B1F33"/>
                 </a:solidFill>
                 <a:latin typeface="Georgia"/>
                 <a:ea typeface="Georgia"/>
                 <a:cs typeface="Georgia"/>
               </a:rPr>
+              <a:t>≈ RMB 13.5M</a:t>
+            </a:r>
+          </a:p>
+        </p:txBody>
+      </p:sp>
+      <p:sp>
+        <p:nvSpPr>
+          <p:cNvPr id="29" name="TextBox 28"/>
+          <p:cNvSpPr txBox="1"/>
+          <p:nvPr/>
+        </p:nvSpPr>
+        <p:spPr>
+          <a:xfrm>
+            <a:off x="4443984" y="4663440"/>
+            <a:ext cx="3383280" cy="219456"/>
+          </a:xfrm>
+          <a:prstGeom prst="rect">
+            <a:avLst/>
+          </a:prstGeom>
+          <a:noFill/>
+        </p:spPr>
+        <p:txBody>
+          <a:bodyPr wrap="square" anchor="t"/>
+          <a:lstStyle/>
+          <a:p>
+            <a:pPr algn="l"/>
+            <a:r>
+              <a:rPr sz="1300" b="1" i="0">
+                <a:solidFill>
+                  <a:srgbClr val="0A6B63"/>
+                </a:solidFill>
+                <a:latin typeface="Georgia"/>
+                <a:ea typeface="Georgia"/>
+                <a:cs typeface="Georgia"/>
+              </a:rPr>
+              <a:t>2028E</a:t>
+            </a:r>
+          </a:p>
+        </p:txBody>
+      </p:sp>
+      <p:sp>
+        <p:nvSpPr>
+          <p:cNvPr id="30" name="TextBox 29"/>
+          <p:cNvSpPr txBox="1"/>
+          <p:nvPr/>
+        </p:nvSpPr>
+        <p:spPr>
+          <a:xfrm>
+            <a:off x="4443984" y="4901184"/>
+            <a:ext cx="3383280" cy="457200"/>
+          </a:xfrm>
+          <a:prstGeom prst="rect">
+            <a:avLst/>
+          </a:prstGeom>
+          <a:noFill/>
+        </p:spPr>
+        <p:txBody>
+          <a:bodyPr wrap="square" anchor="t"/>
+          <a:lstStyle/>
+          <a:p>
+            <a:pPr algn="l"/>
+            <a:r>
+              <a:rPr sz="2600" b="1" i="0">
+                <a:solidFill>
+                  <a:srgbClr val="0B1F33"/>
+                </a:solidFill>
+                <a:latin typeface="Georgia"/>
+                <a:ea typeface="Georgia"/>
+                <a:cs typeface="Georgia"/>
+              </a:rPr>
+              <a:t>US$ 8.0M</a:t>
+            </a:r>
+          </a:p>
+        </p:txBody>
+      </p:sp>
+      <p:sp>
+        <p:nvSpPr>
+          <p:cNvPr id="31" name="TextBox 30"/>
+          <p:cNvSpPr txBox="1"/>
+          <p:nvPr/>
+        </p:nvSpPr>
+        <p:spPr>
+          <a:xfrm>
+            <a:off x="4443984" y="5394960"/>
+            <a:ext cx="3383280" cy="256032"/>
+          </a:xfrm>
+          <a:prstGeom prst="rect">
+            <a:avLst/>
+          </a:prstGeom>
+          <a:noFill/>
+        </p:spPr>
+        <p:txBody>
+          <a:bodyPr wrap="square" anchor="t"/>
+          <a:lstStyle/>
+          <a:p>
+            <a:pPr algn="l"/>
+            <a:r>
+              <a:rPr sz="1400" b="0" i="0">
+                <a:solidFill>
+                  <a:srgbClr val="5E6E80"/>
+                </a:solidFill>
+                <a:latin typeface="Georgia"/>
+                <a:ea typeface="Georgia"/>
+                <a:cs typeface="Georgia"/>
+              </a:rPr>
+              <a:t>≈ RMB 53.8M</a:t>
+            </a:r>
+          </a:p>
+        </p:txBody>
+      </p:sp>
+      <p:sp>
+        <p:nvSpPr>
+          <p:cNvPr id="32" name="TextBox 31"/>
+          <p:cNvSpPr txBox="1"/>
+          <p:nvPr/>
+        </p:nvSpPr>
+        <p:spPr>
+          <a:xfrm>
+            <a:off x="8174736" y="4663440"/>
+            <a:ext cx="3383280" cy="219456"/>
+          </a:xfrm>
+          <a:prstGeom prst="rect">
+            <a:avLst/>
+          </a:prstGeom>
+          <a:noFill/>
+        </p:spPr>
+        <p:txBody>
+          <a:bodyPr wrap="square" anchor="t"/>
+          <a:lstStyle/>
+          <a:p>
+            <a:pPr algn="l"/>
+            <a:r>
+              <a:rPr sz="1300" b="1" i="0">
+                <a:solidFill>
+                  <a:srgbClr val="0A6B63"/>
+                </a:solidFill>
+                <a:latin typeface="Georgia"/>
+                <a:ea typeface="Georgia"/>
+                <a:cs typeface="Georgia"/>
+              </a:rPr>
+              <a:t>2029E</a:t>
+            </a:r>
+          </a:p>
+        </p:txBody>
+      </p:sp>
+      <p:sp>
+        <p:nvSpPr>
+          <p:cNvPr id="33" name="TextBox 32"/>
+          <p:cNvSpPr txBox="1"/>
+          <p:nvPr/>
+        </p:nvSpPr>
+        <p:spPr>
+          <a:xfrm>
+            <a:off x="8174736" y="4901184"/>
+            <a:ext cx="3383280" cy="457200"/>
+          </a:xfrm>
+          <a:prstGeom prst="rect">
+            <a:avLst/>
+          </a:prstGeom>
+          <a:noFill/>
+        </p:spPr>
+        <p:txBody>
+          <a:bodyPr wrap="square" anchor="t"/>
+          <a:lstStyle/>
+          <a:p>
+            <a:pPr algn="l"/>
+            <a:r>
+              <a:rPr sz="2600" b="1" i="0">
+                <a:solidFill>
+                  <a:srgbClr val="0B1F33"/>
+                </a:solidFill>
+                <a:latin typeface="Georgia"/>
+                <a:ea typeface="Georgia"/>
+                <a:cs typeface="Georgia"/>
+              </a:rPr>
               <a:t>US$ 28.0M</a:t>
             </a:r>
           </a:p>
@@ -36339,27 +36339,27 @@
         </p:nvSpPr>
         <p:spPr>
           <a:xfrm>
-            <a:off x="8138160" y="5440680"/>
-            <a:ext cx="3291840" cy="256032"/>
-          </a:xfrm>
-          <a:prstGeom prst="rect">
-            <a:avLst/>
-          </a:prstGeom>
-          <a:noFill/>
-        </p:spPr>
-        <p:txBody>
-          <a:bodyPr wrap="square" anchor="t"/>
-          <a:lstStyle/>
-          <a:p>
-            <a:pPr algn="l"/>
-            <a:r>
-              <a:rPr sz="1300" b="0" i="0">
+            <a:off x="8174736" y="5394960"/>
+            <a:ext cx="3383280" cy="256032"/>
+          </a:xfrm>
+          <a:prstGeom prst="rect">
+            <a:avLst/>
+          </a:prstGeom>
+          <a:noFill/>
+        </p:spPr>
+        <p:txBody>
+          <a:bodyPr wrap="square" anchor="t"/>
+          <a:lstStyle/>
+          <a:p>
+            <a:pPr algn="l"/>
+            <a:r>
+              <a:rPr sz="1400" b="0" i="0">
                 <a:solidFill>
                   <a:srgbClr val="5E6E80"/>
                 </a:solidFill>
-                <a:latin typeface="Segoe UI"/>
-                <a:ea typeface="Segoe UI"/>
-                <a:cs typeface="Segoe UI"/>
+                <a:latin typeface="Georgia"/>
+                <a:ea typeface="Georgia"/>
+                <a:cs typeface="Georgia"/>
               </a:rPr>
               <a:t>≈ RMB 188.4M</a:t>
             </a:r>
@@ -36374,21 +36374,21 @@
         </p:nvSpPr>
         <p:spPr>
           <a:xfrm>
-            <a:off x="777240" y="5806440"/>
-            <a:ext cx="10607040" cy="292608"/>
-          </a:xfrm>
-          <a:prstGeom prst="rect">
-            <a:avLst/>
-          </a:prstGeom>
-          <a:noFill/>
-        </p:spPr>
-        <p:txBody>
-          <a:bodyPr wrap="square" anchor="t"/>
-          <a:lstStyle/>
-          <a:p>
-            <a:pPr algn="l"/>
-            <a:r>
-              <a:rPr sz="1000" b="0" i="0">
+            <a:off x="713232" y="5779008"/>
+            <a:ext cx="10698480" cy="329184"/>
+          </a:xfrm>
+          <a:prstGeom prst="rect">
+            <a:avLst/>
+          </a:prstGeom>
+          <a:noFill/>
+        </p:spPr>
+        <p:txBody>
+          <a:bodyPr wrap="square" anchor="t"/>
+          <a:lstStyle/>
+          <a:p>
+            <a:pPr algn="l"/>
+            <a:r>
+              <a:rPr sz="1200" b="0" i="0">
                 <a:solidFill>
                   <a:srgbClr val="5E6E80"/>
                 </a:solidFill>
@@ -36396,7 +36396,7 @@
                 <a:ea typeface="Segoe UI"/>
                 <a:cs typeface="Segoe UI"/>
               </a:rPr>
-              <a:t>Logic: global job seekers → addressable AI Resume users → paid conversion → stacked revenue (AI + services + commission + B2B + ads).</a:t>
+              <a:t>Logic: global job seekers  →  addressable AI Resume users  →  paid conversion  →  stacked revenue (AI + services + commission + B2B + ads).</a:t>
             </a:r>
           </a:p>
         </p:txBody>

</xml_diff>

<commit_message>
Align slide 7 solution numbers on a symmetric grid
Place 01–07 in identical centered badges with even row spacing
so the step list lines up with the AI Resume panel.

Co-authored-by: anthonyleedu <anthonyleedu@users.noreply.github.com>
</commit_message>
<xml_diff>
--- a/51Careers_Addition.pptx
+++ b/51Careers_Addition.pptx
@@ -36740,7 +36740,7 @@
         <p:spPr>
           <a:xfrm>
             <a:off x="502920" y="1115568"/>
-            <a:ext cx="6949440" cy="658368"/>
+            <a:ext cx="6903720" cy="676656"/>
           </a:xfrm>
           <a:prstGeom prst="roundRect">
             <a:avLst>
@@ -36785,7 +36785,7 @@
         <p:spPr>
           <a:xfrm>
             <a:off x="502920" y="1115568"/>
-            <a:ext cx="73152" cy="658368"/>
+            <a:ext cx="73152" cy="676656"/>
           </a:xfrm>
           <a:prstGeom prst="rect">
             <a:avLst/>
@@ -36821,29 +36821,50 @@
       </p:sp>
       <p:sp>
         <p:nvSpPr>
-          <p:cNvPr id="7" name="TextBox 6"/>
-          <p:cNvSpPr txBox="1"/>
-          <p:nvPr/>
-        </p:nvSpPr>
-        <p:spPr>
-          <a:xfrm>
-            <a:off x="777240" y="1261872"/>
-            <a:ext cx="457200" cy="384048"/>
-          </a:xfrm>
-          <a:prstGeom prst="rect">
-            <a:avLst/>
-          </a:prstGeom>
-          <a:noFill/>
-        </p:spPr>
-        <p:txBody>
-          <a:bodyPr wrap="square" anchor="t"/>
-          <a:lstStyle/>
-          <a:p>
-            <a:pPr algn="l"/>
-            <a:r>
-              <a:rPr sz="1600" b="1" i="0">
-                <a:solidFill>
-                  <a:srgbClr val="0A6B63"/>
+          <p:cNvPr id="7" name="Rounded Rectangle 6"/>
+          <p:cNvSpPr/>
+          <p:nvPr/>
+        </p:nvSpPr>
+        <p:spPr>
+          <a:xfrm>
+            <a:off x="713232" y="1271016"/>
+            <a:ext cx="512064" cy="365760"/>
+          </a:xfrm>
+          <a:prstGeom prst="roundRect">
+            <a:avLst>
+              <a:gd name="adj" fmla="val 25000"/>
+            </a:avLst>
+          </a:prstGeom>
+          <a:solidFill>
+            <a:srgbClr val="0A6B63"/>
+          </a:solidFill>
+          <a:ln>
+            <a:noFill/>
+          </a:ln>
+        </p:spPr>
+        <p:style>
+          <a:lnRef idx="1">
+            <a:schemeClr val="accent1"/>
+          </a:lnRef>
+          <a:fillRef idx="3">
+            <a:schemeClr val="accent1"/>
+          </a:fillRef>
+          <a:effectRef idx="2">
+            <a:schemeClr val="accent1"/>
+          </a:effectRef>
+          <a:fontRef idx="minor">
+            <a:schemeClr val="lt1"/>
+          </a:fontRef>
+        </p:style>
+        <p:txBody>
+          <a:bodyPr rtlCol="0" anchor="ctr" wrap="square"/>
+          <a:lstStyle/>
+          <a:p>
+            <a:pPr algn="ctr"/>
+            <a:r>
+              <a:rPr sz="1300" b="1" i="0">
+                <a:solidFill>
+                  <a:srgbClr val="FFFFFF"/>
                 </a:solidFill>
                 <a:latin typeface="Georgia"/>
                 <a:ea typeface="Georgia"/>
@@ -36862,21 +36883,21 @@
         </p:nvSpPr>
         <p:spPr>
           <a:xfrm>
-            <a:off x="1325880" y="1261872"/>
-            <a:ext cx="5852160" cy="384048"/>
-          </a:xfrm>
-          <a:prstGeom prst="rect">
-            <a:avLst/>
-          </a:prstGeom>
-          <a:noFill/>
-        </p:spPr>
-        <p:txBody>
-          <a:bodyPr wrap="square" anchor="t"/>
-          <a:lstStyle/>
-          <a:p>
-            <a:pPr algn="l"/>
-            <a:r>
-              <a:rPr sz="1700" b="1" i="0">
+            <a:off x="1371600" y="1115568"/>
+            <a:ext cx="5852160" cy="676656"/>
+          </a:xfrm>
+          <a:prstGeom prst="rect">
+            <a:avLst/>
+          </a:prstGeom>
+          <a:noFill/>
+        </p:spPr>
+        <p:txBody>
+          <a:bodyPr wrap="square" anchor="ctr"/>
+          <a:lstStyle/>
+          <a:p>
+            <a:pPr algn="l"/>
+            <a:r>
+              <a:rPr sz="1600" b="1" i="0">
                 <a:solidFill>
                   <a:srgbClr val="0B1F33"/>
                 </a:solidFill>
@@ -36897,8 +36918,8 @@
         </p:nvSpPr>
         <p:spPr>
           <a:xfrm>
-            <a:off x="502920" y="1828800"/>
-            <a:ext cx="6949440" cy="658368"/>
+            <a:off x="502920" y="1865376"/>
+            <a:ext cx="6903720" cy="676656"/>
           </a:xfrm>
           <a:prstGeom prst="roundRect">
             <a:avLst>
@@ -36942,8 +36963,8 @@
         </p:nvSpPr>
         <p:spPr>
           <a:xfrm>
-            <a:off x="502920" y="1828800"/>
-            <a:ext cx="73152" cy="658368"/>
+            <a:off x="502920" y="1865376"/>
+            <a:ext cx="73152" cy="676656"/>
           </a:xfrm>
           <a:prstGeom prst="rect">
             <a:avLst/>
@@ -36979,29 +37000,50 @@
       </p:sp>
       <p:sp>
         <p:nvSpPr>
-          <p:cNvPr id="11" name="TextBox 10"/>
-          <p:cNvSpPr txBox="1"/>
-          <p:nvPr/>
-        </p:nvSpPr>
-        <p:spPr>
-          <a:xfrm>
-            <a:off x="777240" y="1975104"/>
-            <a:ext cx="457200" cy="384048"/>
-          </a:xfrm>
-          <a:prstGeom prst="rect">
-            <a:avLst/>
-          </a:prstGeom>
-          <a:noFill/>
-        </p:spPr>
-        <p:txBody>
-          <a:bodyPr wrap="square" anchor="t"/>
-          <a:lstStyle/>
-          <a:p>
-            <a:pPr algn="l"/>
-            <a:r>
-              <a:rPr sz="1600" b="1" i="0">
-                <a:solidFill>
-                  <a:srgbClr val="0A6B63"/>
+          <p:cNvPr id="11" name="Rounded Rectangle 10"/>
+          <p:cNvSpPr/>
+          <p:nvPr/>
+        </p:nvSpPr>
+        <p:spPr>
+          <a:xfrm>
+            <a:off x="713232" y="2020824"/>
+            <a:ext cx="512064" cy="365760"/>
+          </a:xfrm>
+          <a:prstGeom prst="roundRect">
+            <a:avLst>
+              <a:gd name="adj" fmla="val 25000"/>
+            </a:avLst>
+          </a:prstGeom>
+          <a:solidFill>
+            <a:srgbClr val="0A6B63"/>
+          </a:solidFill>
+          <a:ln>
+            <a:noFill/>
+          </a:ln>
+        </p:spPr>
+        <p:style>
+          <a:lnRef idx="1">
+            <a:schemeClr val="accent1"/>
+          </a:lnRef>
+          <a:fillRef idx="3">
+            <a:schemeClr val="accent1"/>
+          </a:fillRef>
+          <a:effectRef idx="2">
+            <a:schemeClr val="accent1"/>
+          </a:effectRef>
+          <a:fontRef idx="minor">
+            <a:schemeClr val="lt1"/>
+          </a:fontRef>
+        </p:style>
+        <p:txBody>
+          <a:bodyPr rtlCol="0" anchor="ctr" wrap="square"/>
+          <a:lstStyle/>
+          <a:p>
+            <a:pPr algn="ctr"/>
+            <a:r>
+              <a:rPr sz="1300" b="1" i="0">
+                <a:solidFill>
+                  <a:srgbClr val="FFFFFF"/>
                 </a:solidFill>
                 <a:latin typeface="Georgia"/>
                 <a:ea typeface="Georgia"/>
@@ -37020,21 +37062,21 @@
         </p:nvSpPr>
         <p:spPr>
           <a:xfrm>
-            <a:off x="1325880" y="1975104"/>
-            <a:ext cx="5852160" cy="384048"/>
-          </a:xfrm>
-          <a:prstGeom prst="rect">
-            <a:avLst/>
-          </a:prstGeom>
-          <a:noFill/>
-        </p:spPr>
-        <p:txBody>
-          <a:bodyPr wrap="square" anchor="t"/>
-          <a:lstStyle/>
-          <a:p>
-            <a:pPr algn="l"/>
-            <a:r>
-              <a:rPr sz="1700" b="1" i="0">
+            <a:off x="1371600" y="1865376"/>
+            <a:ext cx="5852160" cy="676656"/>
+          </a:xfrm>
+          <a:prstGeom prst="rect">
+            <a:avLst/>
+          </a:prstGeom>
+          <a:noFill/>
+        </p:spPr>
+        <p:txBody>
+          <a:bodyPr wrap="square" anchor="ctr"/>
+          <a:lstStyle/>
+          <a:p>
+            <a:pPr algn="l"/>
+            <a:r>
+              <a:rPr sz="1600" b="1" i="0">
                 <a:solidFill>
                   <a:srgbClr val="0B1F33"/>
                 </a:solidFill>
@@ -37055,8 +37097,8 @@
         </p:nvSpPr>
         <p:spPr>
           <a:xfrm>
-            <a:off x="502920" y="2542032"/>
-            <a:ext cx="6949440" cy="658368"/>
+            <a:off x="502920" y="2615184"/>
+            <a:ext cx="6903720" cy="676656"/>
           </a:xfrm>
           <a:prstGeom prst="roundRect">
             <a:avLst>
@@ -37100,8 +37142,8 @@
         </p:nvSpPr>
         <p:spPr>
           <a:xfrm>
-            <a:off x="502920" y="2542032"/>
-            <a:ext cx="73152" cy="658368"/>
+            <a:off x="502920" y="2615184"/>
+            <a:ext cx="73152" cy="676656"/>
           </a:xfrm>
           <a:prstGeom prst="rect">
             <a:avLst/>
@@ -37137,29 +37179,50 @@
       </p:sp>
       <p:sp>
         <p:nvSpPr>
-          <p:cNvPr id="15" name="TextBox 14"/>
-          <p:cNvSpPr txBox="1"/>
-          <p:nvPr/>
-        </p:nvSpPr>
-        <p:spPr>
-          <a:xfrm>
-            <a:off x="777240" y="2688336"/>
-            <a:ext cx="457200" cy="384048"/>
-          </a:xfrm>
-          <a:prstGeom prst="rect">
-            <a:avLst/>
-          </a:prstGeom>
-          <a:noFill/>
-        </p:spPr>
-        <p:txBody>
-          <a:bodyPr wrap="square" anchor="t"/>
-          <a:lstStyle/>
-          <a:p>
-            <a:pPr algn="l"/>
-            <a:r>
-              <a:rPr sz="1600" b="1" i="0">
-                <a:solidFill>
-                  <a:srgbClr val="0A6B63"/>
+          <p:cNvPr id="15" name="Rounded Rectangle 14"/>
+          <p:cNvSpPr/>
+          <p:nvPr/>
+        </p:nvSpPr>
+        <p:spPr>
+          <a:xfrm>
+            <a:off x="713232" y="2770632"/>
+            <a:ext cx="512064" cy="365760"/>
+          </a:xfrm>
+          <a:prstGeom prst="roundRect">
+            <a:avLst>
+              <a:gd name="adj" fmla="val 25000"/>
+            </a:avLst>
+          </a:prstGeom>
+          <a:solidFill>
+            <a:srgbClr val="0A6B63"/>
+          </a:solidFill>
+          <a:ln>
+            <a:noFill/>
+          </a:ln>
+        </p:spPr>
+        <p:style>
+          <a:lnRef idx="1">
+            <a:schemeClr val="accent1"/>
+          </a:lnRef>
+          <a:fillRef idx="3">
+            <a:schemeClr val="accent1"/>
+          </a:fillRef>
+          <a:effectRef idx="2">
+            <a:schemeClr val="accent1"/>
+          </a:effectRef>
+          <a:fontRef idx="minor">
+            <a:schemeClr val="lt1"/>
+          </a:fontRef>
+        </p:style>
+        <p:txBody>
+          <a:bodyPr rtlCol="0" anchor="ctr" wrap="square"/>
+          <a:lstStyle/>
+          <a:p>
+            <a:pPr algn="ctr"/>
+            <a:r>
+              <a:rPr sz="1300" b="1" i="0">
+                <a:solidFill>
+                  <a:srgbClr val="FFFFFF"/>
                 </a:solidFill>
                 <a:latin typeface="Georgia"/>
                 <a:ea typeface="Georgia"/>
@@ -37178,21 +37241,21 @@
         </p:nvSpPr>
         <p:spPr>
           <a:xfrm>
-            <a:off x="1325880" y="2688336"/>
-            <a:ext cx="5852160" cy="384048"/>
-          </a:xfrm>
-          <a:prstGeom prst="rect">
-            <a:avLst/>
-          </a:prstGeom>
-          <a:noFill/>
-        </p:spPr>
-        <p:txBody>
-          <a:bodyPr wrap="square" anchor="t"/>
-          <a:lstStyle/>
-          <a:p>
-            <a:pPr algn="l"/>
-            <a:r>
-              <a:rPr sz="1700" b="1" i="0">
+            <a:off x="1371600" y="2615184"/>
+            <a:ext cx="5852160" cy="676656"/>
+          </a:xfrm>
+          <a:prstGeom prst="rect">
+            <a:avLst/>
+          </a:prstGeom>
+          <a:noFill/>
+        </p:spPr>
+        <p:txBody>
+          <a:bodyPr wrap="square" anchor="ctr"/>
+          <a:lstStyle/>
+          <a:p>
+            <a:pPr algn="l"/>
+            <a:r>
+              <a:rPr sz="1600" b="1" i="0">
                 <a:solidFill>
                   <a:srgbClr val="0B1F33"/>
                 </a:solidFill>
@@ -37213,8 +37276,8 @@
         </p:nvSpPr>
         <p:spPr>
           <a:xfrm>
-            <a:off x="502920" y="3255264"/>
-            <a:ext cx="6949440" cy="658368"/>
+            <a:off x="502920" y="3364991"/>
+            <a:ext cx="6903720" cy="676656"/>
           </a:xfrm>
           <a:prstGeom prst="roundRect">
             <a:avLst>
@@ -37258,8 +37321,8 @@
         </p:nvSpPr>
         <p:spPr>
           <a:xfrm>
-            <a:off x="502920" y="3255264"/>
-            <a:ext cx="73152" cy="658368"/>
+            <a:off x="502920" y="3364991"/>
+            <a:ext cx="73152" cy="676656"/>
           </a:xfrm>
           <a:prstGeom prst="rect">
             <a:avLst/>
@@ -37295,29 +37358,50 @@
       </p:sp>
       <p:sp>
         <p:nvSpPr>
-          <p:cNvPr id="19" name="TextBox 18"/>
-          <p:cNvSpPr txBox="1"/>
-          <p:nvPr/>
-        </p:nvSpPr>
-        <p:spPr>
-          <a:xfrm>
-            <a:off x="777240" y="3401568"/>
-            <a:ext cx="457200" cy="384048"/>
-          </a:xfrm>
-          <a:prstGeom prst="rect">
-            <a:avLst/>
-          </a:prstGeom>
-          <a:noFill/>
-        </p:spPr>
-        <p:txBody>
-          <a:bodyPr wrap="square" anchor="t"/>
-          <a:lstStyle/>
-          <a:p>
-            <a:pPr algn="l"/>
-            <a:r>
-              <a:rPr sz="1600" b="1" i="0">
-                <a:solidFill>
-                  <a:srgbClr val="0A6B63"/>
+          <p:cNvPr id="19" name="Rounded Rectangle 18"/>
+          <p:cNvSpPr/>
+          <p:nvPr/>
+        </p:nvSpPr>
+        <p:spPr>
+          <a:xfrm>
+            <a:off x="713232" y="3520439"/>
+            <a:ext cx="512064" cy="365760"/>
+          </a:xfrm>
+          <a:prstGeom prst="roundRect">
+            <a:avLst>
+              <a:gd name="adj" fmla="val 25000"/>
+            </a:avLst>
+          </a:prstGeom>
+          <a:solidFill>
+            <a:srgbClr val="0A6B63"/>
+          </a:solidFill>
+          <a:ln>
+            <a:noFill/>
+          </a:ln>
+        </p:spPr>
+        <p:style>
+          <a:lnRef idx="1">
+            <a:schemeClr val="accent1"/>
+          </a:lnRef>
+          <a:fillRef idx="3">
+            <a:schemeClr val="accent1"/>
+          </a:fillRef>
+          <a:effectRef idx="2">
+            <a:schemeClr val="accent1"/>
+          </a:effectRef>
+          <a:fontRef idx="minor">
+            <a:schemeClr val="lt1"/>
+          </a:fontRef>
+        </p:style>
+        <p:txBody>
+          <a:bodyPr rtlCol="0" anchor="ctr" wrap="square"/>
+          <a:lstStyle/>
+          <a:p>
+            <a:pPr algn="ctr"/>
+            <a:r>
+              <a:rPr sz="1300" b="1" i="0">
+                <a:solidFill>
+                  <a:srgbClr val="FFFFFF"/>
                 </a:solidFill>
                 <a:latin typeface="Georgia"/>
                 <a:ea typeface="Georgia"/>
@@ -37336,21 +37420,21 @@
         </p:nvSpPr>
         <p:spPr>
           <a:xfrm>
-            <a:off x="1325880" y="3401568"/>
-            <a:ext cx="5852160" cy="384048"/>
-          </a:xfrm>
-          <a:prstGeom prst="rect">
-            <a:avLst/>
-          </a:prstGeom>
-          <a:noFill/>
-        </p:spPr>
-        <p:txBody>
-          <a:bodyPr wrap="square" anchor="t"/>
-          <a:lstStyle/>
-          <a:p>
-            <a:pPr algn="l"/>
-            <a:r>
-              <a:rPr sz="1700" b="1" i="0">
+            <a:off x="1371600" y="3364991"/>
+            <a:ext cx="5852160" cy="676656"/>
+          </a:xfrm>
+          <a:prstGeom prst="rect">
+            <a:avLst/>
+          </a:prstGeom>
+          <a:noFill/>
+        </p:spPr>
+        <p:txBody>
+          <a:bodyPr wrap="square" anchor="ctr"/>
+          <a:lstStyle/>
+          <a:p>
+            <a:pPr algn="l"/>
+            <a:r>
+              <a:rPr sz="1600" b="1" i="0">
                 <a:solidFill>
                   <a:srgbClr val="0B1F33"/>
                 </a:solidFill>
@@ -37371,8 +37455,8 @@
         </p:nvSpPr>
         <p:spPr>
           <a:xfrm>
-            <a:off x="502920" y="3968496"/>
-            <a:ext cx="6949440" cy="658368"/>
+            <a:off x="502920" y="4114800"/>
+            <a:ext cx="6903720" cy="676656"/>
           </a:xfrm>
           <a:prstGeom prst="roundRect">
             <a:avLst>
@@ -37416,8 +37500,8 @@
         </p:nvSpPr>
         <p:spPr>
           <a:xfrm>
-            <a:off x="502920" y="3968496"/>
-            <a:ext cx="73152" cy="658368"/>
+            <a:off x="502920" y="4114800"/>
+            <a:ext cx="73152" cy="676656"/>
           </a:xfrm>
           <a:prstGeom prst="rect">
             <a:avLst/>
@@ -37453,29 +37537,50 @@
       </p:sp>
       <p:sp>
         <p:nvSpPr>
-          <p:cNvPr id="23" name="TextBox 22"/>
-          <p:cNvSpPr txBox="1"/>
-          <p:nvPr/>
-        </p:nvSpPr>
-        <p:spPr>
-          <a:xfrm>
-            <a:off x="777240" y="4114800"/>
-            <a:ext cx="457200" cy="384048"/>
-          </a:xfrm>
-          <a:prstGeom prst="rect">
-            <a:avLst/>
-          </a:prstGeom>
-          <a:noFill/>
-        </p:spPr>
-        <p:txBody>
-          <a:bodyPr wrap="square" anchor="t"/>
-          <a:lstStyle/>
-          <a:p>
-            <a:pPr algn="l"/>
-            <a:r>
-              <a:rPr sz="1600" b="1" i="0">
-                <a:solidFill>
-                  <a:srgbClr val="0A6B63"/>
+          <p:cNvPr id="23" name="Rounded Rectangle 22"/>
+          <p:cNvSpPr/>
+          <p:nvPr/>
+        </p:nvSpPr>
+        <p:spPr>
+          <a:xfrm>
+            <a:off x="713232" y="4270248"/>
+            <a:ext cx="512064" cy="365760"/>
+          </a:xfrm>
+          <a:prstGeom prst="roundRect">
+            <a:avLst>
+              <a:gd name="adj" fmla="val 25000"/>
+            </a:avLst>
+          </a:prstGeom>
+          <a:solidFill>
+            <a:srgbClr val="0A6B63"/>
+          </a:solidFill>
+          <a:ln>
+            <a:noFill/>
+          </a:ln>
+        </p:spPr>
+        <p:style>
+          <a:lnRef idx="1">
+            <a:schemeClr val="accent1"/>
+          </a:lnRef>
+          <a:fillRef idx="3">
+            <a:schemeClr val="accent1"/>
+          </a:fillRef>
+          <a:effectRef idx="2">
+            <a:schemeClr val="accent1"/>
+          </a:effectRef>
+          <a:fontRef idx="minor">
+            <a:schemeClr val="lt1"/>
+          </a:fontRef>
+        </p:style>
+        <p:txBody>
+          <a:bodyPr rtlCol="0" anchor="ctr" wrap="square"/>
+          <a:lstStyle/>
+          <a:p>
+            <a:pPr algn="ctr"/>
+            <a:r>
+              <a:rPr sz="1300" b="1" i="0">
+                <a:solidFill>
+                  <a:srgbClr val="FFFFFF"/>
                 </a:solidFill>
                 <a:latin typeface="Georgia"/>
                 <a:ea typeface="Georgia"/>
@@ -37494,21 +37599,21 @@
         </p:nvSpPr>
         <p:spPr>
           <a:xfrm>
-            <a:off x="1325880" y="4114800"/>
-            <a:ext cx="5852160" cy="384048"/>
-          </a:xfrm>
-          <a:prstGeom prst="rect">
-            <a:avLst/>
-          </a:prstGeom>
-          <a:noFill/>
-        </p:spPr>
-        <p:txBody>
-          <a:bodyPr wrap="square" anchor="t"/>
-          <a:lstStyle/>
-          <a:p>
-            <a:pPr algn="l"/>
-            <a:r>
-              <a:rPr sz="1700" b="1" i="0">
+            <a:off x="1371600" y="4114800"/>
+            <a:ext cx="5852160" cy="676656"/>
+          </a:xfrm>
+          <a:prstGeom prst="rect">
+            <a:avLst/>
+          </a:prstGeom>
+          <a:noFill/>
+        </p:spPr>
+        <p:txBody>
+          <a:bodyPr wrap="square" anchor="ctr"/>
+          <a:lstStyle/>
+          <a:p>
+            <a:pPr algn="l"/>
+            <a:r>
+              <a:rPr sz="1600" b="1" i="0">
                 <a:solidFill>
                   <a:srgbClr val="0B1F33"/>
                 </a:solidFill>
@@ -37529,8 +37634,8 @@
         </p:nvSpPr>
         <p:spPr>
           <a:xfrm>
-            <a:off x="502920" y="4681728"/>
-            <a:ext cx="6949440" cy="658368"/>
+            <a:off x="502920" y="4864607"/>
+            <a:ext cx="6903720" cy="676656"/>
           </a:xfrm>
           <a:prstGeom prst="roundRect">
             <a:avLst>
@@ -37574,8 +37679,8 @@
         </p:nvSpPr>
         <p:spPr>
           <a:xfrm>
-            <a:off x="502920" y="4681728"/>
-            <a:ext cx="73152" cy="658368"/>
+            <a:off x="502920" y="4864607"/>
+            <a:ext cx="73152" cy="676656"/>
           </a:xfrm>
           <a:prstGeom prst="rect">
             <a:avLst/>
@@ -37611,29 +37716,50 @@
       </p:sp>
       <p:sp>
         <p:nvSpPr>
-          <p:cNvPr id="27" name="TextBox 26"/>
-          <p:cNvSpPr txBox="1"/>
-          <p:nvPr/>
-        </p:nvSpPr>
-        <p:spPr>
-          <a:xfrm>
-            <a:off x="777240" y="4828032"/>
-            <a:ext cx="457200" cy="384048"/>
-          </a:xfrm>
-          <a:prstGeom prst="rect">
-            <a:avLst/>
-          </a:prstGeom>
-          <a:noFill/>
-        </p:spPr>
-        <p:txBody>
-          <a:bodyPr wrap="square" anchor="t"/>
-          <a:lstStyle/>
-          <a:p>
-            <a:pPr algn="l"/>
-            <a:r>
-              <a:rPr sz="1600" b="1" i="0">
-                <a:solidFill>
-                  <a:srgbClr val="0A6B63"/>
+          <p:cNvPr id="27" name="Rounded Rectangle 26"/>
+          <p:cNvSpPr/>
+          <p:nvPr/>
+        </p:nvSpPr>
+        <p:spPr>
+          <a:xfrm>
+            <a:off x="713232" y="5020055"/>
+            <a:ext cx="512064" cy="365760"/>
+          </a:xfrm>
+          <a:prstGeom prst="roundRect">
+            <a:avLst>
+              <a:gd name="adj" fmla="val 25000"/>
+            </a:avLst>
+          </a:prstGeom>
+          <a:solidFill>
+            <a:srgbClr val="0A6B63"/>
+          </a:solidFill>
+          <a:ln>
+            <a:noFill/>
+          </a:ln>
+        </p:spPr>
+        <p:style>
+          <a:lnRef idx="1">
+            <a:schemeClr val="accent1"/>
+          </a:lnRef>
+          <a:fillRef idx="3">
+            <a:schemeClr val="accent1"/>
+          </a:fillRef>
+          <a:effectRef idx="2">
+            <a:schemeClr val="accent1"/>
+          </a:effectRef>
+          <a:fontRef idx="minor">
+            <a:schemeClr val="lt1"/>
+          </a:fontRef>
+        </p:style>
+        <p:txBody>
+          <a:bodyPr rtlCol="0" anchor="ctr" wrap="square"/>
+          <a:lstStyle/>
+          <a:p>
+            <a:pPr algn="ctr"/>
+            <a:r>
+              <a:rPr sz="1300" b="1" i="0">
+                <a:solidFill>
+                  <a:srgbClr val="FFFFFF"/>
                 </a:solidFill>
                 <a:latin typeface="Georgia"/>
                 <a:ea typeface="Georgia"/>
@@ -37652,21 +37778,21 @@
         </p:nvSpPr>
         <p:spPr>
           <a:xfrm>
-            <a:off x="1325880" y="4828032"/>
-            <a:ext cx="5852160" cy="384048"/>
-          </a:xfrm>
-          <a:prstGeom prst="rect">
-            <a:avLst/>
-          </a:prstGeom>
-          <a:noFill/>
-        </p:spPr>
-        <p:txBody>
-          <a:bodyPr wrap="square" anchor="t"/>
-          <a:lstStyle/>
-          <a:p>
-            <a:pPr algn="l"/>
-            <a:r>
-              <a:rPr sz="1700" b="1" i="0">
+            <a:off x="1371600" y="4864607"/>
+            <a:ext cx="5852160" cy="676656"/>
+          </a:xfrm>
+          <a:prstGeom prst="rect">
+            <a:avLst/>
+          </a:prstGeom>
+          <a:noFill/>
+        </p:spPr>
+        <p:txBody>
+          <a:bodyPr wrap="square" anchor="ctr"/>
+          <a:lstStyle/>
+          <a:p>
+            <a:pPr algn="l"/>
+            <a:r>
+              <a:rPr sz="1600" b="1" i="0">
                 <a:solidFill>
                   <a:srgbClr val="0B1F33"/>
                 </a:solidFill>
@@ -37687,8 +37813,8 @@
         </p:nvSpPr>
         <p:spPr>
           <a:xfrm>
-            <a:off x="502920" y="5394960"/>
-            <a:ext cx="6949440" cy="658368"/>
+            <a:off x="502920" y="5614416"/>
+            <a:ext cx="6903720" cy="676656"/>
           </a:xfrm>
           <a:prstGeom prst="roundRect">
             <a:avLst>
@@ -37732,8 +37858,8 @@
         </p:nvSpPr>
         <p:spPr>
           <a:xfrm>
-            <a:off x="502920" y="5394960"/>
-            <a:ext cx="73152" cy="658368"/>
+            <a:off x="502920" y="5614416"/>
+            <a:ext cx="73152" cy="676656"/>
           </a:xfrm>
           <a:prstGeom prst="rect">
             <a:avLst/>
@@ -37769,29 +37895,50 @@
       </p:sp>
       <p:sp>
         <p:nvSpPr>
-          <p:cNvPr id="31" name="TextBox 30"/>
-          <p:cNvSpPr txBox="1"/>
-          <p:nvPr/>
-        </p:nvSpPr>
-        <p:spPr>
-          <a:xfrm>
-            <a:off x="777240" y="5541264"/>
-            <a:ext cx="457200" cy="384048"/>
-          </a:xfrm>
-          <a:prstGeom prst="rect">
-            <a:avLst/>
-          </a:prstGeom>
-          <a:noFill/>
-        </p:spPr>
-        <p:txBody>
-          <a:bodyPr wrap="square" anchor="t"/>
-          <a:lstStyle/>
-          <a:p>
-            <a:pPr algn="l"/>
-            <a:r>
-              <a:rPr sz="1600" b="1" i="0">
-                <a:solidFill>
-                  <a:srgbClr val="0A6B63"/>
+          <p:cNvPr id="31" name="Rounded Rectangle 30"/>
+          <p:cNvSpPr/>
+          <p:nvPr/>
+        </p:nvSpPr>
+        <p:spPr>
+          <a:xfrm>
+            <a:off x="713232" y="5769864"/>
+            <a:ext cx="512064" cy="365760"/>
+          </a:xfrm>
+          <a:prstGeom prst="roundRect">
+            <a:avLst>
+              <a:gd name="adj" fmla="val 25000"/>
+            </a:avLst>
+          </a:prstGeom>
+          <a:solidFill>
+            <a:srgbClr val="0A6B63"/>
+          </a:solidFill>
+          <a:ln>
+            <a:noFill/>
+          </a:ln>
+        </p:spPr>
+        <p:style>
+          <a:lnRef idx="1">
+            <a:schemeClr val="accent1"/>
+          </a:lnRef>
+          <a:fillRef idx="3">
+            <a:schemeClr val="accent1"/>
+          </a:fillRef>
+          <a:effectRef idx="2">
+            <a:schemeClr val="accent1"/>
+          </a:effectRef>
+          <a:fontRef idx="minor">
+            <a:schemeClr val="lt1"/>
+          </a:fontRef>
+        </p:style>
+        <p:txBody>
+          <a:bodyPr rtlCol="0" anchor="ctr" wrap="square"/>
+          <a:lstStyle/>
+          <a:p>
+            <a:pPr algn="ctr"/>
+            <a:r>
+              <a:rPr sz="1300" b="1" i="0">
+                <a:solidFill>
+                  <a:srgbClr val="FFFFFF"/>
                 </a:solidFill>
                 <a:latin typeface="Georgia"/>
                 <a:ea typeface="Georgia"/>
@@ -37810,21 +37957,21 @@
         </p:nvSpPr>
         <p:spPr>
           <a:xfrm>
-            <a:off x="1325880" y="5541264"/>
-            <a:ext cx="5852160" cy="384048"/>
-          </a:xfrm>
-          <a:prstGeom prst="rect">
-            <a:avLst/>
-          </a:prstGeom>
-          <a:noFill/>
-        </p:spPr>
-        <p:txBody>
-          <a:bodyPr wrap="square" anchor="t"/>
-          <a:lstStyle/>
-          <a:p>
-            <a:pPr algn="l"/>
-            <a:r>
-              <a:rPr sz="1700" b="1" i="0">
+            <a:off x="1371600" y="5614416"/>
+            <a:ext cx="5852160" cy="676656"/>
+          </a:xfrm>
+          <a:prstGeom prst="rect">
+            <a:avLst/>
+          </a:prstGeom>
+          <a:noFill/>
+        </p:spPr>
+        <p:txBody>
+          <a:bodyPr wrap="square" anchor="ctr"/>
+          <a:lstStyle/>
+          <a:p>
+            <a:pPr algn="l"/>
+            <a:r>
+              <a:rPr sz="1600" b="1" i="0">
                 <a:solidFill>
                   <a:srgbClr val="0B1F33"/>
                 </a:solidFill>

</xml_diff>

<commit_message>
Use Rocky Chen contact from the Helio Space products deck
Replace the 51 Careers close-slide contact with rocky@helio.space
and 19921169641 from Heliospace_Company_And_Product_Overview.

Co-authored-by: anthonyleedu <anthonyleedu@users.noreply.github.com>
</commit_message>
<xml_diff>
--- a/51Careers_Addition.pptx
+++ b/51Careers_Addition.pptx
@@ -33477,7 +33477,7 @@
         <p:spPr>
           <a:xfrm>
             <a:off x="1024128" y="3703320"/>
-            <a:ext cx="3072384" cy="822960"/>
+            <a:ext cx="3072384" cy="868680"/>
           </a:xfrm>
           <a:prstGeom prst="rect">
             <a:avLst/>
@@ -33498,7 +33498,7 @@
                 <a:ea typeface="Georgia"/>
                 <a:cs typeface="Georgia"/>
               </a:rPr>
-              <a:t>info@51careers.com</a:t>
+              <a:t>rocky@helio.space</a:t>
             </a:r>
           </a:p>
         </p:txBody>
@@ -33621,7 +33621,7 @@
                 <a:ea typeface="Segoe UI"/>
                 <a:cs typeface="Segoe UI"/>
               </a:rPr>
-              <a:t>WEB</a:t>
+              <a:t>PHONE</a:t>
             </a:r>
           </a:p>
         </p:txBody>
@@ -33635,7 +33635,7 @@
         <p:spPr>
           <a:xfrm>
             <a:off x="4681728" y="3703320"/>
-            <a:ext cx="3072384" cy="822960"/>
+            <a:ext cx="3072384" cy="868680"/>
           </a:xfrm>
           <a:prstGeom prst="rect">
             <a:avLst/>
@@ -33656,7 +33656,7 @@
                 <a:ea typeface="Georgia"/>
                 <a:cs typeface="Georgia"/>
               </a:rPr>
-              <a:t>www.51careers.ai</a:t>
+              <a:t>19921169641</a:t>
             </a:r>
           </a:p>
         </p:txBody>
@@ -33779,7 +33779,7 @@
                 <a:ea typeface="Segoe UI"/>
                 <a:cs typeface="Segoe UI"/>
               </a:rPr>
-              <a:t>OFFICE</a:t>
+              <a:t>WEB</a:t>
             </a:r>
           </a:p>
         </p:txBody>
@@ -33793,7 +33793,7 @@
         <p:spPr>
           <a:xfrm>
             <a:off x="8339328" y="3703320"/>
-            <a:ext cx="3072384" cy="822960"/>
+            <a:ext cx="3072384" cy="868680"/>
           </a:xfrm>
           <a:prstGeom prst="rect">
             <a:avLst/>
@@ -33814,7 +33814,7 @@
                 <a:ea typeface="Georgia"/>
                 <a:cs typeface="Georgia"/>
               </a:rPr>
-              <a:t>48 Wall Street, 11th Floor</a:t>
+              <a:t>www.helio.space</a:t>
             </a:r>
           </a:p>
         </p:txBody>
@@ -33841,7 +33841,7 @@
           <a:p>
             <a:pPr algn="l"/>
             <a:r>
-              <a:rPr sz="1600" b="0" i="0">
+              <a:rPr sz="1400" b="0" i="0">
                 <a:solidFill>
                   <a:srgbClr val="D7EBE8"/>
                 </a:solidFill>
@@ -33849,7 +33849,7 @@
                 <a:ea typeface="Segoe UI"/>
                 <a:cs typeface="Segoe UI"/>
               </a:rPr>
-              <a:t>New York, NY 10005</a:t>
+              <a:t>info@helio.space   ·   (510) 545-2666   ·   2448 Sixth Street, Berkeley, CA 94710</a:t>
             </a:r>
           </a:p>
         </p:txBody>
@@ -33927,7 +33927,7 @@
                 <a:ea typeface="Segoe UI"/>
                 <a:cs typeface="Segoe UI"/>
               </a:rPr>
-              <a:t>51 CAREERS.AI   ·   ROCKY CHEN   ·   INFO@51CAREERS.COM</a:t>
+              <a:t>ROCKY CHEN   ·   ROCKY@HELIO.SPACE   ·   19921169641</a:t>
             </a:r>
           </a:p>
         </p:txBody>

</xml_diff>

<commit_message>
Add leadership biographies for all six executives
Each Leadership Team card now shows name, title, and two description
bullets covering background, credentials, and current role.

Co-authored-by: anthonyleedu <anthonyleedu@users.noreply.github.com>
</commit_message>
<xml_diff>
--- a/51Careers_Addition.pptx
+++ b/51Careers_Addition.pptx
@@ -18866,7 +18866,7 @@
                 <a:ea typeface="Segoe UI"/>
                 <a:cs typeface="Segoe UI"/>
               </a:rPr>
-              <a:t>Founder-led. Globally distributed. Full biographies available in the data room.</a:t>
+              <a:t>Founder-led. Globally distributed.</a:t>
             </a:r>
           </a:p>
         </p:txBody>
@@ -18967,21 +18967,21 @@
         </p:nvSpPr>
         <p:spPr>
           <a:xfrm>
-            <a:off x="704088" y="1280160"/>
-            <a:ext cx="3200400" cy="365760"/>
-          </a:xfrm>
-          <a:prstGeom prst="rect">
-            <a:avLst/>
-          </a:prstGeom>
-          <a:noFill/>
-        </p:spPr>
-        <p:txBody>
-          <a:bodyPr wrap="square" anchor="t"/>
-          <a:lstStyle/>
-          <a:p>
-            <a:pPr algn="l"/>
-            <a:r>
-              <a:rPr sz="1800" b="1" i="0">
+            <a:off x="704088" y="1225296"/>
+            <a:ext cx="3200400" cy="310896"/>
+          </a:xfrm>
+          <a:prstGeom prst="rect">
+            <a:avLst/>
+          </a:prstGeom>
+          <a:noFill/>
+        </p:spPr>
+        <p:txBody>
+          <a:bodyPr wrap="square" anchor="t"/>
+          <a:lstStyle/>
+          <a:p>
+            <a:pPr algn="l"/>
+            <a:r>
+              <a:rPr sz="1600" b="1" i="0">
                 <a:solidFill>
                   <a:srgbClr val="0B1F33"/>
                 </a:solidFill>
@@ -19002,21 +19002,21 @@
         </p:nvSpPr>
         <p:spPr>
           <a:xfrm>
-            <a:off x="704088" y="1645920"/>
-            <a:ext cx="3200400" cy="274320"/>
-          </a:xfrm>
-          <a:prstGeom prst="rect">
-            <a:avLst/>
-          </a:prstGeom>
-          <a:noFill/>
-        </p:spPr>
-        <p:txBody>
-          <a:bodyPr wrap="square" anchor="t"/>
-          <a:lstStyle/>
-          <a:p>
-            <a:pPr algn="l"/>
-            <a:r>
-              <a:rPr sz="1200" b="1" i="0">
+            <a:off x="704088" y="1536192"/>
+            <a:ext cx="3200400" cy="237744"/>
+          </a:xfrm>
+          <a:prstGeom prst="rect">
+            <a:avLst/>
+          </a:prstGeom>
+          <a:noFill/>
+        </p:spPr>
+        <p:txBody>
+          <a:bodyPr wrap="square" anchor="t"/>
+          <a:lstStyle/>
+          <a:p>
+            <a:pPr algn="l"/>
+            <a:r>
+              <a:rPr sz="1100" b="1" i="0">
                 <a:solidFill>
                   <a:srgbClr val="0A6B63"/>
                 </a:solidFill>
@@ -19037,21 +19037,21 @@
         </p:nvSpPr>
         <p:spPr>
           <a:xfrm>
-            <a:off x="704088" y="1993392"/>
-            <a:ext cx="3200400" cy="1371600"/>
-          </a:xfrm>
-          <a:prstGeom prst="rect">
-            <a:avLst/>
-          </a:prstGeom>
-          <a:noFill/>
-        </p:spPr>
-        <p:txBody>
-          <a:bodyPr wrap="square" anchor="t"/>
-          <a:lstStyle/>
-          <a:p>
-            <a:pPr algn="l"/>
-            <a:r>
-              <a:rPr sz="1300" b="0" i="0">
+            <a:off x="704088" y="1828800"/>
+            <a:ext cx="3200400" cy="804672"/>
+          </a:xfrm>
+          <a:prstGeom prst="rect">
+            <a:avLst/>
+          </a:prstGeom>
+          <a:noFill/>
+        </p:spPr>
+        <p:txBody>
+          <a:bodyPr wrap="square" anchor="t"/>
+          <a:lstStyle/>
+          <a:p>
+            <a:pPr algn="l"/>
+            <a:r>
+              <a:rPr sz="1200" b="0" i="0">
                 <a:solidFill>
                   <a:srgbClr val="2C3A4B"/>
                 </a:solidFill>
@@ -19059,14 +19059,49 @@
                 <a:ea typeface="Segoe UI"/>
                 <a:cs typeface="Segoe UI"/>
               </a:rPr>
-              <a:t>Founder of 51 Careers and 51 Careers.AI; investor and Managing Director at publicly listed Helio. Decade of international business, capital markets, and global resource integration.</a:t>
-            </a:r>
-          </a:p>
-        </p:txBody>
-      </p:sp>
-      <p:sp>
-        <p:nvSpPr>
-          <p:cNvPr id="10" name="Rounded Rectangle 9"/>
+              <a:t>▸  Founded 51 Careers in New York in 2016 and built it from a boutique consultancy into a multi-market career-services and technology business.</a:t>
+            </a:r>
+          </a:p>
+        </p:txBody>
+      </p:sp>
+      <p:sp>
+        <p:nvSpPr>
+          <p:cNvPr id="10" name="TextBox 9"/>
+          <p:cNvSpPr txBox="1"/>
+          <p:nvPr/>
+        </p:nvSpPr>
+        <p:spPr>
+          <a:xfrm>
+            <a:off x="704088" y="2651760"/>
+            <a:ext cx="3200400" cy="804672"/>
+          </a:xfrm>
+          <a:prstGeom prst="rect">
+            <a:avLst/>
+          </a:prstGeom>
+          <a:noFill/>
+        </p:spPr>
+        <p:txBody>
+          <a:bodyPr wrap="square" anchor="t"/>
+          <a:lstStyle/>
+          <a:p>
+            <a:pPr algn="l"/>
+            <a:r>
+              <a:rPr sz="1200" b="0" i="0">
+                <a:solidFill>
+                  <a:srgbClr val="2C3A4B"/>
+                </a:solidFill>
+                <a:latin typeface="Segoe UI"/>
+                <a:ea typeface="Segoe UI"/>
+                <a:cs typeface="Segoe UI"/>
+              </a:rPr>
+              <a:t>▸  Founder of 51 Careers.AI; investor and Managing Director at publicly listed Helio. Architect of the AI-first strategy, including the 2025 Alibaba Cloud AI partnership.</a:t>
+            </a:r>
+          </a:p>
+        </p:txBody>
+      </p:sp>
+      <p:sp>
+        <p:nvSpPr>
+          <p:cNvPr id="11" name="Rounded Rectangle 10"/>
           <p:cNvSpPr/>
           <p:nvPr/>
         </p:nvSpPr>
@@ -19111,7 +19146,7 @@
       </p:sp>
       <p:sp>
         <p:nvSpPr>
-          <p:cNvPr id="11" name="Rectangle 10"/>
+          <p:cNvPr id="12" name="Rectangle 11"/>
           <p:cNvSpPr/>
           <p:nvPr/>
         </p:nvSpPr>
@@ -19154,27 +19189,27 @@
       </p:sp>
       <p:sp>
         <p:nvSpPr>
-          <p:cNvPr id="12" name="TextBox 11"/>
-          <p:cNvSpPr txBox="1"/>
-          <p:nvPr/>
-        </p:nvSpPr>
-        <p:spPr>
-          <a:xfrm>
-            <a:off x="4434840" y="1280160"/>
-            <a:ext cx="3200400" cy="365760"/>
-          </a:xfrm>
-          <a:prstGeom prst="rect">
-            <a:avLst/>
-          </a:prstGeom>
-          <a:noFill/>
-        </p:spPr>
-        <p:txBody>
-          <a:bodyPr wrap="square" anchor="t"/>
-          <a:lstStyle/>
-          <a:p>
-            <a:pPr algn="l"/>
-            <a:r>
-              <a:rPr sz="1800" b="1" i="0">
+          <p:cNvPr id="13" name="TextBox 12"/>
+          <p:cNvSpPr txBox="1"/>
+          <p:nvPr/>
+        </p:nvSpPr>
+        <p:spPr>
+          <a:xfrm>
+            <a:off x="4434840" y="1225296"/>
+            <a:ext cx="3200400" cy="310896"/>
+          </a:xfrm>
+          <a:prstGeom prst="rect">
+            <a:avLst/>
+          </a:prstGeom>
+          <a:noFill/>
+        </p:spPr>
+        <p:txBody>
+          <a:bodyPr wrap="square" anchor="t"/>
+          <a:lstStyle/>
+          <a:p>
+            <a:pPr algn="l"/>
+            <a:r>
+              <a:rPr sz="1600" b="1" i="0">
                 <a:solidFill>
                   <a:srgbClr val="0B1F33"/>
                 </a:solidFill>
@@ -19189,27 +19224,27 @@
       </p:sp>
       <p:sp>
         <p:nvSpPr>
-          <p:cNvPr id="13" name="TextBox 12"/>
-          <p:cNvSpPr txBox="1"/>
-          <p:nvPr/>
-        </p:nvSpPr>
-        <p:spPr>
-          <a:xfrm>
-            <a:off x="4434840" y="1645920"/>
-            <a:ext cx="3200400" cy="274320"/>
-          </a:xfrm>
-          <a:prstGeom prst="rect">
-            <a:avLst/>
-          </a:prstGeom>
-          <a:noFill/>
-        </p:spPr>
-        <p:txBody>
-          <a:bodyPr wrap="square" anchor="t"/>
-          <a:lstStyle/>
-          <a:p>
-            <a:pPr algn="l"/>
-            <a:r>
-              <a:rPr sz="1200" b="1" i="0">
+          <p:cNvPr id="14" name="TextBox 13"/>
+          <p:cNvSpPr txBox="1"/>
+          <p:nvPr/>
+        </p:nvSpPr>
+        <p:spPr>
+          <a:xfrm>
+            <a:off x="4434840" y="1536192"/>
+            <a:ext cx="3200400" cy="237744"/>
+          </a:xfrm>
+          <a:prstGeom prst="rect">
+            <a:avLst/>
+          </a:prstGeom>
+          <a:noFill/>
+        </p:spPr>
+        <p:txBody>
+          <a:bodyPr wrap="square" anchor="t"/>
+          <a:lstStyle/>
+          <a:p>
+            <a:pPr algn="l"/>
+            <a:r>
+              <a:rPr sz="1100" b="1" i="0">
                 <a:solidFill>
                   <a:srgbClr val="0A6B63"/>
                 </a:solidFill>
@@ -19224,27 +19259,27 @@
       </p:sp>
       <p:sp>
         <p:nvSpPr>
-          <p:cNvPr id="14" name="TextBox 13"/>
-          <p:cNvSpPr txBox="1"/>
-          <p:nvPr/>
-        </p:nvSpPr>
-        <p:spPr>
-          <a:xfrm>
-            <a:off x="4434840" y="1993392"/>
-            <a:ext cx="3200400" cy="1371600"/>
-          </a:xfrm>
-          <a:prstGeom prst="rect">
-            <a:avLst/>
-          </a:prstGeom>
-          <a:noFill/>
-        </p:spPr>
-        <p:txBody>
-          <a:bodyPr wrap="square" anchor="t"/>
-          <a:lstStyle/>
-          <a:p>
-            <a:pPr algn="l"/>
-            <a:r>
-              <a:rPr sz="1300" b="0" i="0">
+          <p:cNvPr id="15" name="TextBox 14"/>
+          <p:cNvSpPr txBox="1"/>
+          <p:nvPr/>
+        </p:nvSpPr>
+        <p:spPr>
+          <a:xfrm>
+            <a:off x="4434840" y="1828800"/>
+            <a:ext cx="3200400" cy="804672"/>
+          </a:xfrm>
+          <a:prstGeom prst="rect">
+            <a:avLst/>
+          </a:prstGeom>
+          <a:noFill/>
+        </p:spPr>
+        <p:txBody>
+          <a:bodyPr wrap="square" anchor="t"/>
+          <a:lstStyle/>
+          <a:p>
+            <a:pPr algn="l"/>
+            <a:r>
+              <a:rPr sz="1200" b="0" i="0">
                 <a:solidFill>
                   <a:srgbClr val="2C3A4B"/>
                 </a:solidFill>
@@ -19252,14 +19287,49 @@
                 <a:ea typeface="Segoe UI"/>
                 <a:cs typeface="Segoe UI"/>
               </a:rPr>
-              <a:t>Co-founder since 2016. U.S. CPA; M.S. Accounting, Pace University. Oversees financial strategy, corporate governance, and sustainable growth.</a:t>
-            </a:r>
-          </a:p>
-        </p:txBody>
-      </p:sp>
-      <p:sp>
-        <p:nvSpPr>
-          <p:cNvPr id="15" name="Rounded Rectangle 14"/>
+              <a:t>▸  Co-founder since 2016. U.S. CPA; M.S. Accounting, Pace University.</a:t>
+            </a:r>
+          </a:p>
+        </p:txBody>
+      </p:sp>
+      <p:sp>
+        <p:nvSpPr>
+          <p:cNvPr id="16" name="TextBox 15"/>
+          <p:cNvSpPr txBox="1"/>
+          <p:nvPr/>
+        </p:nvSpPr>
+        <p:spPr>
+          <a:xfrm>
+            <a:off x="4434840" y="2651760"/>
+            <a:ext cx="3200400" cy="804672"/>
+          </a:xfrm>
+          <a:prstGeom prst="rect">
+            <a:avLst/>
+          </a:prstGeom>
+          <a:noFill/>
+        </p:spPr>
+        <p:txBody>
+          <a:bodyPr wrap="square" anchor="t"/>
+          <a:lstStyle/>
+          <a:p>
+            <a:pPr algn="l"/>
+            <a:r>
+              <a:rPr sz="1200" b="0" i="0">
+                <a:solidFill>
+                  <a:srgbClr val="2C3A4B"/>
+                </a:solidFill>
+                <a:latin typeface="Segoe UI"/>
+                <a:ea typeface="Segoe UI"/>
+                <a:cs typeface="Segoe UI"/>
+              </a:rPr>
+              <a:t>▸  Oversees financial strategy, corporate governance, and sustainable growth for 51 Careers and 51 Careers.AI.</a:t>
+            </a:r>
+          </a:p>
+        </p:txBody>
+      </p:sp>
+      <p:sp>
+        <p:nvSpPr>
+          <p:cNvPr id="17" name="Rounded Rectangle 16"/>
           <p:cNvSpPr/>
           <p:nvPr/>
         </p:nvSpPr>
@@ -19304,7 +19374,7 @@
       </p:sp>
       <p:sp>
         <p:nvSpPr>
-          <p:cNvPr id="16" name="Rectangle 15"/>
+          <p:cNvPr id="18" name="Rectangle 17"/>
           <p:cNvSpPr/>
           <p:nvPr/>
         </p:nvSpPr>
@@ -19347,27 +19417,27 @@
       </p:sp>
       <p:sp>
         <p:nvSpPr>
-          <p:cNvPr id="17" name="TextBox 16"/>
-          <p:cNvSpPr txBox="1"/>
-          <p:nvPr/>
-        </p:nvSpPr>
-        <p:spPr>
-          <a:xfrm>
-            <a:off x="8165592" y="1280160"/>
-            <a:ext cx="3200400" cy="365760"/>
-          </a:xfrm>
-          <a:prstGeom prst="rect">
-            <a:avLst/>
-          </a:prstGeom>
-          <a:noFill/>
-        </p:spPr>
-        <p:txBody>
-          <a:bodyPr wrap="square" anchor="t"/>
-          <a:lstStyle/>
-          <a:p>
-            <a:pPr algn="l"/>
-            <a:r>
-              <a:rPr sz="1800" b="1" i="0">
+          <p:cNvPr id="19" name="TextBox 18"/>
+          <p:cNvSpPr txBox="1"/>
+          <p:nvPr/>
+        </p:nvSpPr>
+        <p:spPr>
+          <a:xfrm>
+            <a:off x="8165592" y="1225296"/>
+            <a:ext cx="3200400" cy="310896"/>
+          </a:xfrm>
+          <a:prstGeom prst="rect">
+            <a:avLst/>
+          </a:prstGeom>
+          <a:noFill/>
+        </p:spPr>
+        <p:txBody>
+          <a:bodyPr wrap="square" anchor="t"/>
+          <a:lstStyle/>
+          <a:p>
+            <a:pPr algn="l"/>
+            <a:r>
+              <a:rPr sz="1600" b="1" i="0">
                 <a:solidFill>
                   <a:srgbClr val="0B1F33"/>
                 </a:solidFill>
@@ -19382,27 +19452,27 @@
       </p:sp>
       <p:sp>
         <p:nvSpPr>
-          <p:cNvPr id="18" name="TextBox 17"/>
-          <p:cNvSpPr txBox="1"/>
-          <p:nvPr/>
-        </p:nvSpPr>
-        <p:spPr>
-          <a:xfrm>
-            <a:off x="8165592" y="1645920"/>
-            <a:ext cx="3200400" cy="274320"/>
-          </a:xfrm>
-          <a:prstGeom prst="rect">
-            <a:avLst/>
-          </a:prstGeom>
-          <a:noFill/>
-        </p:spPr>
-        <p:txBody>
-          <a:bodyPr wrap="square" anchor="t"/>
-          <a:lstStyle/>
-          <a:p>
-            <a:pPr algn="l"/>
-            <a:r>
-              <a:rPr sz="1200" b="1" i="0">
+          <p:cNvPr id="20" name="TextBox 19"/>
+          <p:cNvSpPr txBox="1"/>
+          <p:nvPr/>
+        </p:nvSpPr>
+        <p:spPr>
+          <a:xfrm>
+            <a:off x="8165592" y="1536192"/>
+            <a:ext cx="3200400" cy="237744"/>
+          </a:xfrm>
+          <a:prstGeom prst="rect">
+            <a:avLst/>
+          </a:prstGeom>
+          <a:noFill/>
+        </p:spPr>
+        <p:txBody>
+          <a:bodyPr wrap="square" anchor="t"/>
+          <a:lstStyle/>
+          <a:p>
+            <a:pPr algn="l"/>
+            <a:r>
+              <a:rPr sz="1100" b="1" i="0">
                 <a:solidFill>
                   <a:srgbClr val="0A6B63"/>
                 </a:solidFill>
@@ -19417,27 +19487,27 @@
       </p:sp>
       <p:sp>
         <p:nvSpPr>
-          <p:cNvPr id="19" name="TextBox 18"/>
-          <p:cNvSpPr txBox="1"/>
-          <p:nvPr/>
-        </p:nvSpPr>
-        <p:spPr>
-          <a:xfrm>
-            <a:off x="8165592" y="1993392"/>
-            <a:ext cx="3200400" cy="1371600"/>
-          </a:xfrm>
-          <a:prstGeom prst="rect">
-            <a:avLst/>
-          </a:prstGeom>
-          <a:noFill/>
-        </p:spPr>
-        <p:txBody>
-          <a:bodyPr wrap="square" anchor="t"/>
-          <a:lstStyle/>
-          <a:p>
-            <a:pPr algn="l"/>
-            <a:r>
-              <a:rPr sz="1300" b="0" i="0">
+          <p:cNvPr id="21" name="TextBox 20"/>
+          <p:cNvSpPr txBox="1"/>
+          <p:nvPr/>
+        </p:nvSpPr>
+        <p:spPr>
+          <a:xfrm>
+            <a:off x="8165592" y="1828800"/>
+            <a:ext cx="3200400" cy="804672"/>
+          </a:xfrm>
+          <a:prstGeom prst="rect">
+            <a:avLst/>
+          </a:prstGeom>
+          <a:noFill/>
+        </p:spPr>
+        <p:txBody>
+          <a:bodyPr wrap="square" anchor="t"/>
+          <a:lstStyle/>
+          <a:p>
+            <a:pPr algn="l"/>
+            <a:r>
+              <a:rPr sz="1200" b="0" i="0">
                 <a:solidFill>
                   <a:srgbClr val="2C3A4B"/>
                 </a:solidFill>
@@ -19445,14 +19515,49 @@
                 <a:ea typeface="Segoe UI"/>
                 <a:cs typeface="Segoe UI"/>
               </a:rPr>
-              <a:t>Serial entrepreneur (10+ years) across SaaS, AI, and digital business; B.S. Computer Science, ECUST. Leads technology, operations, and AI.</a:t>
-            </a:r>
-          </a:p>
-        </p:txBody>
-      </p:sp>
-      <p:sp>
-        <p:nvSpPr>
-          <p:cNvPr id="20" name="Rounded Rectangle 19"/>
+              <a:t>▸  Serial entrepreneur (10+ years) across SaaS, AI, and digital business; B.S. Computer Science, ECUST.</a:t>
+            </a:r>
+          </a:p>
+        </p:txBody>
+      </p:sp>
+      <p:sp>
+        <p:nvSpPr>
+          <p:cNvPr id="22" name="TextBox 21"/>
+          <p:cNvSpPr txBox="1"/>
+          <p:nvPr/>
+        </p:nvSpPr>
+        <p:spPr>
+          <a:xfrm>
+            <a:off x="8165592" y="2651760"/>
+            <a:ext cx="3200400" cy="804672"/>
+          </a:xfrm>
+          <a:prstGeom prst="rect">
+            <a:avLst/>
+          </a:prstGeom>
+          <a:noFill/>
+        </p:spPr>
+        <p:txBody>
+          <a:bodyPr wrap="square" anchor="t"/>
+          <a:lstStyle/>
+          <a:p>
+            <a:pPr algn="l"/>
+            <a:r>
+              <a:rPr sz="1200" b="0" i="0">
+                <a:solidFill>
+                  <a:srgbClr val="2C3A4B"/>
+                </a:solidFill>
+                <a:latin typeface="Segoe UI"/>
+                <a:ea typeface="Segoe UI"/>
+                <a:cs typeface="Segoe UI"/>
+              </a:rPr>
+              <a:t>▸  Prior CTO roles and multiple co-founded ventures. Leads technology, operations, and AI.</a:t>
+            </a:r>
+          </a:p>
+        </p:txBody>
+      </p:sp>
+      <p:sp>
+        <p:nvSpPr>
+          <p:cNvPr id="23" name="Rounded Rectangle 22"/>
           <p:cNvSpPr/>
           <p:nvPr/>
         </p:nvSpPr>
@@ -19497,7 +19602,7 @@
       </p:sp>
       <p:sp>
         <p:nvSpPr>
-          <p:cNvPr id="21" name="Rectangle 20"/>
+          <p:cNvPr id="24" name="Rectangle 23"/>
           <p:cNvSpPr/>
           <p:nvPr/>
         </p:nvSpPr>
@@ -19540,27 +19645,27 @@
       </p:sp>
       <p:sp>
         <p:nvSpPr>
-          <p:cNvPr id="22" name="TextBox 21"/>
-          <p:cNvSpPr txBox="1"/>
-          <p:nvPr/>
-        </p:nvSpPr>
-        <p:spPr>
-          <a:xfrm>
-            <a:off x="704088" y="3840480"/>
-            <a:ext cx="3200400" cy="365760"/>
-          </a:xfrm>
-          <a:prstGeom prst="rect">
-            <a:avLst/>
-          </a:prstGeom>
-          <a:noFill/>
-        </p:spPr>
-        <p:txBody>
-          <a:bodyPr wrap="square" anchor="t"/>
-          <a:lstStyle/>
-          <a:p>
-            <a:pPr algn="l"/>
-            <a:r>
-              <a:rPr sz="1800" b="1" i="0">
+          <p:cNvPr id="25" name="TextBox 24"/>
+          <p:cNvSpPr txBox="1"/>
+          <p:nvPr/>
+        </p:nvSpPr>
+        <p:spPr>
+          <a:xfrm>
+            <a:off x="704088" y="3785616"/>
+            <a:ext cx="3200400" cy="310896"/>
+          </a:xfrm>
+          <a:prstGeom prst="rect">
+            <a:avLst/>
+          </a:prstGeom>
+          <a:noFill/>
+        </p:spPr>
+        <p:txBody>
+          <a:bodyPr wrap="square" anchor="t"/>
+          <a:lstStyle/>
+          <a:p>
+            <a:pPr algn="l"/>
+            <a:r>
+              <a:rPr sz="1600" b="1" i="0">
                 <a:solidFill>
                   <a:srgbClr val="0B1F33"/>
                 </a:solidFill>
@@ -19575,27 +19680,27 @@
       </p:sp>
       <p:sp>
         <p:nvSpPr>
-          <p:cNvPr id="23" name="TextBox 22"/>
-          <p:cNvSpPr txBox="1"/>
-          <p:nvPr/>
-        </p:nvSpPr>
-        <p:spPr>
-          <a:xfrm>
-            <a:off x="704088" y="4206240"/>
-            <a:ext cx="3200400" cy="274320"/>
-          </a:xfrm>
-          <a:prstGeom prst="rect">
-            <a:avLst/>
-          </a:prstGeom>
-          <a:noFill/>
-        </p:spPr>
-        <p:txBody>
-          <a:bodyPr wrap="square" anchor="t"/>
-          <a:lstStyle/>
-          <a:p>
-            <a:pPr algn="l"/>
-            <a:r>
-              <a:rPr sz="1200" b="1" i="0">
+          <p:cNvPr id="26" name="TextBox 25"/>
+          <p:cNvSpPr txBox="1"/>
+          <p:nvPr/>
+        </p:nvSpPr>
+        <p:spPr>
+          <a:xfrm>
+            <a:off x="704088" y="4096512"/>
+            <a:ext cx="3200400" cy="237744"/>
+          </a:xfrm>
+          <a:prstGeom prst="rect">
+            <a:avLst/>
+          </a:prstGeom>
+          <a:noFill/>
+        </p:spPr>
+        <p:txBody>
+          <a:bodyPr wrap="square" anchor="t"/>
+          <a:lstStyle/>
+          <a:p>
+            <a:pPr algn="l"/>
+            <a:r>
+              <a:rPr sz="1100" b="1" i="0">
                 <a:solidFill>
                   <a:srgbClr val="0A6B63"/>
                 </a:solidFill>
@@ -19610,27 +19715,27 @@
       </p:sp>
       <p:sp>
         <p:nvSpPr>
-          <p:cNvPr id="24" name="TextBox 23"/>
-          <p:cNvSpPr txBox="1"/>
-          <p:nvPr/>
-        </p:nvSpPr>
-        <p:spPr>
-          <a:xfrm>
-            <a:off x="704088" y="4553712"/>
-            <a:ext cx="3200400" cy="1371600"/>
-          </a:xfrm>
-          <a:prstGeom prst="rect">
-            <a:avLst/>
-          </a:prstGeom>
-          <a:noFill/>
-        </p:spPr>
-        <p:txBody>
-          <a:bodyPr wrap="square" anchor="t"/>
-          <a:lstStyle/>
-          <a:p>
-            <a:pPr algn="l"/>
-            <a:r>
-              <a:rPr sz="1300" b="0" i="0">
+          <p:cNvPr id="27" name="TextBox 26"/>
+          <p:cNvSpPr txBox="1"/>
+          <p:nvPr/>
+        </p:nvSpPr>
+        <p:spPr>
+          <a:xfrm>
+            <a:off x="704088" y="4389120"/>
+            <a:ext cx="3200400" cy="804672"/>
+          </a:xfrm>
+          <a:prstGeom prst="rect">
+            <a:avLst/>
+          </a:prstGeom>
+          <a:noFill/>
+        </p:spPr>
+        <p:txBody>
+          <a:bodyPr wrap="square" anchor="t"/>
+          <a:lstStyle/>
+          <a:p>
+            <a:pPr algn="l"/>
+            <a:r>
+              <a:rPr sz="1200" b="0" i="0">
                 <a:solidFill>
                   <a:srgbClr val="2C3A4B"/>
                 </a:solidFill>
@@ -19638,14 +19743,49 @@
                 <a:ea typeface="Segoe UI"/>
                 <a:cs typeface="Segoe UI"/>
               </a:rPr>
-              <a:t>Leads product strategy, architecture, and development of the AI-powered platform. Former CTO &amp; Director of Product, Ci Finance; senior roles at CPIC, Allinpay, and Noah.</a:t>
-            </a:r>
-          </a:p>
-        </p:txBody>
-      </p:sp>
-      <p:sp>
-        <p:nvSpPr>
-          <p:cNvPr id="25" name="Rounded Rectangle 24"/>
+              <a:t>▸  Leads product strategy, architecture, and development of the AI-powered career platform.</a:t>
+            </a:r>
+          </a:p>
+        </p:txBody>
+      </p:sp>
+      <p:sp>
+        <p:nvSpPr>
+          <p:cNvPr id="28" name="TextBox 27"/>
+          <p:cNvSpPr txBox="1"/>
+          <p:nvPr/>
+        </p:nvSpPr>
+        <p:spPr>
+          <a:xfrm>
+            <a:off x="704088" y="5212080"/>
+            <a:ext cx="3200400" cy="804672"/>
+          </a:xfrm>
+          <a:prstGeom prst="rect">
+            <a:avLst/>
+          </a:prstGeom>
+          <a:noFill/>
+        </p:spPr>
+        <p:txBody>
+          <a:bodyPr wrap="square" anchor="t"/>
+          <a:lstStyle/>
+          <a:p>
+            <a:pPr algn="l"/>
+            <a:r>
+              <a:rPr sz="1200" b="0" i="0">
+                <a:solidFill>
+                  <a:srgbClr val="2C3A4B"/>
+                </a:solidFill>
+                <a:latin typeface="Segoe UI"/>
+                <a:ea typeface="Segoe UI"/>
+                <a:cs typeface="Segoe UI"/>
+              </a:rPr>
+              <a:t>▸  Former CTO &amp; Director of Product at Ci Finance; senior product roles at CPIC, Allinpay, and Noah.</a:t>
+            </a:r>
+          </a:p>
+        </p:txBody>
+      </p:sp>
+      <p:sp>
+        <p:nvSpPr>
+          <p:cNvPr id="29" name="Rounded Rectangle 28"/>
           <p:cNvSpPr/>
           <p:nvPr/>
         </p:nvSpPr>
@@ -19690,7 +19830,7 @@
       </p:sp>
       <p:sp>
         <p:nvSpPr>
-          <p:cNvPr id="26" name="Rectangle 25"/>
+          <p:cNvPr id="30" name="Rectangle 29"/>
           <p:cNvSpPr/>
           <p:nvPr/>
         </p:nvSpPr>
@@ -19733,27 +19873,27 @@
       </p:sp>
       <p:sp>
         <p:nvSpPr>
-          <p:cNvPr id="27" name="TextBox 26"/>
-          <p:cNvSpPr txBox="1"/>
-          <p:nvPr/>
-        </p:nvSpPr>
-        <p:spPr>
-          <a:xfrm>
-            <a:off x="4434840" y="3840480"/>
-            <a:ext cx="3200400" cy="365760"/>
-          </a:xfrm>
-          <a:prstGeom prst="rect">
-            <a:avLst/>
-          </a:prstGeom>
-          <a:noFill/>
-        </p:spPr>
-        <p:txBody>
-          <a:bodyPr wrap="square" anchor="t"/>
-          <a:lstStyle/>
-          <a:p>
-            <a:pPr algn="l"/>
-            <a:r>
-              <a:rPr sz="1800" b="1" i="0">
+          <p:cNvPr id="31" name="TextBox 30"/>
+          <p:cNvSpPr txBox="1"/>
+          <p:nvPr/>
+        </p:nvSpPr>
+        <p:spPr>
+          <a:xfrm>
+            <a:off x="4434840" y="3785616"/>
+            <a:ext cx="3200400" cy="310896"/>
+          </a:xfrm>
+          <a:prstGeom prst="rect">
+            <a:avLst/>
+          </a:prstGeom>
+          <a:noFill/>
+        </p:spPr>
+        <p:txBody>
+          <a:bodyPr wrap="square" anchor="t"/>
+          <a:lstStyle/>
+          <a:p>
+            <a:pPr algn="l"/>
+            <a:r>
+              <a:rPr sz="1600" b="1" i="0">
                 <a:solidFill>
                   <a:srgbClr val="0B1F33"/>
                 </a:solidFill>
@@ -19768,27 +19908,27 @@
       </p:sp>
       <p:sp>
         <p:nvSpPr>
-          <p:cNvPr id="28" name="TextBox 27"/>
-          <p:cNvSpPr txBox="1"/>
-          <p:nvPr/>
-        </p:nvSpPr>
-        <p:spPr>
-          <a:xfrm>
-            <a:off x="4434840" y="4206240"/>
-            <a:ext cx="3200400" cy="274320"/>
-          </a:xfrm>
-          <a:prstGeom prst="rect">
-            <a:avLst/>
-          </a:prstGeom>
-          <a:noFill/>
-        </p:spPr>
-        <p:txBody>
-          <a:bodyPr wrap="square" anchor="t"/>
-          <a:lstStyle/>
-          <a:p>
-            <a:pPr algn="l"/>
-            <a:r>
-              <a:rPr sz="1200" b="1" i="0">
+          <p:cNvPr id="32" name="TextBox 31"/>
+          <p:cNvSpPr txBox="1"/>
+          <p:nvPr/>
+        </p:nvSpPr>
+        <p:spPr>
+          <a:xfrm>
+            <a:off x="4434840" y="4096512"/>
+            <a:ext cx="3200400" cy="237744"/>
+          </a:xfrm>
+          <a:prstGeom prst="rect">
+            <a:avLst/>
+          </a:prstGeom>
+          <a:noFill/>
+        </p:spPr>
+        <p:txBody>
+          <a:bodyPr wrap="square" anchor="t"/>
+          <a:lstStyle/>
+          <a:p>
+            <a:pPr algn="l"/>
+            <a:r>
+              <a:rPr sz="1100" b="1" i="0">
                 <a:solidFill>
                   <a:srgbClr val="0A6B63"/>
                 </a:solidFill>
@@ -19803,27 +19943,27 @@
       </p:sp>
       <p:sp>
         <p:nvSpPr>
-          <p:cNvPr id="29" name="TextBox 28"/>
-          <p:cNvSpPr txBox="1"/>
-          <p:nvPr/>
-        </p:nvSpPr>
-        <p:spPr>
-          <a:xfrm>
-            <a:off x="4434840" y="4553712"/>
-            <a:ext cx="3200400" cy="1371600"/>
-          </a:xfrm>
-          <a:prstGeom prst="rect">
-            <a:avLst/>
-          </a:prstGeom>
-          <a:noFill/>
-        </p:spPr>
-        <p:txBody>
-          <a:bodyPr wrap="square" anchor="t"/>
-          <a:lstStyle/>
-          <a:p>
-            <a:pPr algn="l"/>
-            <a:r>
-              <a:rPr sz="1300" b="0" i="0">
+          <p:cNvPr id="33" name="TextBox 32"/>
+          <p:cNvSpPr txBox="1"/>
+          <p:nvPr/>
+        </p:nvSpPr>
+        <p:spPr>
+          <a:xfrm>
+            <a:off x="4434840" y="4389120"/>
+            <a:ext cx="3200400" cy="804672"/>
+          </a:xfrm>
+          <a:prstGeom prst="rect">
+            <a:avLst/>
+          </a:prstGeom>
+          <a:noFill/>
+        </p:spPr>
+        <p:txBody>
+          <a:bodyPr wrap="square" anchor="t"/>
+          <a:lstStyle/>
+          <a:p>
+            <a:pPr algn="l"/>
+            <a:r>
+              <a:rPr sz="1200" b="0" i="0">
                 <a:solidFill>
                   <a:srgbClr val="2C3A4B"/>
                 </a:solidFill>
@@ -19831,14 +19971,49 @@
                 <a:ea typeface="Segoe UI"/>
                 <a:cs typeface="Segoe UI"/>
               </a:rPr>
-              <a:t>Full-stack engineer; previously at Amazon Web Services (AWS). B.S. Northwestern; M.S. Robotics. Extensive hiring-panel experience and mentorship.</a:t>
-            </a:r>
-          </a:p>
-        </p:txBody>
-      </p:sp>
-      <p:sp>
-        <p:nvSpPr>
-          <p:cNvPr id="30" name="Rounded Rectangle 29"/>
+              <a:t>▸  Full-stack engineer; previously at Amazon Web Services (AWS).</a:t>
+            </a:r>
+          </a:p>
+        </p:txBody>
+      </p:sp>
+      <p:sp>
+        <p:nvSpPr>
+          <p:cNvPr id="34" name="TextBox 33"/>
+          <p:cNvSpPr txBox="1"/>
+          <p:nvPr/>
+        </p:nvSpPr>
+        <p:spPr>
+          <a:xfrm>
+            <a:off x="4434840" y="5212080"/>
+            <a:ext cx="3200400" cy="804672"/>
+          </a:xfrm>
+          <a:prstGeom prst="rect">
+            <a:avLst/>
+          </a:prstGeom>
+          <a:noFill/>
+        </p:spPr>
+        <p:txBody>
+          <a:bodyPr wrap="square" anchor="t"/>
+          <a:lstStyle/>
+          <a:p>
+            <a:pPr algn="l"/>
+            <a:r>
+              <a:rPr sz="1200" b="0" i="0">
+                <a:solidFill>
+                  <a:srgbClr val="2C3A4B"/>
+                </a:solidFill>
+                <a:latin typeface="Segoe UI"/>
+                <a:ea typeface="Segoe UI"/>
+                <a:cs typeface="Segoe UI"/>
+              </a:rPr>
+              <a:t>▸  B.S. Northwestern; M.S. Robotics. Extensive hiring-panel experience and professional mentorship.</a:t>
+            </a:r>
+          </a:p>
+        </p:txBody>
+      </p:sp>
+      <p:sp>
+        <p:nvSpPr>
+          <p:cNvPr id="35" name="Rounded Rectangle 34"/>
           <p:cNvSpPr/>
           <p:nvPr/>
         </p:nvSpPr>
@@ -19883,7 +20058,7 @@
       </p:sp>
       <p:sp>
         <p:nvSpPr>
-          <p:cNvPr id="31" name="Rectangle 30"/>
+          <p:cNvPr id="36" name="Rectangle 35"/>
           <p:cNvSpPr/>
           <p:nvPr/>
         </p:nvSpPr>
@@ -19926,27 +20101,27 @@
       </p:sp>
       <p:sp>
         <p:nvSpPr>
-          <p:cNvPr id="32" name="TextBox 31"/>
-          <p:cNvSpPr txBox="1"/>
-          <p:nvPr/>
-        </p:nvSpPr>
-        <p:spPr>
-          <a:xfrm>
-            <a:off x="8165592" y="3840480"/>
-            <a:ext cx="3200400" cy="365760"/>
-          </a:xfrm>
-          <a:prstGeom prst="rect">
-            <a:avLst/>
-          </a:prstGeom>
-          <a:noFill/>
-        </p:spPr>
-        <p:txBody>
-          <a:bodyPr wrap="square" anchor="t"/>
-          <a:lstStyle/>
-          <a:p>
-            <a:pPr algn="l"/>
-            <a:r>
-              <a:rPr sz="1800" b="1" i="0">
+          <p:cNvPr id="37" name="TextBox 36"/>
+          <p:cNvSpPr txBox="1"/>
+          <p:nvPr/>
+        </p:nvSpPr>
+        <p:spPr>
+          <a:xfrm>
+            <a:off x="8165592" y="3785616"/>
+            <a:ext cx="3200400" cy="310896"/>
+          </a:xfrm>
+          <a:prstGeom prst="rect">
+            <a:avLst/>
+          </a:prstGeom>
+          <a:noFill/>
+        </p:spPr>
+        <p:txBody>
+          <a:bodyPr wrap="square" anchor="t"/>
+          <a:lstStyle/>
+          <a:p>
+            <a:pPr algn="l"/>
+            <a:r>
+              <a:rPr sz="1600" b="1" i="0">
                 <a:solidFill>
                   <a:srgbClr val="0B1F33"/>
                 </a:solidFill>
@@ -19961,27 +20136,27 @@
       </p:sp>
       <p:sp>
         <p:nvSpPr>
-          <p:cNvPr id="33" name="TextBox 32"/>
-          <p:cNvSpPr txBox="1"/>
-          <p:nvPr/>
-        </p:nvSpPr>
-        <p:spPr>
-          <a:xfrm>
-            <a:off x="8165592" y="4206240"/>
-            <a:ext cx="3200400" cy="274320"/>
-          </a:xfrm>
-          <a:prstGeom prst="rect">
-            <a:avLst/>
-          </a:prstGeom>
-          <a:noFill/>
-        </p:spPr>
-        <p:txBody>
-          <a:bodyPr wrap="square" anchor="t"/>
-          <a:lstStyle/>
-          <a:p>
-            <a:pPr algn="l"/>
-            <a:r>
-              <a:rPr sz="1200" b="1" i="0">
+          <p:cNvPr id="38" name="TextBox 37"/>
+          <p:cNvSpPr txBox="1"/>
+          <p:nvPr/>
+        </p:nvSpPr>
+        <p:spPr>
+          <a:xfrm>
+            <a:off x="8165592" y="4096512"/>
+            <a:ext cx="3200400" cy="237744"/>
+          </a:xfrm>
+          <a:prstGeom prst="rect">
+            <a:avLst/>
+          </a:prstGeom>
+          <a:noFill/>
+        </p:spPr>
+        <p:txBody>
+          <a:bodyPr wrap="square" anchor="t"/>
+          <a:lstStyle/>
+          <a:p>
+            <a:pPr algn="l"/>
+            <a:r>
+              <a:rPr sz="1100" b="1" i="0">
                 <a:solidFill>
                   <a:srgbClr val="0A6B63"/>
                 </a:solidFill>
@@ -19996,27 +20171,27 @@
       </p:sp>
       <p:sp>
         <p:nvSpPr>
-          <p:cNvPr id="34" name="TextBox 33"/>
-          <p:cNvSpPr txBox="1"/>
-          <p:nvPr/>
-        </p:nvSpPr>
-        <p:spPr>
-          <a:xfrm>
-            <a:off x="8165592" y="4553712"/>
-            <a:ext cx="3200400" cy="1371600"/>
-          </a:xfrm>
-          <a:prstGeom prst="rect">
-            <a:avLst/>
-          </a:prstGeom>
-          <a:noFill/>
-        </p:spPr>
-        <p:txBody>
-          <a:bodyPr wrap="square" anchor="t"/>
-          <a:lstStyle/>
-          <a:p>
-            <a:pPr algn="l"/>
-            <a:r>
-              <a:rPr sz="1300" b="0" i="0">
+          <p:cNvPr id="39" name="TextBox 38"/>
+          <p:cNvSpPr txBox="1"/>
+          <p:nvPr/>
+        </p:nvSpPr>
+        <p:spPr>
+          <a:xfrm>
+            <a:off x="8165592" y="4389120"/>
+            <a:ext cx="3200400" cy="804672"/>
+          </a:xfrm>
+          <a:prstGeom prst="rect">
+            <a:avLst/>
+          </a:prstGeom>
+          <a:noFill/>
+        </p:spPr>
+        <p:txBody>
+          <a:bodyPr wrap="square" anchor="t"/>
+          <a:lstStyle/>
+          <a:p>
+            <a:pPr algn="l"/>
+            <a:r>
+              <a:rPr sz="1200" b="0" i="0">
                 <a:solidFill>
                   <a:srgbClr val="2C3A4B"/>
                 </a:solidFill>
@@ -20024,14 +20199,49 @@
                 <a:ea typeface="Segoe UI"/>
                 <a:cs typeface="Segoe UI"/>
               </a:rPr>
-              <a:t>Harvard and MIT; former senior executive at Morgan Stanley; founder of Cedar. 40+ years in tech M&amp;A and capital raising; advises on growth and expansion.</a:t>
-            </a:r>
-          </a:p>
-        </p:txBody>
-      </p:sp>
-      <p:sp>
-        <p:nvSpPr>
-          <p:cNvPr id="35" name="Rectangle 34"/>
+              <a:t>▸  Harvard and MIT; former senior executive at Morgan Stanley; founder of Cedar.</a:t>
+            </a:r>
+          </a:p>
+        </p:txBody>
+      </p:sp>
+      <p:sp>
+        <p:nvSpPr>
+          <p:cNvPr id="40" name="TextBox 39"/>
+          <p:cNvSpPr txBox="1"/>
+          <p:nvPr/>
+        </p:nvSpPr>
+        <p:spPr>
+          <a:xfrm>
+            <a:off x="8165592" y="5212080"/>
+            <a:ext cx="3200400" cy="804672"/>
+          </a:xfrm>
+          <a:prstGeom prst="rect">
+            <a:avLst/>
+          </a:prstGeom>
+          <a:noFill/>
+        </p:spPr>
+        <p:txBody>
+          <a:bodyPr wrap="square" anchor="t"/>
+          <a:lstStyle/>
+          <a:p>
+            <a:pPr algn="l"/>
+            <a:r>
+              <a:rPr sz="1200" b="0" i="0">
+                <a:solidFill>
+                  <a:srgbClr val="2C3A4B"/>
+                </a:solidFill>
+                <a:latin typeface="Segoe UI"/>
+                <a:ea typeface="Segoe UI"/>
+                <a:cs typeface="Segoe UI"/>
+              </a:rPr>
+              <a:t>▸  40+ years in technology M&amp;A and capital raising. Advises 51 Careers on growth and expansion.</a:t>
+            </a:r>
+          </a:p>
+        </p:txBody>
+      </p:sp>
+      <p:sp>
+        <p:nvSpPr>
+          <p:cNvPr id="41" name="Rectangle 40"/>
           <p:cNvSpPr/>
           <p:nvPr/>
         </p:nvSpPr>
@@ -20074,7 +20284,7 @@
       </p:sp>
       <p:sp>
         <p:nvSpPr>
-          <p:cNvPr id="36" name="Rectangle 35"/>
+          <p:cNvPr id="42" name="Rectangle 41"/>
           <p:cNvSpPr/>
           <p:nvPr/>
         </p:nvSpPr>
@@ -20117,7 +20327,7 @@
       </p:sp>
       <p:sp>
         <p:nvSpPr>
-          <p:cNvPr id="37" name="Rectangle 36"/>
+          <p:cNvPr id="43" name="Rectangle 42"/>
           <p:cNvSpPr/>
           <p:nvPr/>
         </p:nvSpPr>
@@ -20160,7 +20370,7 @@
       </p:sp>
       <p:sp>
         <p:nvSpPr>
-          <p:cNvPr id="38" name="TextBox 37"/>
+          <p:cNvPr id="44" name="TextBox 43"/>
           <p:cNvSpPr txBox="1"/>
           <p:nvPr/>
         </p:nvSpPr>
@@ -20195,7 +20405,7 @@
       </p:sp>
       <p:sp>
         <p:nvSpPr>
-          <p:cNvPr id="39" name="TextBox 38"/>
+          <p:cNvPr id="45" name="TextBox 44"/>
           <p:cNvSpPr txBox="1"/>
           <p:nvPr/>
         </p:nvSpPr>

</xml_diff>